<commit_message>
release: record final acceptance and proposal evidence
</commit_message>
<xml_diff>
--- a/docs/submission/FinProof_Technical_Proposal.pptx
+++ b/docs/submission/FinProof_Technical_Proposal.pptx
@@ -2,27 +2,27 @@
 <file path=ppt/presentation.xml><?xml version="1.0" encoding="utf-8"?>
 <p:presentation xmlns:p="http://schemas.openxmlformats.org/presentationml/2006/main">
   <p:sldMasterIdLst>
-    <p:sldMasterId xmlns:r="http://schemas.openxmlformats.org/officeDocument/2006/relationships" id="2147483648" r:id="R787f46feec7c4015"/>
+    <p:sldMasterId xmlns:r="http://schemas.openxmlformats.org/officeDocument/2006/relationships" id="2147483648" r:id="R418e659f2ceb43d3"/>
   </p:sldMasterIdLst>
   <p:notesMasterIdLst>
-    <p:notesMasterId xmlns:r="http://schemas.openxmlformats.org/officeDocument/2006/relationships" r:id="Rb6b901ed391c46fe"/>
+    <p:notesMasterId xmlns:r="http://schemas.openxmlformats.org/officeDocument/2006/relationships" r:id="Re204b45d5974498e"/>
   </p:notesMasterIdLst>
   <p:sldIdLst>
-    <p:sldId xmlns:r="http://schemas.openxmlformats.org/officeDocument/2006/relationships" id="256" r:id="Re3c8f54523fc47ae"/>
-    <p:sldId xmlns:r="http://schemas.openxmlformats.org/officeDocument/2006/relationships" id="257" r:id="Rc09e47ceafe84680"/>
-    <p:sldId xmlns:r="http://schemas.openxmlformats.org/officeDocument/2006/relationships" id="258" r:id="R23f189d220994156"/>
-    <p:sldId xmlns:r="http://schemas.openxmlformats.org/officeDocument/2006/relationships" id="259" r:id="R0828b4dd700f4f78"/>
-    <p:sldId xmlns:r="http://schemas.openxmlformats.org/officeDocument/2006/relationships" id="260" r:id="R3dec482ba2ed4814"/>
-    <p:sldId xmlns:r="http://schemas.openxmlformats.org/officeDocument/2006/relationships" id="261" r:id="R00442e615e4d4faf"/>
-    <p:sldId xmlns:r="http://schemas.openxmlformats.org/officeDocument/2006/relationships" id="262" r:id="R855f206ee998425c"/>
-    <p:sldId xmlns:r="http://schemas.openxmlformats.org/officeDocument/2006/relationships" id="263" r:id="R139483cc1dd04508"/>
-    <p:sldId xmlns:r="http://schemas.openxmlformats.org/officeDocument/2006/relationships" id="264" r:id="R1edd6892c4db497a"/>
-    <p:sldId xmlns:r="http://schemas.openxmlformats.org/officeDocument/2006/relationships" id="265" r:id="R9358b6e2d52b41ec"/>
-    <p:sldId xmlns:r="http://schemas.openxmlformats.org/officeDocument/2006/relationships" id="266" r:id="Rc49faf1c59e64d46"/>
-    <p:sldId xmlns:r="http://schemas.openxmlformats.org/officeDocument/2006/relationships" id="267" r:id="Rd90dc58ccf0740ac"/>
-    <p:sldId xmlns:r="http://schemas.openxmlformats.org/officeDocument/2006/relationships" id="268" r:id="Rc214da55dd6c466a"/>
-    <p:sldId xmlns:r="http://schemas.openxmlformats.org/officeDocument/2006/relationships" id="269" r:id="R1b95887b91e04e53"/>
-    <p:sldId xmlns:r="http://schemas.openxmlformats.org/officeDocument/2006/relationships" id="270" r:id="R9835ed9fff3a4adf"/>
+    <p:sldId xmlns:r="http://schemas.openxmlformats.org/officeDocument/2006/relationships" id="256" r:id="R769b14fd90cb4100"/>
+    <p:sldId xmlns:r="http://schemas.openxmlformats.org/officeDocument/2006/relationships" id="257" r:id="R7e2d212d66b44d76"/>
+    <p:sldId xmlns:r="http://schemas.openxmlformats.org/officeDocument/2006/relationships" id="258" r:id="R7242e8ea907a4491"/>
+    <p:sldId xmlns:r="http://schemas.openxmlformats.org/officeDocument/2006/relationships" id="259" r:id="R420354bd57964ab5"/>
+    <p:sldId xmlns:r="http://schemas.openxmlformats.org/officeDocument/2006/relationships" id="260" r:id="R2fe0ec344e7843e5"/>
+    <p:sldId xmlns:r="http://schemas.openxmlformats.org/officeDocument/2006/relationships" id="261" r:id="R6b372244a2bd4df9"/>
+    <p:sldId xmlns:r="http://schemas.openxmlformats.org/officeDocument/2006/relationships" id="262" r:id="Rb6ae030e4988470a"/>
+    <p:sldId xmlns:r="http://schemas.openxmlformats.org/officeDocument/2006/relationships" id="263" r:id="R818fad78c1534302"/>
+    <p:sldId xmlns:r="http://schemas.openxmlformats.org/officeDocument/2006/relationships" id="264" r:id="R8535143449e84651"/>
+    <p:sldId xmlns:r="http://schemas.openxmlformats.org/officeDocument/2006/relationships" id="265" r:id="R744f3197bd254bc8"/>
+    <p:sldId xmlns:r="http://schemas.openxmlformats.org/officeDocument/2006/relationships" id="266" r:id="Rc20c09a4a3b94dae"/>
+    <p:sldId xmlns:r="http://schemas.openxmlformats.org/officeDocument/2006/relationships" id="267" r:id="Raf1eec31d6014c8f"/>
+    <p:sldId xmlns:r="http://schemas.openxmlformats.org/officeDocument/2006/relationships" id="268" r:id="R1c8b137d8ea54f49"/>
+    <p:sldId xmlns:r="http://schemas.openxmlformats.org/officeDocument/2006/relationships" id="269" r:id="R6f93871569334d75"/>
+    <p:sldId xmlns:r="http://schemas.openxmlformats.org/officeDocument/2006/relationships" id="270" r:id="R9f94d0962ae3494d"/>
   </p:sldIdLst>
   <p:sldSz cx="12192000" cy="6858000"/>
   <p:notesSz cx="6858000" cy="9144000"/>
@@ -1504,7 +1504,7 @@
   </p:cSld>
   <p:clrMap bg1="lt1" tx1="dk1" bg2="lt2" tx2="dk2" accent1="accent1" accent2="accent2" accent3="accent3" accent4="accent4" accent5="accent5" accent6="accent6" hlink="hlink" folHlink="folHlink"/>
   <p:sldLayoutIdLst>
-    <p:sldLayoutId xmlns:r="http://schemas.openxmlformats.org/officeDocument/2006/relationships" id="2147483649" r:id="Reb162560cfcf449d"/>
+    <p:sldLayoutId xmlns:r="http://schemas.openxmlformats.org/officeDocument/2006/relationships" id="2147483649" r:id="Rd08417b74f204aa4"/>
   </p:sldLayoutIdLst>
   <p:txStyles>
     <p:titleStyle>
@@ -2418,7 +2418,7 @@
                   <c:v>625</c:v>
                 </c:pt>
                 <c:pt idx="1">
-                  <c:v>11351.361</c:v>
+                  <c:v>11007.57</c:v>
                 </c:pt>
                 <c:pt idx="2">
                   <c:v>31610.704</c:v>
@@ -2580,7 +2580,7 @@
           <p:cNvPr id="9" name="">
             <a:extLst xmlns:a="http://schemas.openxmlformats.org/drawingml/2006/main">
               <a:ext uri="{FF2B5EF4-FFF2-40B4-BE49-F238E27FC236}">
-                <a16:creationId xmlns:a16="http://schemas.microsoft.com/office/drawing/2014/main" id="{568A93AE-CA1E-413A-89AC-848C3D1F5BDD}"/>
+                <a16:creationId xmlns:a16="http://schemas.microsoft.com/office/drawing/2014/main" id="{324AB84D-8C9E-4612-B39E-DABFC19CF6BA}"/>
               </a:ext>
             </a:extLst>
           </p:cNvPr>
@@ -2610,7 +2610,7 @@
           <p:cNvPr id="2" name="">
             <a:extLst xmlns:a="http://schemas.openxmlformats.org/drawingml/2006/main">
               <a:ext uri="{FF2B5EF4-FFF2-40B4-BE49-F238E27FC236}">
-                <a16:creationId xmlns:a16="http://schemas.microsoft.com/office/drawing/2014/main" id="{429EA291-49C9-46F9-9DB4-9B6E748CFAC5}"/>
+                <a16:creationId xmlns:a16="http://schemas.microsoft.com/office/drawing/2014/main" id="{C15DCDA8-C2A6-45D5-AD91-6C2C035C7961}"/>
               </a:ext>
             </a:extLst>
           </p:cNvPr>
@@ -2667,7 +2667,7 @@
           <p:cNvPr id="3" name="">
             <a:extLst xmlns:a="http://schemas.openxmlformats.org/drawingml/2006/main">
               <a:ext uri="{FF2B5EF4-FFF2-40B4-BE49-F238E27FC236}">
-                <a16:creationId xmlns:a16="http://schemas.microsoft.com/office/drawing/2014/main" id="{4A16285F-9286-4D5A-8E17-1DB99012FCA0}"/>
+                <a16:creationId xmlns:a16="http://schemas.microsoft.com/office/drawing/2014/main" id="{59D685DE-4E3A-4821-8B96-CF520938DAB3}"/>
               </a:ext>
             </a:extLst>
           </p:cNvPr>
@@ -2747,7 +2747,7 @@
           <p:cNvPr id="4" name="">
             <a:extLst xmlns:a="http://schemas.openxmlformats.org/drawingml/2006/main">
               <a:ext uri="{FF2B5EF4-FFF2-40B4-BE49-F238E27FC236}">
-                <a16:creationId xmlns:a16="http://schemas.microsoft.com/office/drawing/2014/main" id="{0ECD141E-4D98-4D64-B0BD-D26442B4563C}"/>
+                <a16:creationId xmlns:a16="http://schemas.microsoft.com/office/drawing/2014/main" id="{56AF34C0-6BA7-4DDB-851B-AE180B4C7EB7}"/>
               </a:ext>
             </a:extLst>
           </p:cNvPr>
@@ -2804,7 +2804,7 @@
           <p:cNvPr id="5" name="">
             <a:extLst xmlns:a="http://schemas.openxmlformats.org/drawingml/2006/main">
               <a:ext uri="{FF2B5EF4-FFF2-40B4-BE49-F238E27FC236}">
-                <a16:creationId xmlns:a16="http://schemas.microsoft.com/office/drawing/2014/main" id="{4F9D7A1A-46F0-4AAC-B40D-358E308B6C9C}"/>
+                <a16:creationId xmlns:a16="http://schemas.microsoft.com/office/drawing/2014/main" id="{3ABBCFC5-39D4-483D-9BEC-82C0549A29A8}"/>
               </a:ext>
             </a:extLst>
           </p:cNvPr>
@@ -2834,7 +2834,7 @@
           <p:cNvPr id="6" name="">
             <a:extLst xmlns:a="http://schemas.openxmlformats.org/drawingml/2006/main">
               <a:ext uri="{FF2B5EF4-FFF2-40B4-BE49-F238E27FC236}">
-                <a16:creationId xmlns:a16="http://schemas.microsoft.com/office/drawing/2014/main" id="{E445DC18-9090-4040-88B4-E85CDE8818A2}"/>
+                <a16:creationId xmlns:a16="http://schemas.microsoft.com/office/drawing/2014/main" id="{C95B5D28-19BB-4255-9D38-C3E0A8A47F43}"/>
               </a:ext>
             </a:extLst>
           </p:cNvPr>
@@ -2891,7 +2891,7 @@
           <p:cNvPr id="7" name="">
             <a:extLst xmlns:a="http://schemas.openxmlformats.org/drawingml/2006/main">
               <a:ext uri="{FF2B5EF4-FFF2-40B4-BE49-F238E27FC236}">
-                <a16:creationId xmlns:a16="http://schemas.microsoft.com/office/drawing/2014/main" id="{396CFD34-C411-4FCF-A788-034E94EA6E28}"/>
+                <a16:creationId xmlns:a16="http://schemas.microsoft.com/office/drawing/2014/main" id="{E0A125AF-950E-481E-8B7E-DCE329B1AF88}"/>
               </a:ext>
             </a:extLst>
           </p:cNvPr>
@@ -2948,7 +2948,7 @@
           <p:cNvPr id="8" name="">
             <a:extLst xmlns:a="http://schemas.openxmlformats.org/drawingml/2006/main">
               <a:ext uri="{FF2B5EF4-FFF2-40B4-BE49-F238E27FC236}">
-                <a16:creationId xmlns:a16="http://schemas.microsoft.com/office/drawing/2014/main" id="{BF82B567-2CBA-410B-95B9-485EEA1F73D8}"/>
+                <a16:creationId xmlns:a16="http://schemas.microsoft.com/office/drawing/2014/main" id="{9E0AB572-004D-49D3-B569-0EE4853E0324}"/>
               </a:ext>
             </a:extLst>
           </p:cNvPr>
@@ -3003,7 +3003,7 @@
     </p:spTree>
     <p:extLst>
       <p:ext uri="{BB962C8B-B14F-4D97-AF65-F5344CB8AC3E}">
-        <p14:creationId xmlns:p14="http://schemas.microsoft.com/office/powerpoint/2010/main" val="1889371190"/>
+        <p14:creationId xmlns:p14="http://schemas.microsoft.com/office/powerpoint/2010/main" val="1202926283"/>
       </p:ext>
     </p:extLst>
   </p:cSld>
@@ -3034,7 +3034,7 @@
           <p:cNvPr id="28" name="">
             <a:extLst xmlns:a="http://schemas.openxmlformats.org/drawingml/2006/main">
               <a:ext uri="{FF2B5EF4-FFF2-40B4-BE49-F238E27FC236}">
-                <a16:creationId xmlns:a16="http://schemas.microsoft.com/office/drawing/2014/main" id="{B2666B12-1043-48FA-83E0-EACDBFDE1A15}"/>
+                <a16:creationId xmlns:a16="http://schemas.microsoft.com/office/drawing/2014/main" id="{F57BF93B-E979-4928-963E-B380D572A2B2}"/>
               </a:ext>
             </a:extLst>
           </p:cNvPr>
@@ -3091,7 +3091,7 @@
           <p:cNvPr id="2" name="">
             <a:extLst xmlns:a="http://schemas.openxmlformats.org/drawingml/2006/main">
               <a:ext uri="{FF2B5EF4-FFF2-40B4-BE49-F238E27FC236}">
-                <a16:creationId xmlns:a16="http://schemas.microsoft.com/office/drawing/2014/main" id="{BE954602-4CB1-455F-B5CF-4F44DE20168A}"/>
+                <a16:creationId xmlns:a16="http://schemas.microsoft.com/office/drawing/2014/main" id="{4BE747FB-0748-445A-A397-58BE5D83AFD2}"/>
               </a:ext>
             </a:extLst>
           </p:cNvPr>
@@ -3148,7 +3148,7 @@
           <p:cNvPr id="3" name="">
             <a:extLst xmlns:a="http://schemas.openxmlformats.org/drawingml/2006/main">
               <a:ext uri="{FF2B5EF4-FFF2-40B4-BE49-F238E27FC236}">
-                <a16:creationId xmlns:a16="http://schemas.microsoft.com/office/drawing/2014/main" id="{53E6C695-A2E0-490B-B9EA-148B28EEF368}"/>
+                <a16:creationId xmlns:a16="http://schemas.microsoft.com/office/drawing/2014/main" id="{76AEF02C-1F0B-417A-BDB5-6C4F8E2BCC69}"/>
               </a:ext>
             </a:extLst>
           </p:cNvPr>
@@ -3178,7 +3178,7 @@
           <p:cNvPr id="4" name="">
             <a:extLst xmlns:a="http://schemas.openxmlformats.org/drawingml/2006/main">
               <a:ext uri="{FF2B5EF4-FFF2-40B4-BE49-F238E27FC236}">
-                <a16:creationId xmlns:a16="http://schemas.microsoft.com/office/drawing/2014/main" id="{3E5A1DD7-BC37-4AD9-B6D9-8D36CE784E1B}"/>
+                <a16:creationId xmlns:a16="http://schemas.microsoft.com/office/drawing/2014/main" id="{21375AA8-572F-4FD4-9872-E392655E72AA}"/>
               </a:ext>
             </a:extLst>
           </p:cNvPr>
@@ -3235,7 +3235,7 @@
           <p:cNvPr id="5" name="">
             <a:extLst xmlns:a="http://schemas.openxmlformats.org/drawingml/2006/main">
               <a:ext uri="{FF2B5EF4-FFF2-40B4-BE49-F238E27FC236}">
-                <a16:creationId xmlns:a16="http://schemas.microsoft.com/office/drawing/2014/main" id="{0F217C75-2DC8-44B0-BA53-0553FCD1274B}"/>
+                <a16:creationId xmlns:a16="http://schemas.microsoft.com/office/drawing/2014/main" id="{740A15B4-A77C-4A98-91F5-6E4FE764BE9C}"/>
               </a:ext>
             </a:extLst>
           </p:cNvPr>
@@ -3292,7 +3292,7 @@
           <p:cNvPr id="6" name="">
             <a:extLst xmlns:a="http://schemas.openxmlformats.org/drawingml/2006/main">
               <a:ext uri="{FF2B5EF4-FFF2-40B4-BE49-F238E27FC236}">
-                <a16:creationId xmlns:a16="http://schemas.microsoft.com/office/drawing/2014/main" id="{6C1131CB-02A1-4DAF-A7EF-D891E2D22D1C}"/>
+                <a16:creationId xmlns:a16="http://schemas.microsoft.com/office/drawing/2014/main" id="{A530F1C0-05D8-4859-8FAC-7B970B23E198}"/>
               </a:ext>
             </a:extLst>
           </p:cNvPr>
@@ -3326,7 +3326,7 @@
           <p:cNvPr id="7" name="">
             <a:extLst xmlns:a="http://schemas.openxmlformats.org/drawingml/2006/main">
               <a:ext uri="{FF2B5EF4-FFF2-40B4-BE49-F238E27FC236}">
-                <a16:creationId xmlns:a16="http://schemas.microsoft.com/office/drawing/2014/main" id="{4469569D-5ADB-4757-B4B0-C22CC81A7A6F}"/>
+                <a16:creationId xmlns:a16="http://schemas.microsoft.com/office/drawing/2014/main" id="{7159D008-2990-4019-A716-3AD95CBBD12B}"/>
               </a:ext>
             </a:extLst>
           </p:cNvPr>
@@ -3387,7 +3387,7 @@
           <p:cNvPr id="8" name="">
             <a:extLst xmlns:a="http://schemas.openxmlformats.org/drawingml/2006/main">
               <a:ext uri="{FF2B5EF4-FFF2-40B4-BE49-F238E27FC236}">
-                <a16:creationId xmlns:a16="http://schemas.microsoft.com/office/drawing/2014/main" id="{7C0D9DCF-70DC-4F61-9463-8A4351960877}"/>
+                <a16:creationId xmlns:a16="http://schemas.microsoft.com/office/drawing/2014/main" id="{2D445BBB-C212-4A0C-9571-5B08E1693D2B}"/>
               </a:ext>
             </a:extLst>
           </p:cNvPr>
@@ -3444,7 +3444,7 @@
           <p:cNvPr id="9" name="">
             <a:extLst xmlns:a="http://schemas.openxmlformats.org/drawingml/2006/main">
               <a:ext uri="{FF2B5EF4-FFF2-40B4-BE49-F238E27FC236}">
-                <a16:creationId xmlns:a16="http://schemas.microsoft.com/office/drawing/2014/main" id="{11594927-2A0A-4DE5-980A-1F558DB91BD0}"/>
+                <a16:creationId xmlns:a16="http://schemas.microsoft.com/office/drawing/2014/main" id="{A1D77042-6A13-49B5-8198-716F267C4792}"/>
               </a:ext>
             </a:extLst>
           </p:cNvPr>
@@ -3501,7 +3501,7 @@
           <p:cNvPr id="10" name="">
             <a:extLst xmlns:a="http://schemas.openxmlformats.org/drawingml/2006/main">
               <a:ext uri="{FF2B5EF4-FFF2-40B4-BE49-F238E27FC236}">
-                <a16:creationId xmlns:a16="http://schemas.microsoft.com/office/drawing/2014/main" id="{D21B4453-9AFF-4A35-ADCC-86369DDC7BD1}"/>
+                <a16:creationId xmlns:a16="http://schemas.microsoft.com/office/drawing/2014/main" id="{18D2D5C7-B62C-4BB4-9F61-17D263490CC5}"/>
               </a:ext>
             </a:extLst>
           </p:cNvPr>
@@ -3535,7 +3535,7 @@
           <p:cNvPr id="11" name="">
             <a:extLst xmlns:a="http://schemas.openxmlformats.org/drawingml/2006/main">
               <a:ext uri="{FF2B5EF4-FFF2-40B4-BE49-F238E27FC236}">
-                <a16:creationId xmlns:a16="http://schemas.microsoft.com/office/drawing/2014/main" id="{C946B968-033B-45E0-B452-E7AD9AEE330F}"/>
+                <a16:creationId xmlns:a16="http://schemas.microsoft.com/office/drawing/2014/main" id="{818BC23F-57D8-49A4-A838-DBF2797C5FEF}"/>
               </a:ext>
             </a:extLst>
           </p:cNvPr>
@@ -3596,7 +3596,7 @@
           <p:cNvPr id="12" name="">
             <a:extLst xmlns:a="http://schemas.openxmlformats.org/drawingml/2006/main">
               <a:ext uri="{FF2B5EF4-FFF2-40B4-BE49-F238E27FC236}">
-                <a16:creationId xmlns:a16="http://schemas.microsoft.com/office/drawing/2014/main" id="{F140940A-3729-4648-9D4E-E9C1686BE50A}"/>
+                <a16:creationId xmlns:a16="http://schemas.microsoft.com/office/drawing/2014/main" id="{7AE63969-6572-425B-8D7E-F36B5CD8FB4D}"/>
               </a:ext>
             </a:extLst>
           </p:cNvPr>
@@ -3653,7 +3653,7 @@
           <p:cNvPr id="13" name="">
             <a:extLst xmlns:a="http://schemas.openxmlformats.org/drawingml/2006/main">
               <a:ext uri="{FF2B5EF4-FFF2-40B4-BE49-F238E27FC236}">
-                <a16:creationId xmlns:a16="http://schemas.microsoft.com/office/drawing/2014/main" id="{85A2DA3F-67B3-4FDB-B45B-6B77B42F1622}"/>
+                <a16:creationId xmlns:a16="http://schemas.microsoft.com/office/drawing/2014/main" id="{4BF78166-ED8B-4A77-91FF-72516A800AA8}"/>
               </a:ext>
             </a:extLst>
           </p:cNvPr>
@@ -3710,7 +3710,7 @@
           <p:cNvPr id="14" name="">
             <a:extLst xmlns:a="http://schemas.openxmlformats.org/drawingml/2006/main">
               <a:ext uri="{FF2B5EF4-FFF2-40B4-BE49-F238E27FC236}">
-                <a16:creationId xmlns:a16="http://schemas.microsoft.com/office/drawing/2014/main" id="{30877F3E-8A83-410C-8343-C754967ACB4D}"/>
+                <a16:creationId xmlns:a16="http://schemas.microsoft.com/office/drawing/2014/main" id="{1547906D-8A32-47F1-8D9F-5520E5C399F9}"/>
               </a:ext>
             </a:extLst>
           </p:cNvPr>
@@ -3744,7 +3744,7 @@
           <p:cNvPr id="15" name="">
             <a:extLst xmlns:a="http://schemas.openxmlformats.org/drawingml/2006/main">
               <a:ext uri="{FF2B5EF4-FFF2-40B4-BE49-F238E27FC236}">
-                <a16:creationId xmlns:a16="http://schemas.microsoft.com/office/drawing/2014/main" id="{60785F8B-E2B1-4C8D-A123-9F805BF255B9}"/>
+                <a16:creationId xmlns:a16="http://schemas.microsoft.com/office/drawing/2014/main" id="{8D4C9F39-0C72-4A78-A59A-FAA34F32AC25}"/>
               </a:ext>
             </a:extLst>
           </p:cNvPr>
@@ -3805,7 +3805,7 @@
           <p:cNvPr id="16" name="">
             <a:extLst xmlns:a="http://schemas.openxmlformats.org/drawingml/2006/main">
               <a:ext uri="{FF2B5EF4-FFF2-40B4-BE49-F238E27FC236}">
-                <a16:creationId xmlns:a16="http://schemas.microsoft.com/office/drawing/2014/main" id="{4BBA8449-CCA9-4CA4-8A22-D6A742746E3F}"/>
+                <a16:creationId xmlns:a16="http://schemas.microsoft.com/office/drawing/2014/main" id="{9F723427-A47C-4A38-BA2F-5FCFA4858C13}"/>
               </a:ext>
             </a:extLst>
           </p:cNvPr>
@@ -3862,7 +3862,7 @@
           <p:cNvPr id="17" name="">
             <a:extLst xmlns:a="http://schemas.openxmlformats.org/drawingml/2006/main">
               <a:ext uri="{FF2B5EF4-FFF2-40B4-BE49-F238E27FC236}">
-                <a16:creationId xmlns:a16="http://schemas.microsoft.com/office/drawing/2014/main" id="{536CA31C-FDFB-4BDD-8F73-826215EF9FC3}"/>
+                <a16:creationId xmlns:a16="http://schemas.microsoft.com/office/drawing/2014/main" id="{B6165E34-A389-4E40-BE9A-A5BFC65996E8}"/>
               </a:ext>
             </a:extLst>
           </p:cNvPr>
@@ -3919,7 +3919,7 @@
           <p:cNvPr id="18" name="">
             <a:extLst xmlns:a="http://schemas.openxmlformats.org/drawingml/2006/main">
               <a:ext uri="{FF2B5EF4-FFF2-40B4-BE49-F238E27FC236}">
-                <a16:creationId xmlns:a16="http://schemas.microsoft.com/office/drawing/2014/main" id="{B34ED0C1-98CE-48AA-BAF1-60E506A7B227}"/>
+                <a16:creationId xmlns:a16="http://schemas.microsoft.com/office/drawing/2014/main" id="{CDE4F6C4-DEE5-459F-90BB-5E3BB6BBA4DA}"/>
               </a:ext>
             </a:extLst>
           </p:cNvPr>
@@ -3953,7 +3953,7 @@
           <p:cNvPr id="19" name="">
             <a:extLst xmlns:a="http://schemas.openxmlformats.org/drawingml/2006/main">
               <a:ext uri="{FF2B5EF4-FFF2-40B4-BE49-F238E27FC236}">
-                <a16:creationId xmlns:a16="http://schemas.microsoft.com/office/drawing/2014/main" id="{5D1C55ED-8928-4AFE-8E19-CEAB1169C9B1}"/>
+                <a16:creationId xmlns:a16="http://schemas.microsoft.com/office/drawing/2014/main" id="{18876D61-39C1-473C-83D5-535836C26AA6}"/>
               </a:ext>
             </a:extLst>
           </p:cNvPr>
@@ -4014,7 +4014,7 @@
           <p:cNvPr id="20" name="">
             <a:extLst xmlns:a="http://schemas.openxmlformats.org/drawingml/2006/main">
               <a:ext uri="{FF2B5EF4-FFF2-40B4-BE49-F238E27FC236}">
-                <a16:creationId xmlns:a16="http://schemas.microsoft.com/office/drawing/2014/main" id="{E936DF02-1D3C-4983-87A2-DABE4C88B587}"/>
+                <a16:creationId xmlns:a16="http://schemas.microsoft.com/office/drawing/2014/main" id="{25B8A3CE-55F0-4F02-9E56-0B04037AB23A}"/>
               </a:ext>
             </a:extLst>
           </p:cNvPr>
@@ -4071,7 +4071,7 @@
           <p:cNvPr id="21" name="">
             <a:extLst xmlns:a="http://schemas.openxmlformats.org/drawingml/2006/main">
               <a:ext uri="{FF2B5EF4-FFF2-40B4-BE49-F238E27FC236}">
-                <a16:creationId xmlns:a16="http://schemas.microsoft.com/office/drawing/2014/main" id="{91AEFF0B-D3D7-4649-A5DE-16D9D3EA953A}"/>
+                <a16:creationId xmlns:a16="http://schemas.microsoft.com/office/drawing/2014/main" id="{E3AEDB80-9E13-4564-9186-6FE34AE31281}"/>
               </a:ext>
             </a:extLst>
           </p:cNvPr>
@@ -4203,7 +4203,7 @@
           <p:cNvPr id="25" name="">
             <a:extLst xmlns:a="http://schemas.openxmlformats.org/drawingml/2006/main">
               <a:ext uri="{FF2B5EF4-FFF2-40B4-BE49-F238E27FC236}">
-                <a16:creationId xmlns:a16="http://schemas.microsoft.com/office/drawing/2014/main" id="{0BDCE97C-8645-4CC6-B751-8BF4D1423198}"/>
+                <a16:creationId xmlns:a16="http://schemas.microsoft.com/office/drawing/2014/main" id="{0CAEFAFD-3082-42A8-93C2-4A3BC1D9884D}"/>
               </a:ext>
             </a:extLst>
           </p:cNvPr>
@@ -4260,7 +4260,7 @@
           <p:cNvPr id="26" name="">
             <a:extLst xmlns:a="http://schemas.openxmlformats.org/drawingml/2006/main">
               <a:ext uri="{FF2B5EF4-FFF2-40B4-BE49-F238E27FC236}">
-                <a16:creationId xmlns:a16="http://schemas.microsoft.com/office/drawing/2014/main" id="{4B04B050-1D4C-49AC-8183-9127047522C9}"/>
+                <a16:creationId xmlns:a16="http://schemas.microsoft.com/office/drawing/2014/main" id="{0C700FA3-827C-4A14-B542-086EC6F5B9D8}"/>
               </a:ext>
             </a:extLst>
           </p:cNvPr>
@@ -4321,7 +4321,7 @@
           <p:cNvPr id="27" name="">
             <a:extLst xmlns:a="http://schemas.openxmlformats.org/drawingml/2006/main">
               <a:ext uri="{FF2B5EF4-FFF2-40B4-BE49-F238E27FC236}">
-                <a16:creationId xmlns:a16="http://schemas.microsoft.com/office/drawing/2014/main" id="{07B993CA-0396-4D71-9FD9-360F20AB0C85}"/>
+                <a16:creationId xmlns:a16="http://schemas.microsoft.com/office/drawing/2014/main" id="{32E06C62-6E87-4291-BB6F-514CB075F302}"/>
               </a:ext>
             </a:extLst>
           </p:cNvPr>
@@ -4376,7 +4376,7 @@
     </p:spTree>
     <p:extLst>
       <p:ext uri="{BB962C8B-B14F-4D97-AF65-F5344CB8AC3E}">
-        <p14:creationId xmlns:p14="http://schemas.microsoft.com/office/powerpoint/2010/main" val="1320175770"/>
+        <p14:creationId xmlns:p14="http://schemas.microsoft.com/office/powerpoint/2010/main" val="599207614"/>
       </p:ext>
     </p:extLst>
   </p:cSld>
@@ -4407,7 +4407,7 @@
           <p:cNvPr id="17" name="">
             <a:extLst xmlns:a="http://schemas.openxmlformats.org/drawingml/2006/main">
               <a:ext uri="{FF2B5EF4-FFF2-40B4-BE49-F238E27FC236}">
-                <a16:creationId xmlns:a16="http://schemas.microsoft.com/office/drawing/2014/main" id="{D27E2190-1B5E-4675-8CB1-BFE89BDFC9CF}"/>
+                <a16:creationId xmlns:a16="http://schemas.microsoft.com/office/drawing/2014/main" id="{EB44B375-B2F8-417E-8A6C-44D31978BE37}"/>
               </a:ext>
             </a:extLst>
           </p:cNvPr>
@@ -4464,7 +4464,7 @@
           <p:cNvPr id="2" name="">
             <a:extLst xmlns:a="http://schemas.openxmlformats.org/drawingml/2006/main">
               <a:ext uri="{FF2B5EF4-FFF2-40B4-BE49-F238E27FC236}">
-                <a16:creationId xmlns:a16="http://schemas.microsoft.com/office/drawing/2014/main" id="{8C2F06E7-2FC8-49C9-ABFB-E68FB0227991}"/>
+                <a16:creationId xmlns:a16="http://schemas.microsoft.com/office/drawing/2014/main" id="{8180E733-40B3-49F9-A5F2-A9D1705DA18B}"/>
               </a:ext>
             </a:extLst>
           </p:cNvPr>
@@ -4521,7 +4521,7 @@
           <p:cNvPr id="3" name="">
             <a:extLst xmlns:a="http://schemas.openxmlformats.org/drawingml/2006/main">
               <a:ext uri="{FF2B5EF4-FFF2-40B4-BE49-F238E27FC236}">
-                <a16:creationId xmlns:a16="http://schemas.microsoft.com/office/drawing/2014/main" id="{EC99DC14-0D8F-42E8-8884-1D9226225A93}"/>
+                <a16:creationId xmlns:a16="http://schemas.microsoft.com/office/drawing/2014/main" id="{FCC60934-8304-4B7D-9E62-AB4893D35B7B}"/>
               </a:ext>
             </a:extLst>
           </p:cNvPr>
@@ -4551,7 +4551,7 @@
           <p:cNvPr id="4" name="">
             <a:extLst xmlns:a="http://schemas.openxmlformats.org/drawingml/2006/main">
               <a:ext uri="{FF2B5EF4-FFF2-40B4-BE49-F238E27FC236}">
-                <a16:creationId xmlns:a16="http://schemas.microsoft.com/office/drawing/2014/main" id="{061786AE-ACA0-4EDF-B64C-FCFA1F8B930E}"/>
+                <a16:creationId xmlns:a16="http://schemas.microsoft.com/office/drawing/2014/main" id="{D82AF58F-7808-4D18-84DB-D9B07075CDAA}"/>
               </a:ext>
             </a:extLst>
           </p:cNvPr>
@@ -4608,7 +4608,7 @@
           <p:cNvPr id="5" name="">
             <a:extLst xmlns:a="http://schemas.openxmlformats.org/drawingml/2006/main">
               <a:ext uri="{FF2B5EF4-FFF2-40B4-BE49-F238E27FC236}">
-                <a16:creationId xmlns:a16="http://schemas.microsoft.com/office/drawing/2014/main" id="{67839962-5347-4CA1-9AB3-D330247BCDF8}"/>
+                <a16:creationId xmlns:a16="http://schemas.microsoft.com/office/drawing/2014/main" id="{68B69408-E910-4C67-AE4D-900E400F6270}"/>
               </a:ext>
             </a:extLst>
           </p:cNvPr>
@@ -4642,7 +4642,7 @@
           <p:cNvPr id="6" name="">
             <a:extLst xmlns:a="http://schemas.openxmlformats.org/drawingml/2006/main">
               <a:ext uri="{FF2B5EF4-FFF2-40B4-BE49-F238E27FC236}">
-                <a16:creationId xmlns:a16="http://schemas.microsoft.com/office/drawing/2014/main" id="{B42C9B95-F58F-4720-9A88-31DDBF5D0243}"/>
+                <a16:creationId xmlns:a16="http://schemas.microsoft.com/office/drawing/2014/main" id="{C9C38D88-0643-42CF-A411-9ED54A1BFF65}"/>
               </a:ext>
             </a:extLst>
           </p:cNvPr>
@@ -4699,7 +4699,7 @@
           <p:cNvPr id="7" name="">
             <a:extLst xmlns:a="http://schemas.openxmlformats.org/drawingml/2006/main">
               <a:ext uri="{FF2B5EF4-FFF2-40B4-BE49-F238E27FC236}">
-                <a16:creationId xmlns:a16="http://schemas.microsoft.com/office/drawing/2014/main" id="{CCB5A9A7-8D26-4F32-8297-A676A9D49925}"/>
+                <a16:creationId xmlns:a16="http://schemas.microsoft.com/office/drawing/2014/main" id="{58893FC6-401C-4668-852A-5B32312AAC0C}"/>
               </a:ext>
             </a:extLst>
           </p:cNvPr>
@@ -4756,7 +4756,7 @@
           <p:cNvPr id="8" name="">
             <a:extLst xmlns:a="http://schemas.openxmlformats.org/drawingml/2006/main">
               <a:ext uri="{FF2B5EF4-FFF2-40B4-BE49-F238E27FC236}">
-                <a16:creationId xmlns:a16="http://schemas.microsoft.com/office/drawing/2014/main" id="{F4D5FBBE-EC68-42A2-BEFE-8F5CBA14FA33}"/>
+                <a16:creationId xmlns:a16="http://schemas.microsoft.com/office/drawing/2014/main" id="{03545603-BA27-4A8F-98C1-C359B2141FC0}"/>
               </a:ext>
             </a:extLst>
           </p:cNvPr>
@@ -4836,7 +4836,7 @@
           <p:cNvPr id="9" name="">
             <a:extLst xmlns:a="http://schemas.openxmlformats.org/drawingml/2006/main">
               <a:ext uri="{FF2B5EF4-FFF2-40B4-BE49-F238E27FC236}">
-                <a16:creationId xmlns:a16="http://schemas.microsoft.com/office/drawing/2014/main" id="{6014A9B5-C2E2-4A5D-BB63-DC2D1679C69A}"/>
+                <a16:creationId xmlns:a16="http://schemas.microsoft.com/office/drawing/2014/main" id="{D88E0E39-F31C-4A65-A08A-EE01540C6321}"/>
               </a:ext>
             </a:extLst>
           </p:cNvPr>
@@ -4870,7 +4870,7 @@
           <p:cNvPr id="10" name="">
             <a:extLst xmlns:a="http://schemas.openxmlformats.org/drawingml/2006/main">
               <a:ext uri="{FF2B5EF4-FFF2-40B4-BE49-F238E27FC236}">
-                <a16:creationId xmlns:a16="http://schemas.microsoft.com/office/drawing/2014/main" id="{3CA2AC53-3C3C-40EE-AEAC-5EDCC1B34BCC}"/>
+                <a16:creationId xmlns:a16="http://schemas.microsoft.com/office/drawing/2014/main" id="{CDDB34D3-B8BA-471E-AE3C-AF3A7B1C5248}"/>
               </a:ext>
             </a:extLst>
           </p:cNvPr>
@@ -4927,7 +4927,7 @@
           <p:cNvPr id="11" name="">
             <a:extLst xmlns:a="http://schemas.openxmlformats.org/drawingml/2006/main">
               <a:ext uri="{FF2B5EF4-FFF2-40B4-BE49-F238E27FC236}">
-                <a16:creationId xmlns:a16="http://schemas.microsoft.com/office/drawing/2014/main" id="{29B6CDAD-F161-4401-A07D-D8A682222BAC}"/>
+                <a16:creationId xmlns:a16="http://schemas.microsoft.com/office/drawing/2014/main" id="{15828AEE-29A1-4CA7-B6C4-1E9C031BF0AA}"/>
               </a:ext>
             </a:extLst>
           </p:cNvPr>
@@ -4984,7 +4984,7 @@
           <p:cNvPr id="12" name="">
             <a:extLst xmlns:a="http://schemas.openxmlformats.org/drawingml/2006/main">
               <a:ext uri="{FF2B5EF4-FFF2-40B4-BE49-F238E27FC236}">
-                <a16:creationId xmlns:a16="http://schemas.microsoft.com/office/drawing/2014/main" id="{8D712FA8-D023-4ECE-AD74-4EB178C0FAC1}"/>
+                <a16:creationId xmlns:a16="http://schemas.microsoft.com/office/drawing/2014/main" id="{C7140F5F-0526-4F17-859C-16B2AF7DA9B8}"/>
               </a:ext>
             </a:extLst>
           </p:cNvPr>
@@ -5064,7 +5064,7 @@
           <p:cNvPr id="13" name="">
             <a:extLst xmlns:a="http://schemas.openxmlformats.org/drawingml/2006/main">
               <a:ext uri="{FF2B5EF4-FFF2-40B4-BE49-F238E27FC236}">
-                <a16:creationId xmlns:a16="http://schemas.microsoft.com/office/drawing/2014/main" id="{9943E195-7176-49B4-B4A1-47A7D972D18E}"/>
+                <a16:creationId xmlns:a16="http://schemas.microsoft.com/office/drawing/2014/main" id="{C4F1C865-14A0-40AD-AA68-C2EE1DC06188}"/>
               </a:ext>
             </a:extLst>
           </p:cNvPr>
@@ -5098,7 +5098,7 @@
           <p:cNvPr id="14" name="">
             <a:extLst xmlns:a="http://schemas.openxmlformats.org/drawingml/2006/main">
               <a:ext uri="{FF2B5EF4-FFF2-40B4-BE49-F238E27FC236}">
-                <a16:creationId xmlns:a16="http://schemas.microsoft.com/office/drawing/2014/main" id="{641F44AE-BDF6-442E-941D-B0B84D6255C4}"/>
+                <a16:creationId xmlns:a16="http://schemas.microsoft.com/office/drawing/2014/main" id="{98F3F2A6-FA75-4A7B-A504-2AF64551463D}"/>
               </a:ext>
             </a:extLst>
           </p:cNvPr>
@@ -5132,7 +5132,7 @@
           <p:cNvPr id="15" name="">
             <a:extLst xmlns:a="http://schemas.openxmlformats.org/drawingml/2006/main">
               <a:ext uri="{FF2B5EF4-FFF2-40B4-BE49-F238E27FC236}">
-                <a16:creationId xmlns:a16="http://schemas.microsoft.com/office/drawing/2014/main" id="{B2979442-F3B5-49B1-9B11-E5BBDA121CB6}"/>
+                <a16:creationId xmlns:a16="http://schemas.microsoft.com/office/drawing/2014/main" id="{56CB567B-DEEE-40A2-94BD-280438DD2D88}"/>
               </a:ext>
             </a:extLst>
           </p:cNvPr>
@@ -5189,7 +5189,7 @@
           <p:cNvPr id="16" name="">
             <a:extLst xmlns:a="http://schemas.openxmlformats.org/drawingml/2006/main">
               <a:ext uri="{FF2B5EF4-FFF2-40B4-BE49-F238E27FC236}">
-                <a16:creationId xmlns:a16="http://schemas.microsoft.com/office/drawing/2014/main" id="{564727AB-89C2-4C04-97D1-0E4570EC8032}"/>
+                <a16:creationId xmlns:a16="http://schemas.microsoft.com/office/drawing/2014/main" id="{8A4D7B45-118E-4245-BF09-A6219A809799}"/>
               </a:ext>
             </a:extLst>
           </p:cNvPr>
@@ -5244,7 +5244,7 @@
     </p:spTree>
     <p:extLst>
       <p:ext uri="{BB962C8B-B14F-4D97-AF65-F5344CB8AC3E}">
-        <p14:creationId xmlns:p14="http://schemas.microsoft.com/office/powerpoint/2010/main" val="45352886"/>
+        <p14:creationId xmlns:p14="http://schemas.microsoft.com/office/powerpoint/2010/main" val="570595769"/>
       </p:ext>
     </p:extLst>
   </p:cSld>
@@ -5275,7 +5275,7 @@
           <p:cNvPr id="14" name="">
             <a:extLst xmlns:a="http://schemas.openxmlformats.org/drawingml/2006/main">
               <a:ext uri="{FF2B5EF4-FFF2-40B4-BE49-F238E27FC236}">
-                <a16:creationId xmlns:a16="http://schemas.microsoft.com/office/drawing/2014/main" id="{68EE050E-CABB-4273-B99C-62C4323713D6}"/>
+                <a16:creationId xmlns:a16="http://schemas.microsoft.com/office/drawing/2014/main" id="{5D33C81D-1F9C-4B88-9EFB-46595065C4C3}"/>
               </a:ext>
             </a:extLst>
           </p:cNvPr>
@@ -5332,7 +5332,7 @@
           <p:cNvPr id="2" name="">
             <a:extLst xmlns:a="http://schemas.openxmlformats.org/drawingml/2006/main">
               <a:ext uri="{FF2B5EF4-FFF2-40B4-BE49-F238E27FC236}">
-                <a16:creationId xmlns:a16="http://schemas.microsoft.com/office/drawing/2014/main" id="{A4041EF6-8B48-4828-91F6-B54749058F36}"/>
+                <a16:creationId xmlns:a16="http://schemas.microsoft.com/office/drawing/2014/main" id="{5DA6B46D-4E74-436F-9491-23A2F745F4ED}"/>
               </a:ext>
             </a:extLst>
           </p:cNvPr>
@@ -5389,7 +5389,7 @@
           <p:cNvPr id="3" name="">
             <a:extLst xmlns:a="http://schemas.openxmlformats.org/drawingml/2006/main">
               <a:ext uri="{FF2B5EF4-FFF2-40B4-BE49-F238E27FC236}">
-                <a16:creationId xmlns:a16="http://schemas.microsoft.com/office/drawing/2014/main" id="{56F517BF-F2A1-42F7-BF07-72DB5EC81AC4}"/>
+                <a16:creationId xmlns:a16="http://schemas.microsoft.com/office/drawing/2014/main" id="{675216BC-DB81-46A5-802A-0F69A3D17DA4}"/>
               </a:ext>
             </a:extLst>
           </p:cNvPr>
@@ -5419,7 +5419,7 @@
           <p:cNvPr id="4" name="">
             <a:extLst xmlns:a="http://schemas.openxmlformats.org/drawingml/2006/main">
               <a:ext uri="{FF2B5EF4-FFF2-40B4-BE49-F238E27FC236}">
-                <a16:creationId xmlns:a16="http://schemas.microsoft.com/office/drawing/2014/main" id="{8F00506C-B488-4D1F-973A-E5D025E57EAF}"/>
+                <a16:creationId xmlns:a16="http://schemas.microsoft.com/office/drawing/2014/main" id="{A0DE9FF3-02DB-4F63-917A-C8D1A95A9241}"/>
               </a:ext>
             </a:extLst>
           </p:cNvPr>
@@ -5476,7 +5476,7 @@
           <p:cNvPr id="5" name="">
             <a:extLst xmlns:a="http://schemas.openxmlformats.org/drawingml/2006/main">
               <a:ext uri="{FF2B5EF4-FFF2-40B4-BE49-F238E27FC236}">
-                <a16:creationId xmlns:a16="http://schemas.microsoft.com/office/drawing/2014/main" id="{745B694C-C473-4609-B8EC-DB918E903BCE}"/>
+                <a16:creationId xmlns:a16="http://schemas.microsoft.com/office/drawing/2014/main" id="{A999AE83-562F-468A-9096-6F81B181E40C}"/>
               </a:ext>
             </a:extLst>
           </p:cNvPr>
@@ -5533,7 +5533,7 @@
           <p:cNvPr id="6" name="">
             <a:extLst xmlns:a="http://schemas.openxmlformats.org/drawingml/2006/main">
               <a:ext uri="{FF2B5EF4-FFF2-40B4-BE49-F238E27FC236}">
-                <a16:creationId xmlns:a16="http://schemas.microsoft.com/office/drawing/2014/main" id="{8A7905D8-216C-44EA-B6F7-5520AD0A8A99}"/>
+                <a16:creationId xmlns:a16="http://schemas.microsoft.com/office/drawing/2014/main" id="{00A0004E-7B75-4ABC-A931-AF85BB348FBE}"/>
               </a:ext>
             </a:extLst>
           </p:cNvPr>
@@ -5597,7 +5597,7 @@
         </p:xfrm>
         <a:graphic xmlns:a="http://schemas.openxmlformats.org/drawingml/2006/main">
           <a:graphicData uri="http://schemas.openxmlformats.org/drawingml/2006/chart">
-            <c:chart xmlns:r="http://schemas.openxmlformats.org/officeDocument/2006/relationships" xmlns:c="http://schemas.openxmlformats.org/drawingml/2006/chart" r:id="Ra097f94b4aef4326"/>
+            <c:chart xmlns:r="http://schemas.openxmlformats.org/officeDocument/2006/relationships" xmlns:c="http://schemas.openxmlformats.org/drawingml/2006/chart" r:id="Rbfe73d79ed9f45a7"/>
           </a:graphicData>
         </a:graphic>
       </p:graphicFrame>
@@ -5606,7 +5606,7 @@
           <p:cNvPr id="8" name="">
             <a:extLst xmlns:a="http://schemas.openxmlformats.org/drawingml/2006/main">
               <a:ext uri="{FF2B5EF4-FFF2-40B4-BE49-F238E27FC236}">
-                <a16:creationId xmlns:a16="http://schemas.microsoft.com/office/drawing/2014/main" id="{0C147223-58C9-4B91-ABAD-F4015CA47F9E}"/>
+                <a16:creationId xmlns:a16="http://schemas.microsoft.com/office/drawing/2014/main" id="{F35F45AA-3121-4202-B302-4C7800A1ACC8}"/>
               </a:ext>
             </a:extLst>
           </p:cNvPr>
@@ -5663,7 +5663,7 @@
           <p:cNvPr id="9" name="">
             <a:extLst xmlns:a="http://schemas.openxmlformats.org/drawingml/2006/main">
               <a:ext uri="{FF2B5EF4-FFF2-40B4-BE49-F238E27FC236}">
-                <a16:creationId xmlns:a16="http://schemas.microsoft.com/office/drawing/2014/main" id="{FF4DBE8A-D416-40FA-8AD4-25C5F45CB596}"/>
+                <a16:creationId xmlns:a16="http://schemas.microsoft.com/office/drawing/2014/main" id="{376072D2-3293-4B53-BB3E-61EB6E91F5C1}"/>
               </a:ext>
             </a:extLst>
           </p:cNvPr>
@@ -5743,7 +5743,7 @@
           <p:cNvPr id="10" name="">
             <a:extLst xmlns:a="http://schemas.openxmlformats.org/drawingml/2006/main">
               <a:ext uri="{FF2B5EF4-FFF2-40B4-BE49-F238E27FC236}">
-                <a16:creationId xmlns:a16="http://schemas.microsoft.com/office/drawing/2014/main" id="{130A4623-496C-4CA6-87B9-DDD6526FC7BF}"/>
+                <a16:creationId xmlns:a16="http://schemas.microsoft.com/office/drawing/2014/main" id="{A5983374-59E2-4D9E-893F-3D30D4EAA8CE}"/>
               </a:ext>
             </a:extLst>
           </p:cNvPr>
@@ -5773,7 +5773,7 @@
           <p:cNvPr id="11" name="">
             <a:extLst xmlns:a="http://schemas.openxmlformats.org/drawingml/2006/main">
               <a:ext uri="{FF2B5EF4-FFF2-40B4-BE49-F238E27FC236}">
-                <a16:creationId xmlns:a16="http://schemas.microsoft.com/office/drawing/2014/main" id="{016723BF-3C2B-439A-B3C3-E9D4B6BA91F0}"/>
+                <a16:creationId xmlns:a16="http://schemas.microsoft.com/office/drawing/2014/main" id="{91632F95-53C9-4FB0-9AF5-3F5ABB571375}"/>
               </a:ext>
             </a:extLst>
           </p:cNvPr>
@@ -5830,7 +5830,7 @@
           <p:cNvPr id="12" name="">
             <a:extLst xmlns:a="http://schemas.openxmlformats.org/drawingml/2006/main">
               <a:ext uri="{FF2B5EF4-FFF2-40B4-BE49-F238E27FC236}">
-                <a16:creationId xmlns:a16="http://schemas.microsoft.com/office/drawing/2014/main" id="{1EB0FD36-12E1-4B4A-ABF1-B56F443561B9}"/>
+                <a16:creationId xmlns:a16="http://schemas.microsoft.com/office/drawing/2014/main" id="{B87ACC49-B9D8-4863-B6BA-FA51AD50C3B2}"/>
               </a:ext>
             </a:extLst>
           </p:cNvPr>
@@ -5877,7 +5877,7 @@
                 <a:ea typeface="Apple SD Gothic Neo"/>
                 <a:cs typeface="Apple SD Gothic Neo"/>
               </a:rPr>
-              <a:t>A 25   B 10   C 14   D 16   E 15</a:t>
+              <a:t>A 25   B 11   C 15   D 17   E 16</a:t>
             </a:r>
           </a:p>
         </p:txBody>
@@ -5887,7 +5887,7 @@
           <p:cNvPr id="13" name="">
             <a:extLst xmlns:a="http://schemas.openxmlformats.org/drawingml/2006/main">
               <a:ext uri="{FF2B5EF4-FFF2-40B4-BE49-F238E27FC236}">
-                <a16:creationId xmlns:a16="http://schemas.microsoft.com/office/drawing/2014/main" id="{4CB58F83-C72F-497F-AB59-A3E5CD10FAE7}"/>
+                <a16:creationId xmlns:a16="http://schemas.microsoft.com/office/drawing/2014/main" id="{14A309AC-19EE-4C59-B296-E20E7728F0EC}"/>
               </a:ext>
             </a:extLst>
           </p:cNvPr>
@@ -5957,7 +5957,7 @@
                 <a:ea typeface="Apple SD Gothic Neo"/>
                 <a:cs typeface="Apple SD Gothic Neo"/>
               </a:rPr>
-              <a:t>Product F1 53.31%</a:t>
+              <a:t>Product F1 47.37%</a:t>
             </a:r>
           </a:p>
           <a:p xmlns:a="http://schemas.openxmlformats.org/drawingml/2006/main">
@@ -5980,7 +5980,7 @@
                 <a:ea typeface="Apple SD Gothic Neo"/>
                 <a:cs typeface="Apple SD Gothic Neo"/>
               </a:rPr>
-              <a:t>Order 32.28%</a:t>
+              <a:t>Order 25.95%</a:t>
             </a:r>
           </a:p>
           <a:p xmlns:a="http://schemas.openxmlformats.org/drawingml/2006/main">
@@ -6003,7 +6003,7 @@
                 <a:ea typeface="Apple SD Gothic Neo"/>
                 <a:cs typeface="Apple SD Gothic Neo"/>
               </a:rPr>
-              <a:t>Numeric 43.48%</a:t>
+              <a:t>Numeric 39.13%</a:t>
             </a:r>
           </a:p>
           <a:p xmlns:a="http://schemas.openxmlformats.org/drawingml/2006/main">
@@ -6026,7 +6026,7 @@
                 <a:ea typeface="Apple SD Gothic Neo"/>
                 <a:cs typeface="Apple SD Gothic Neo"/>
               </a:rPr>
-              <a:t>Evidence 21.87%</a:t>
+              <a:t>Evidence 17.08%</a:t>
             </a:r>
           </a:p>
           <a:p xmlns:a="http://schemas.openxmlformats.org/drawingml/2006/main">
@@ -6049,7 +6049,7 @@
                 <a:ea typeface="Apple SD Gothic Neo"/>
                 <a:cs typeface="Apple SD Gothic Neo"/>
               </a:rPr>
-              <a:t>Limitation 57.14%</a:t>
+              <a:t>Limitation 54.29%</a:t>
             </a:r>
           </a:p>
         </p:txBody>
@@ -6057,7 +6057,7 @@
     </p:spTree>
     <p:extLst>
       <p:ext uri="{BB962C8B-B14F-4D97-AF65-F5344CB8AC3E}">
-        <p14:creationId xmlns:p14="http://schemas.microsoft.com/office/powerpoint/2010/main" val="1497959977"/>
+        <p14:creationId xmlns:p14="http://schemas.microsoft.com/office/powerpoint/2010/main" val="1466261164"/>
       </p:ext>
     </p:extLst>
   </p:cSld>
@@ -6088,7 +6088,7 @@
           <p:cNvPr id="16" name="">
             <a:extLst xmlns:a="http://schemas.openxmlformats.org/drawingml/2006/main">
               <a:ext uri="{FF2B5EF4-FFF2-40B4-BE49-F238E27FC236}">
-                <a16:creationId xmlns:a16="http://schemas.microsoft.com/office/drawing/2014/main" id="{00D30AC6-85CB-4912-82A8-3F8074AD7B66}"/>
+                <a16:creationId xmlns:a16="http://schemas.microsoft.com/office/drawing/2014/main" id="{57C6F557-83B2-4B17-8E1B-61B2DE154FE8}"/>
               </a:ext>
             </a:extLst>
           </p:cNvPr>
@@ -6145,7 +6145,7 @@
           <p:cNvPr id="2" name="">
             <a:extLst xmlns:a="http://schemas.openxmlformats.org/drawingml/2006/main">
               <a:ext uri="{FF2B5EF4-FFF2-40B4-BE49-F238E27FC236}">
-                <a16:creationId xmlns:a16="http://schemas.microsoft.com/office/drawing/2014/main" id="{97657140-90FA-47DC-B92E-E4DA6142EBBE}"/>
+                <a16:creationId xmlns:a16="http://schemas.microsoft.com/office/drawing/2014/main" id="{9CB77325-3649-48BF-94F5-50D6EF509560}"/>
               </a:ext>
             </a:extLst>
           </p:cNvPr>
@@ -6202,7 +6202,7 @@
           <p:cNvPr id="3" name="">
             <a:extLst xmlns:a="http://schemas.openxmlformats.org/drawingml/2006/main">
               <a:ext uri="{FF2B5EF4-FFF2-40B4-BE49-F238E27FC236}">
-                <a16:creationId xmlns:a16="http://schemas.microsoft.com/office/drawing/2014/main" id="{1518D73F-32C1-4610-84C8-604A9F75DA92}"/>
+                <a16:creationId xmlns:a16="http://schemas.microsoft.com/office/drawing/2014/main" id="{7D7EDBCB-67D3-4388-BBD1-AE8C8C550A7B}"/>
               </a:ext>
             </a:extLst>
           </p:cNvPr>
@@ -6232,7 +6232,7 @@
           <p:cNvPr id="4" name="">
             <a:extLst xmlns:a="http://schemas.openxmlformats.org/drawingml/2006/main">
               <a:ext uri="{FF2B5EF4-FFF2-40B4-BE49-F238E27FC236}">
-                <a16:creationId xmlns:a16="http://schemas.microsoft.com/office/drawing/2014/main" id="{0CA04303-E2E1-4CC5-A4E8-8CEF6EA89666}"/>
+                <a16:creationId xmlns:a16="http://schemas.microsoft.com/office/drawing/2014/main" id="{E11C6387-54C4-4BBC-A061-837E2295E0C7}"/>
               </a:ext>
             </a:extLst>
           </p:cNvPr>
@@ -6296,7 +6296,7 @@
         </p:xfrm>
         <a:graphic xmlns:a="http://schemas.openxmlformats.org/drawingml/2006/main">
           <a:graphicData uri="http://schemas.openxmlformats.org/drawingml/2006/chart">
-            <c:chart xmlns:r="http://schemas.openxmlformats.org/officeDocument/2006/relationships" xmlns:c="http://schemas.openxmlformats.org/drawingml/2006/chart" r:id="R254c6d585dbd446b"/>
+            <c:chart xmlns:r="http://schemas.openxmlformats.org/officeDocument/2006/relationships" xmlns:c="http://schemas.openxmlformats.org/drawingml/2006/chart" r:id="R4b4c70a162424632"/>
           </a:graphicData>
         </a:graphic>
       </p:graphicFrame>
@@ -6305,7 +6305,7 @@
           <p:cNvPr id="6" name="">
             <a:extLst xmlns:a="http://schemas.openxmlformats.org/drawingml/2006/main">
               <a:ext uri="{FF2B5EF4-FFF2-40B4-BE49-F238E27FC236}">
-                <a16:creationId xmlns:a16="http://schemas.microsoft.com/office/drawing/2014/main" id="{21BE7E86-3115-44FB-B815-355138CAD17E}"/>
+                <a16:creationId xmlns:a16="http://schemas.microsoft.com/office/drawing/2014/main" id="{35E7642E-474F-42E0-B634-D4B2C6FF3925}"/>
               </a:ext>
             </a:extLst>
           </p:cNvPr>
@@ -6362,7 +6362,7 @@
           <p:cNvPr id="7" name="">
             <a:extLst xmlns:a="http://schemas.openxmlformats.org/drawingml/2006/main">
               <a:ext uri="{FF2B5EF4-FFF2-40B4-BE49-F238E27FC236}">
-                <a16:creationId xmlns:a16="http://schemas.microsoft.com/office/drawing/2014/main" id="{AB74732D-C584-43A3-B741-C984986B5EDB}"/>
+                <a16:creationId xmlns:a16="http://schemas.microsoft.com/office/drawing/2014/main" id="{7DFFC708-1AF1-4689-9BE0-2E0EF58F46EC}"/>
               </a:ext>
             </a:extLst>
           </p:cNvPr>
@@ -6396,7 +6396,7 @@
           <p:cNvPr id="8" name="">
             <a:extLst xmlns:a="http://schemas.openxmlformats.org/drawingml/2006/main">
               <a:ext uri="{FF2B5EF4-FFF2-40B4-BE49-F238E27FC236}">
-                <a16:creationId xmlns:a16="http://schemas.microsoft.com/office/drawing/2014/main" id="{D0543FB3-BB93-4D89-8AB1-B072DDAFE780}"/>
+                <a16:creationId xmlns:a16="http://schemas.microsoft.com/office/drawing/2014/main" id="{0945F81E-63F6-46F7-9BE7-5D1111D8EA3B}"/>
               </a:ext>
             </a:extLst>
           </p:cNvPr>
@@ -6430,7 +6430,7 @@
           <p:cNvPr id="9" name="">
             <a:extLst xmlns:a="http://schemas.openxmlformats.org/drawingml/2006/main">
               <a:ext uri="{FF2B5EF4-FFF2-40B4-BE49-F238E27FC236}">
-                <a16:creationId xmlns:a16="http://schemas.microsoft.com/office/drawing/2014/main" id="{F76D3D4C-2B69-4096-98EC-C882BBD9C05D}"/>
+                <a16:creationId xmlns:a16="http://schemas.microsoft.com/office/drawing/2014/main" id="{2199533B-976D-4D2E-92AB-EB2279813AE5}"/>
               </a:ext>
             </a:extLst>
           </p:cNvPr>
@@ -6487,7 +6487,7 @@
           <p:cNvPr id="10" name="">
             <a:extLst xmlns:a="http://schemas.openxmlformats.org/drawingml/2006/main">
               <a:ext uri="{FF2B5EF4-FFF2-40B4-BE49-F238E27FC236}">
-                <a16:creationId xmlns:a16="http://schemas.microsoft.com/office/drawing/2014/main" id="{FF4F0618-0A0B-4468-BDF1-F387583E46CB}"/>
+                <a16:creationId xmlns:a16="http://schemas.microsoft.com/office/drawing/2014/main" id="{B936B264-F84B-4CC1-9C8D-BCE616FFCBB9}"/>
               </a:ext>
             </a:extLst>
           </p:cNvPr>
@@ -6557,7 +6557,7 @@
                 <a:ea typeface="Apple SD Gothic Neo"/>
                 <a:cs typeface="Apple SD Gothic Neo"/>
               </a:rPr>
-              <a:t>평균 7,347.939 ms</a:t>
+              <a:t>평균 7,268.868 ms</a:t>
             </a:r>
           </a:p>
           <a:p xmlns:a="http://schemas.openxmlformats.org/drawingml/2006/main">
@@ -6580,7 +6580,7 @@
                 <a:ea typeface="Apple SD Gothic Neo"/>
                 <a:cs typeface="Apple SD Gothic Neo"/>
               </a:rPr>
-              <a:t>p95 11,351.361 ms</a:t>
+              <a:t>p95 11,007.570 ms</a:t>
             </a:r>
           </a:p>
         </p:txBody>
@@ -6590,7 +6590,7 @@
           <p:cNvPr id="11" name="">
             <a:extLst xmlns:a="http://schemas.openxmlformats.org/drawingml/2006/main">
               <a:ext uri="{FF2B5EF4-FFF2-40B4-BE49-F238E27FC236}">
-                <a16:creationId xmlns:a16="http://schemas.microsoft.com/office/drawing/2014/main" id="{3B5BB173-F277-4830-9AE9-F3A1357FA9C0}"/>
+                <a16:creationId xmlns:a16="http://schemas.microsoft.com/office/drawing/2014/main" id="{5E640EF3-008F-4CBA-B859-31FA07737114}"/>
               </a:ext>
             </a:extLst>
           </p:cNvPr>
@@ -6624,7 +6624,7 @@
           <p:cNvPr id="12" name="">
             <a:extLst xmlns:a="http://schemas.openxmlformats.org/drawingml/2006/main">
               <a:ext uri="{FF2B5EF4-FFF2-40B4-BE49-F238E27FC236}">
-                <a16:creationId xmlns:a16="http://schemas.microsoft.com/office/drawing/2014/main" id="{452BE293-26A6-4F4D-B710-686EBB4686E3}"/>
+                <a16:creationId xmlns:a16="http://schemas.microsoft.com/office/drawing/2014/main" id="{3920C82F-932D-458D-A5B5-4A21C6D3EB9E}"/>
               </a:ext>
             </a:extLst>
           </p:cNvPr>
@@ -6658,7 +6658,7 @@
           <p:cNvPr id="13" name="">
             <a:extLst xmlns:a="http://schemas.openxmlformats.org/drawingml/2006/main">
               <a:ext uri="{FF2B5EF4-FFF2-40B4-BE49-F238E27FC236}">
-                <a16:creationId xmlns:a16="http://schemas.microsoft.com/office/drawing/2014/main" id="{05BDDF89-A217-437D-8097-62092217D6B2}"/>
+                <a16:creationId xmlns:a16="http://schemas.microsoft.com/office/drawing/2014/main" id="{660D951A-268E-4431-9A70-C415576A74E8}"/>
               </a:ext>
             </a:extLst>
           </p:cNvPr>
@@ -6715,7 +6715,7 @@
           <p:cNvPr id="14" name="">
             <a:extLst xmlns:a="http://schemas.openxmlformats.org/drawingml/2006/main">
               <a:ext uri="{FF2B5EF4-FFF2-40B4-BE49-F238E27FC236}">
-                <a16:creationId xmlns:a16="http://schemas.microsoft.com/office/drawing/2014/main" id="{0A126B93-DA90-4BCD-9211-48C066DD64F1}"/>
+                <a16:creationId xmlns:a16="http://schemas.microsoft.com/office/drawing/2014/main" id="{6FAA00B8-3531-43C7-8BAA-B4D5DFCF8038}"/>
               </a:ext>
             </a:extLst>
           </p:cNvPr>
@@ -6785,7 +6785,7 @@
                 <a:ea typeface="Apple SD Gothic Neo"/>
                 <a:cs typeface="Apple SD Gothic Neo"/>
               </a:rPr>
-              <a:t>517.063초</a:t>
+              <a:t>1,123.638초</a:t>
             </a:r>
           </a:p>
           <a:p xmlns:a="http://schemas.openxmlformats.org/drawingml/2006/main">
@@ -6818,7 +6818,7 @@
           <p:cNvPr id="15" name="">
             <a:extLst xmlns:a="http://schemas.openxmlformats.org/drawingml/2006/main">
               <a:ext uri="{FF2B5EF4-FFF2-40B4-BE49-F238E27FC236}">
-                <a16:creationId xmlns:a16="http://schemas.microsoft.com/office/drawing/2014/main" id="{E0E45B67-5F87-48A5-8187-3F67C791B8F5}"/>
+                <a16:creationId xmlns:a16="http://schemas.microsoft.com/office/drawing/2014/main" id="{2B6B16BE-B7AB-4CC7-8455-26B470B36CD5}"/>
               </a:ext>
             </a:extLst>
           </p:cNvPr>
@@ -6873,7 +6873,7 @@
     </p:spTree>
     <p:extLst>
       <p:ext uri="{BB962C8B-B14F-4D97-AF65-F5344CB8AC3E}">
-        <p14:creationId xmlns:p14="http://schemas.microsoft.com/office/powerpoint/2010/main" val="829791444"/>
+        <p14:creationId xmlns:p14="http://schemas.microsoft.com/office/powerpoint/2010/main" val="1855131703"/>
       </p:ext>
     </p:extLst>
   </p:cSld>
@@ -6904,7 +6904,7 @@
           <p:cNvPr id="27" name="">
             <a:extLst xmlns:a="http://schemas.openxmlformats.org/drawingml/2006/main">
               <a:ext uri="{FF2B5EF4-FFF2-40B4-BE49-F238E27FC236}">
-                <a16:creationId xmlns:a16="http://schemas.microsoft.com/office/drawing/2014/main" id="{C8F063AB-254D-4829-A088-4F7B7DC53D5E}"/>
+                <a16:creationId xmlns:a16="http://schemas.microsoft.com/office/drawing/2014/main" id="{07D6B8B7-8E03-469F-8C60-210E514C5667}"/>
               </a:ext>
             </a:extLst>
           </p:cNvPr>
@@ -6961,7 +6961,7 @@
           <p:cNvPr id="2" name="">
             <a:extLst xmlns:a="http://schemas.openxmlformats.org/drawingml/2006/main">
               <a:ext uri="{FF2B5EF4-FFF2-40B4-BE49-F238E27FC236}">
-                <a16:creationId xmlns:a16="http://schemas.microsoft.com/office/drawing/2014/main" id="{AD036B78-21DA-4E2C-9D33-5DB95B0171BB}"/>
+                <a16:creationId xmlns:a16="http://schemas.microsoft.com/office/drawing/2014/main" id="{989A21DB-C4B2-4F16-A739-F0C4C9FDDB21}"/>
               </a:ext>
             </a:extLst>
           </p:cNvPr>
@@ -7018,7 +7018,7 @@
           <p:cNvPr id="3" name="">
             <a:extLst xmlns:a="http://schemas.openxmlformats.org/drawingml/2006/main">
               <a:ext uri="{FF2B5EF4-FFF2-40B4-BE49-F238E27FC236}">
-                <a16:creationId xmlns:a16="http://schemas.microsoft.com/office/drawing/2014/main" id="{91959441-3922-4151-9778-0B1F79E575EC}"/>
+                <a16:creationId xmlns:a16="http://schemas.microsoft.com/office/drawing/2014/main" id="{FA28F7D0-BED7-4FE5-9B96-DD0F14525400}"/>
               </a:ext>
             </a:extLst>
           </p:cNvPr>
@@ -7048,7 +7048,7 @@
           <p:cNvPr id="4" name="">
             <a:extLst xmlns:a="http://schemas.openxmlformats.org/drawingml/2006/main">
               <a:ext uri="{FF2B5EF4-FFF2-40B4-BE49-F238E27FC236}">
-                <a16:creationId xmlns:a16="http://schemas.microsoft.com/office/drawing/2014/main" id="{C11FAC4F-D6E0-4717-A133-3FCDE4450F13}"/>
+                <a16:creationId xmlns:a16="http://schemas.microsoft.com/office/drawing/2014/main" id="{A8735A5C-C60A-40A5-A31E-5D083F35B2F0}"/>
               </a:ext>
             </a:extLst>
           </p:cNvPr>
@@ -7105,7 +7105,7 @@
           <p:cNvPr id="5" name="">
             <a:extLst xmlns:a="http://schemas.openxmlformats.org/drawingml/2006/main">
               <a:ext uri="{FF2B5EF4-FFF2-40B4-BE49-F238E27FC236}">
-                <a16:creationId xmlns:a16="http://schemas.microsoft.com/office/drawing/2014/main" id="{C4DBF52A-3313-4CEA-B441-58034A11CC21}"/>
+                <a16:creationId xmlns:a16="http://schemas.microsoft.com/office/drawing/2014/main" id="{2E597491-98EB-4308-A574-2BBC8211C919}"/>
               </a:ext>
             </a:extLst>
           </p:cNvPr>
@@ -7139,7 +7139,7 @@
           <p:cNvPr id="6" name="">
             <a:extLst xmlns:a="http://schemas.openxmlformats.org/drawingml/2006/main">
               <a:ext uri="{FF2B5EF4-FFF2-40B4-BE49-F238E27FC236}">
-                <a16:creationId xmlns:a16="http://schemas.microsoft.com/office/drawing/2014/main" id="{42D3CF9E-5177-4CFE-912A-7DC1BBC96C46}"/>
+                <a16:creationId xmlns:a16="http://schemas.microsoft.com/office/drawing/2014/main" id="{1EC2FB80-8041-4CC9-961F-4627EB218EA1}"/>
               </a:ext>
             </a:extLst>
           </p:cNvPr>
@@ -7173,7 +7173,7 @@
           <p:cNvPr id="7" name="">
             <a:extLst xmlns:a="http://schemas.openxmlformats.org/drawingml/2006/main">
               <a:ext uri="{FF2B5EF4-FFF2-40B4-BE49-F238E27FC236}">
-                <a16:creationId xmlns:a16="http://schemas.microsoft.com/office/drawing/2014/main" id="{C0826826-077C-4B3B-ADC9-8D3298B4EAAB}"/>
+                <a16:creationId xmlns:a16="http://schemas.microsoft.com/office/drawing/2014/main" id="{787A6098-7D76-4D12-9057-83540B72AD82}"/>
               </a:ext>
             </a:extLst>
           </p:cNvPr>
@@ -7230,7 +7230,7 @@
           <p:cNvPr id="8" name="">
             <a:extLst xmlns:a="http://schemas.openxmlformats.org/drawingml/2006/main">
               <a:ext uri="{FF2B5EF4-FFF2-40B4-BE49-F238E27FC236}">
-                <a16:creationId xmlns:a16="http://schemas.microsoft.com/office/drawing/2014/main" id="{D06FCF04-3D9B-4A87-9645-5B92293110A7}"/>
+                <a16:creationId xmlns:a16="http://schemas.microsoft.com/office/drawing/2014/main" id="{1F7C3E25-F69F-4D6E-8B38-E843AE838B21}"/>
               </a:ext>
             </a:extLst>
           </p:cNvPr>
@@ -7287,7 +7287,7 @@
           <p:cNvPr id="9" name="">
             <a:extLst xmlns:a="http://schemas.openxmlformats.org/drawingml/2006/main">
               <a:ext uri="{FF2B5EF4-FFF2-40B4-BE49-F238E27FC236}">
-                <a16:creationId xmlns:a16="http://schemas.microsoft.com/office/drawing/2014/main" id="{34709FAE-3DC6-4EC8-9FB9-CE455D28C2D8}"/>
+                <a16:creationId xmlns:a16="http://schemas.microsoft.com/office/drawing/2014/main" id="{CE4F109A-C61E-48A5-B588-833B8FDCCB3F}"/>
               </a:ext>
             </a:extLst>
           </p:cNvPr>
@@ -7321,7 +7321,7 @@
           <p:cNvPr id="10" name="">
             <a:extLst xmlns:a="http://schemas.openxmlformats.org/drawingml/2006/main">
               <a:ext uri="{FF2B5EF4-FFF2-40B4-BE49-F238E27FC236}">
-                <a16:creationId xmlns:a16="http://schemas.microsoft.com/office/drawing/2014/main" id="{6EE2B46D-ABA5-4285-927A-CAB5E3A4C4E0}"/>
+                <a16:creationId xmlns:a16="http://schemas.microsoft.com/office/drawing/2014/main" id="{E2EF0B41-A07E-4F0C-B74A-1698BE25034C}"/>
               </a:ext>
             </a:extLst>
           </p:cNvPr>
@@ -7355,7 +7355,7 @@
           <p:cNvPr id="11" name="">
             <a:extLst xmlns:a="http://schemas.openxmlformats.org/drawingml/2006/main">
               <a:ext uri="{FF2B5EF4-FFF2-40B4-BE49-F238E27FC236}">
-                <a16:creationId xmlns:a16="http://schemas.microsoft.com/office/drawing/2014/main" id="{DF9F0544-0F99-4114-A8B6-D356F4A0CC3F}"/>
+                <a16:creationId xmlns:a16="http://schemas.microsoft.com/office/drawing/2014/main" id="{E194397A-BE23-4613-BB81-BE703595DE21}"/>
               </a:ext>
             </a:extLst>
           </p:cNvPr>
@@ -7412,7 +7412,7 @@
           <p:cNvPr id="12" name="">
             <a:extLst xmlns:a="http://schemas.openxmlformats.org/drawingml/2006/main">
               <a:ext uri="{FF2B5EF4-FFF2-40B4-BE49-F238E27FC236}">
-                <a16:creationId xmlns:a16="http://schemas.microsoft.com/office/drawing/2014/main" id="{9CBB8AD2-1107-457B-A470-0AF632D418A6}"/>
+                <a16:creationId xmlns:a16="http://schemas.microsoft.com/office/drawing/2014/main" id="{88DB0122-15E1-49A6-8A9A-F5065A53A55E}"/>
               </a:ext>
             </a:extLst>
           </p:cNvPr>
@@ -7469,7 +7469,7 @@
           <p:cNvPr id="13" name="">
             <a:extLst xmlns:a="http://schemas.openxmlformats.org/drawingml/2006/main">
               <a:ext uri="{FF2B5EF4-FFF2-40B4-BE49-F238E27FC236}">
-                <a16:creationId xmlns:a16="http://schemas.microsoft.com/office/drawing/2014/main" id="{21AAA933-C594-4941-AD57-4BC27B3F1486}"/>
+                <a16:creationId xmlns:a16="http://schemas.microsoft.com/office/drawing/2014/main" id="{93C16E89-BA98-41E8-A7C8-4B9061CA4078}"/>
               </a:ext>
             </a:extLst>
           </p:cNvPr>
@@ -7526,7 +7526,7 @@
           <p:cNvPr id="14" name="">
             <a:extLst xmlns:a="http://schemas.openxmlformats.org/drawingml/2006/main">
               <a:ext uri="{FF2B5EF4-FFF2-40B4-BE49-F238E27FC236}">
-                <a16:creationId xmlns:a16="http://schemas.microsoft.com/office/drawing/2014/main" id="{3A523B37-14F7-4BF4-84D6-7EBAB6C20874}"/>
+                <a16:creationId xmlns:a16="http://schemas.microsoft.com/office/drawing/2014/main" id="{6A21B7DA-5C11-467C-8876-B526356AF3D1}"/>
               </a:ext>
             </a:extLst>
           </p:cNvPr>
@@ -7560,7 +7560,7 @@
           <p:cNvPr id="15" name="">
             <a:extLst xmlns:a="http://schemas.openxmlformats.org/drawingml/2006/main">
               <a:ext uri="{FF2B5EF4-FFF2-40B4-BE49-F238E27FC236}">
-                <a16:creationId xmlns:a16="http://schemas.microsoft.com/office/drawing/2014/main" id="{0E4A07F3-5D68-4AA2-8919-33365DBF41B0}"/>
+                <a16:creationId xmlns:a16="http://schemas.microsoft.com/office/drawing/2014/main" id="{FCC23476-6363-4D55-8246-EBD82CCA5305}"/>
               </a:ext>
             </a:extLst>
           </p:cNvPr>
@@ -7617,7 +7617,7 @@
           <p:cNvPr id="16" name="">
             <a:extLst xmlns:a="http://schemas.openxmlformats.org/drawingml/2006/main">
               <a:ext uri="{FF2B5EF4-FFF2-40B4-BE49-F238E27FC236}">
-                <a16:creationId xmlns:a16="http://schemas.microsoft.com/office/drawing/2014/main" id="{F5D29219-41F0-4827-AD39-C72A9AA18BBF}"/>
+                <a16:creationId xmlns:a16="http://schemas.microsoft.com/office/drawing/2014/main" id="{80DE8844-B7B9-4C36-97F6-07AF61A34C76}"/>
               </a:ext>
             </a:extLst>
           </p:cNvPr>
@@ -7674,7 +7674,7 @@
           <p:cNvPr id="17" name="">
             <a:extLst xmlns:a="http://schemas.openxmlformats.org/drawingml/2006/main">
               <a:ext uri="{FF2B5EF4-FFF2-40B4-BE49-F238E27FC236}">
-                <a16:creationId xmlns:a16="http://schemas.microsoft.com/office/drawing/2014/main" id="{2ED5D5FE-1D1D-44C2-BC9F-66D3063D61ED}"/>
+                <a16:creationId xmlns:a16="http://schemas.microsoft.com/office/drawing/2014/main" id="{1D02D512-CA61-4E86-93FE-D0D65FD08B41}"/>
               </a:ext>
             </a:extLst>
           </p:cNvPr>
@@ -7708,7 +7708,7 @@
           <p:cNvPr id="18" name="">
             <a:extLst xmlns:a="http://schemas.openxmlformats.org/drawingml/2006/main">
               <a:ext uri="{FF2B5EF4-FFF2-40B4-BE49-F238E27FC236}">
-                <a16:creationId xmlns:a16="http://schemas.microsoft.com/office/drawing/2014/main" id="{E2FE03B8-309A-4B01-BE29-9AB938100688}"/>
+                <a16:creationId xmlns:a16="http://schemas.microsoft.com/office/drawing/2014/main" id="{98C30BD1-5D1D-4D86-9822-9F6729FBC2EB}"/>
               </a:ext>
             </a:extLst>
           </p:cNvPr>
@@ -7765,7 +7765,7 @@
           <p:cNvPr id="19" name="">
             <a:extLst xmlns:a="http://schemas.openxmlformats.org/drawingml/2006/main">
               <a:ext uri="{FF2B5EF4-FFF2-40B4-BE49-F238E27FC236}">
-                <a16:creationId xmlns:a16="http://schemas.microsoft.com/office/drawing/2014/main" id="{ECC0B28B-A13D-4ADC-BAAB-701156CDF18C}"/>
+                <a16:creationId xmlns:a16="http://schemas.microsoft.com/office/drawing/2014/main" id="{A272875B-BF79-449B-9E5D-7B295D12F3E4}"/>
               </a:ext>
             </a:extLst>
           </p:cNvPr>
@@ -7822,7 +7822,7 @@
           <p:cNvPr id="20" name="">
             <a:extLst xmlns:a="http://schemas.openxmlformats.org/drawingml/2006/main">
               <a:ext uri="{FF2B5EF4-FFF2-40B4-BE49-F238E27FC236}">
-                <a16:creationId xmlns:a16="http://schemas.microsoft.com/office/drawing/2014/main" id="{A4869AA4-C852-4E2C-92AF-3C6BDA393C88}"/>
+                <a16:creationId xmlns:a16="http://schemas.microsoft.com/office/drawing/2014/main" id="{0B2A02C0-CA2F-4ACF-80C6-273A391E7BBF}"/>
               </a:ext>
             </a:extLst>
           </p:cNvPr>
@@ -7856,7 +7856,7 @@
           <p:cNvPr id="21" name="">
             <a:extLst xmlns:a="http://schemas.openxmlformats.org/drawingml/2006/main">
               <a:ext uri="{FF2B5EF4-FFF2-40B4-BE49-F238E27FC236}">
-                <a16:creationId xmlns:a16="http://schemas.microsoft.com/office/drawing/2014/main" id="{A553FD53-8DEF-47BD-8541-6E2C3E90778B}"/>
+                <a16:creationId xmlns:a16="http://schemas.microsoft.com/office/drawing/2014/main" id="{D5B7BCF4-F8ED-4C83-884E-62437E08792C}"/>
               </a:ext>
             </a:extLst>
           </p:cNvPr>
@@ -7913,7 +7913,7 @@
           <p:cNvPr id="22" name="">
             <a:extLst xmlns:a="http://schemas.openxmlformats.org/drawingml/2006/main">
               <a:ext uri="{FF2B5EF4-FFF2-40B4-BE49-F238E27FC236}">
-                <a16:creationId xmlns:a16="http://schemas.microsoft.com/office/drawing/2014/main" id="{379B5A8B-DB6E-484F-88B0-0616E8A4DD86}"/>
+                <a16:creationId xmlns:a16="http://schemas.microsoft.com/office/drawing/2014/main" id="{8670789E-2F85-4344-815F-6D968AAA0348}"/>
               </a:ext>
             </a:extLst>
           </p:cNvPr>
@@ -7970,7 +7970,7 @@
           <p:cNvPr id="23" name="">
             <a:extLst xmlns:a="http://schemas.openxmlformats.org/drawingml/2006/main">
               <a:ext uri="{FF2B5EF4-FFF2-40B4-BE49-F238E27FC236}">
-                <a16:creationId xmlns:a16="http://schemas.microsoft.com/office/drawing/2014/main" id="{AC24BF67-50F4-498F-9628-5046D874F1DF}"/>
+                <a16:creationId xmlns:a16="http://schemas.microsoft.com/office/drawing/2014/main" id="{87535F29-76D4-4166-9568-F5D471B8873F}"/>
               </a:ext>
             </a:extLst>
           </p:cNvPr>
@@ -8004,7 +8004,7 @@
           <p:cNvPr id="24" name="">
             <a:extLst xmlns:a="http://schemas.openxmlformats.org/drawingml/2006/main">
               <a:ext uri="{FF2B5EF4-FFF2-40B4-BE49-F238E27FC236}">
-                <a16:creationId xmlns:a16="http://schemas.microsoft.com/office/drawing/2014/main" id="{EE059F3A-4A8C-42D6-93A5-B3865AB4C9E5}"/>
+                <a16:creationId xmlns:a16="http://schemas.microsoft.com/office/drawing/2014/main" id="{2FF16183-8B96-4231-A8EB-53585AE8303F}"/>
               </a:ext>
             </a:extLst>
           </p:cNvPr>
@@ -8061,7 +8061,7 @@
           <p:cNvPr id="25" name="">
             <a:extLst xmlns:a="http://schemas.openxmlformats.org/drawingml/2006/main">
               <a:ext uri="{FF2B5EF4-FFF2-40B4-BE49-F238E27FC236}">
-                <a16:creationId xmlns:a16="http://schemas.microsoft.com/office/drawing/2014/main" id="{AA2394B1-65C6-4782-8998-7F407C0E866C}"/>
+                <a16:creationId xmlns:a16="http://schemas.microsoft.com/office/drawing/2014/main" id="{2D9751BF-F903-49B7-A52A-5601707DCC25}"/>
               </a:ext>
             </a:extLst>
           </p:cNvPr>
@@ -8118,7 +8118,7 @@
           <p:cNvPr id="26" name="">
             <a:extLst xmlns:a="http://schemas.openxmlformats.org/drawingml/2006/main">
               <a:ext uri="{FF2B5EF4-FFF2-40B4-BE49-F238E27FC236}">
-                <a16:creationId xmlns:a16="http://schemas.microsoft.com/office/drawing/2014/main" id="{FE3745CD-6A1D-49A3-8EA7-52E6BB2FCD35}"/>
+                <a16:creationId xmlns:a16="http://schemas.microsoft.com/office/drawing/2014/main" id="{DB7A010A-A1B5-4455-BC07-545B0C2BD0F1}"/>
               </a:ext>
             </a:extLst>
           </p:cNvPr>
@@ -8173,7 +8173,7 @@
     </p:spTree>
     <p:extLst>
       <p:ext uri="{BB962C8B-B14F-4D97-AF65-F5344CB8AC3E}">
-        <p14:creationId xmlns:p14="http://schemas.microsoft.com/office/powerpoint/2010/main" val="830009778"/>
+        <p14:creationId xmlns:p14="http://schemas.microsoft.com/office/powerpoint/2010/main" val="565029424"/>
       </p:ext>
     </p:extLst>
   </p:cSld>
@@ -8204,7 +8204,7 @@
           <p:cNvPr id="18" name="">
             <a:extLst xmlns:a="http://schemas.openxmlformats.org/drawingml/2006/main">
               <a:ext uri="{FF2B5EF4-FFF2-40B4-BE49-F238E27FC236}">
-                <a16:creationId xmlns:a16="http://schemas.microsoft.com/office/drawing/2014/main" id="{4F83E832-0C1B-4680-9A1F-3DC0BC5175FE}"/>
+                <a16:creationId xmlns:a16="http://schemas.microsoft.com/office/drawing/2014/main" id="{80F04FCE-4BAA-4D5E-938B-33C3E38C607F}"/>
               </a:ext>
             </a:extLst>
           </p:cNvPr>
@@ -8261,7 +8261,7 @@
           <p:cNvPr id="2" name="">
             <a:extLst xmlns:a="http://schemas.openxmlformats.org/drawingml/2006/main">
               <a:ext uri="{FF2B5EF4-FFF2-40B4-BE49-F238E27FC236}">
-                <a16:creationId xmlns:a16="http://schemas.microsoft.com/office/drawing/2014/main" id="{9D307027-811F-4EE8-AD5C-40C447503923}"/>
+                <a16:creationId xmlns:a16="http://schemas.microsoft.com/office/drawing/2014/main" id="{3817A53A-B84D-4F3B-8D91-363CB7B64DC0}"/>
               </a:ext>
             </a:extLst>
           </p:cNvPr>
@@ -8318,7 +8318,7 @@
           <p:cNvPr id="3" name="">
             <a:extLst xmlns:a="http://schemas.openxmlformats.org/drawingml/2006/main">
               <a:ext uri="{FF2B5EF4-FFF2-40B4-BE49-F238E27FC236}">
-                <a16:creationId xmlns:a16="http://schemas.microsoft.com/office/drawing/2014/main" id="{D3FCBB77-DB7E-459C-AF6A-09D0CC2E9F64}"/>
+                <a16:creationId xmlns:a16="http://schemas.microsoft.com/office/drawing/2014/main" id="{455E7A2D-8D65-4A3B-8C9E-086A6F305987}"/>
               </a:ext>
             </a:extLst>
           </p:cNvPr>
@@ -8348,7 +8348,7 @@
           <p:cNvPr id="4" name="">
             <a:extLst xmlns:a="http://schemas.openxmlformats.org/drawingml/2006/main">
               <a:ext uri="{FF2B5EF4-FFF2-40B4-BE49-F238E27FC236}">
-                <a16:creationId xmlns:a16="http://schemas.microsoft.com/office/drawing/2014/main" id="{24BC3F2A-0FC1-4E21-B910-97C2BC638D05}"/>
+                <a16:creationId xmlns:a16="http://schemas.microsoft.com/office/drawing/2014/main" id="{A4C2B489-C585-416D-82E6-DB58F0A29862}"/>
               </a:ext>
             </a:extLst>
           </p:cNvPr>
@@ -8405,7 +8405,7 @@
           <p:cNvPr id="5" name="">
             <a:extLst xmlns:a="http://schemas.openxmlformats.org/drawingml/2006/main">
               <a:ext uri="{FF2B5EF4-FFF2-40B4-BE49-F238E27FC236}">
-                <a16:creationId xmlns:a16="http://schemas.microsoft.com/office/drawing/2014/main" id="{095B945D-E5EB-4DC9-8503-E55CEB3F316B}"/>
+                <a16:creationId xmlns:a16="http://schemas.microsoft.com/office/drawing/2014/main" id="{F93AE3E8-2E31-4656-AC28-DFECB480FB67}"/>
               </a:ext>
             </a:extLst>
           </p:cNvPr>
@@ -8462,7 +8462,7 @@
           <p:cNvPr id="6" name="">
             <a:extLst xmlns:a="http://schemas.openxmlformats.org/drawingml/2006/main">
               <a:ext uri="{FF2B5EF4-FFF2-40B4-BE49-F238E27FC236}">
-                <a16:creationId xmlns:a16="http://schemas.microsoft.com/office/drawing/2014/main" id="{9581A382-A491-483E-A8F6-B76C91A54886}"/>
+                <a16:creationId xmlns:a16="http://schemas.microsoft.com/office/drawing/2014/main" id="{D9F2D32E-FE2E-4EB6-875F-3A5C10BE757C}"/>
               </a:ext>
             </a:extLst>
           </p:cNvPr>
@@ -8588,7 +8588,7 @@
           <p:cNvPr id="7" name="">
             <a:extLst xmlns:a="http://schemas.openxmlformats.org/drawingml/2006/main">
               <a:ext uri="{FF2B5EF4-FFF2-40B4-BE49-F238E27FC236}">
-                <a16:creationId xmlns:a16="http://schemas.microsoft.com/office/drawing/2014/main" id="{A83AF12B-1527-48D3-AF87-9C7DBD1BD6FE}"/>
+                <a16:creationId xmlns:a16="http://schemas.microsoft.com/office/drawing/2014/main" id="{534CABC2-C756-49DB-A763-D61ED35D8311}"/>
               </a:ext>
             </a:extLst>
           </p:cNvPr>
@@ -8645,7 +8645,7 @@
           <p:cNvPr id="8" name="">
             <a:extLst xmlns:a="http://schemas.openxmlformats.org/drawingml/2006/main">
               <a:ext uri="{FF2B5EF4-FFF2-40B4-BE49-F238E27FC236}">
-                <a16:creationId xmlns:a16="http://schemas.microsoft.com/office/drawing/2014/main" id="{109F929E-75A0-4889-9409-0600F8D83C52}"/>
+                <a16:creationId xmlns:a16="http://schemas.microsoft.com/office/drawing/2014/main" id="{F0E6293F-EB94-42F2-992C-6AE502ACA28E}"/>
               </a:ext>
             </a:extLst>
           </p:cNvPr>
@@ -8771,7 +8771,7 @@
           <p:cNvPr id="9" name="">
             <a:extLst xmlns:a="http://schemas.openxmlformats.org/drawingml/2006/main">
               <a:ext uri="{FF2B5EF4-FFF2-40B4-BE49-F238E27FC236}">
-                <a16:creationId xmlns:a16="http://schemas.microsoft.com/office/drawing/2014/main" id="{F17AC4C2-8453-4FA0-AE83-EA0562A4C3D9}"/>
+                <a16:creationId xmlns:a16="http://schemas.microsoft.com/office/drawing/2014/main" id="{00163701-1F12-4106-A8B6-4A4035FAA331}"/>
               </a:ext>
             </a:extLst>
           </p:cNvPr>
@@ -8805,7 +8805,7 @@
           <p:cNvPr id="10" name="">
             <a:extLst xmlns:a="http://schemas.openxmlformats.org/drawingml/2006/main">
               <a:ext uri="{FF2B5EF4-FFF2-40B4-BE49-F238E27FC236}">
-                <a16:creationId xmlns:a16="http://schemas.microsoft.com/office/drawing/2014/main" id="{D34CAD82-17A7-48FA-8D7A-EDBC561DE5BE}"/>
+                <a16:creationId xmlns:a16="http://schemas.microsoft.com/office/drawing/2014/main" id="{B063FC0D-1118-4FC9-9AD4-3ACDAE83168C}"/>
               </a:ext>
             </a:extLst>
           </p:cNvPr>
@@ -8839,7 +8839,7 @@
           <p:cNvPr id="11" name="">
             <a:extLst xmlns:a="http://schemas.openxmlformats.org/drawingml/2006/main">
               <a:ext uri="{FF2B5EF4-FFF2-40B4-BE49-F238E27FC236}">
-                <a16:creationId xmlns:a16="http://schemas.microsoft.com/office/drawing/2014/main" id="{7DA1BC06-99B2-418F-83E5-954BD1FF1937}"/>
+                <a16:creationId xmlns:a16="http://schemas.microsoft.com/office/drawing/2014/main" id="{A274FBAF-5EFF-4EA6-B93C-2E3BF096C977}"/>
               </a:ext>
             </a:extLst>
           </p:cNvPr>
@@ -8896,7 +8896,7 @@
           <p:cNvPr id="12" name="">
             <a:extLst xmlns:a="http://schemas.openxmlformats.org/drawingml/2006/main">
               <a:ext uri="{FF2B5EF4-FFF2-40B4-BE49-F238E27FC236}">
-                <a16:creationId xmlns:a16="http://schemas.microsoft.com/office/drawing/2014/main" id="{C90B69DE-AE94-43FE-9CD7-3F46610F17C9}"/>
+                <a16:creationId xmlns:a16="http://schemas.microsoft.com/office/drawing/2014/main" id="{3C7B97DE-10C6-4161-87B5-75C6F1734E18}"/>
               </a:ext>
             </a:extLst>
           </p:cNvPr>
@@ -9035,7 +9035,7 @@
                 <a:ea typeface="Apple SD Gothic Neo"/>
                 <a:cs typeface="Apple SD Gothic Neo"/>
               </a:rPr>
-              <a:t>soak 517.063초</a:t>
+              <a:t>soak 1,123.638초</a:t>
             </a:r>
           </a:p>
         </p:txBody>
@@ -9045,7 +9045,7 @@
           <p:cNvPr id="13" name="">
             <a:extLst xmlns:a="http://schemas.openxmlformats.org/drawingml/2006/main">
               <a:ext uri="{FF2B5EF4-FFF2-40B4-BE49-F238E27FC236}">
-                <a16:creationId xmlns:a16="http://schemas.microsoft.com/office/drawing/2014/main" id="{2B343A03-7368-4510-A6D5-7A4E9F90542D}"/>
+                <a16:creationId xmlns:a16="http://schemas.microsoft.com/office/drawing/2014/main" id="{A797C025-9214-45F4-AC62-CE863E27DE98}"/>
               </a:ext>
             </a:extLst>
           </p:cNvPr>
@@ -9079,7 +9079,7 @@
           <p:cNvPr id="14" name="">
             <a:extLst xmlns:a="http://schemas.openxmlformats.org/drawingml/2006/main">
               <a:ext uri="{FF2B5EF4-FFF2-40B4-BE49-F238E27FC236}">
-                <a16:creationId xmlns:a16="http://schemas.microsoft.com/office/drawing/2014/main" id="{97DDDA98-1522-4483-AF43-057CA8125652}"/>
+                <a16:creationId xmlns:a16="http://schemas.microsoft.com/office/drawing/2014/main" id="{7C97285D-88C6-467C-BCF2-C181AB3D5DB5}"/>
               </a:ext>
             </a:extLst>
           </p:cNvPr>
@@ -9113,7 +9113,7 @@
           <p:cNvPr id="15" name="">
             <a:extLst xmlns:a="http://schemas.openxmlformats.org/drawingml/2006/main">
               <a:ext uri="{FF2B5EF4-FFF2-40B4-BE49-F238E27FC236}">
-                <a16:creationId xmlns:a16="http://schemas.microsoft.com/office/drawing/2014/main" id="{BAC4B959-F08B-4BE7-BE26-D28854450E44}"/>
+                <a16:creationId xmlns:a16="http://schemas.microsoft.com/office/drawing/2014/main" id="{2AA9EE78-87D9-42AA-ACA9-A315E0D6909A}"/>
               </a:ext>
             </a:extLst>
           </p:cNvPr>
@@ -9170,7 +9170,7 @@
           <p:cNvPr id="16" name="">
             <a:extLst xmlns:a="http://schemas.openxmlformats.org/drawingml/2006/main">
               <a:ext uri="{FF2B5EF4-FFF2-40B4-BE49-F238E27FC236}">
-                <a16:creationId xmlns:a16="http://schemas.microsoft.com/office/drawing/2014/main" id="{271FF04A-034D-423C-9D1C-B108AD218082}"/>
+                <a16:creationId xmlns:a16="http://schemas.microsoft.com/office/drawing/2014/main" id="{3BE3EBB6-0AD9-48DF-B7C2-79DE48C20211}"/>
               </a:ext>
             </a:extLst>
           </p:cNvPr>
@@ -9296,7 +9296,7 @@
           <p:cNvPr id="17" name="">
             <a:extLst xmlns:a="http://schemas.openxmlformats.org/drawingml/2006/main">
               <a:ext uri="{FF2B5EF4-FFF2-40B4-BE49-F238E27FC236}">
-                <a16:creationId xmlns:a16="http://schemas.microsoft.com/office/drawing/2014/main" id="{381F71CF-C7A4-45D9-BD03-41E56DA03B69}"/>
+                <a16:creationId xmlns:a16="http://schemas.microsoft.com/office/drawing/2014/main" id="{005CA2FF-C47E-409F-AE1D-92B796D67668}"/>
               </a:ext>
             </a:extLst>
           </p:cNvPr>
@@ -9351,7 +9351,7 @@
     </p:spTree>
     <p:extLst>
       <p:ext uri="{BB962C8B-B14F-4D97-AF65-F5344CB8AC3E}">
-        <p14:creationId xmlns:p14="http://schemas.microsoft.com/office/powerpoint/2010/main" val="2081761271"/>
+        <p14:creationId xmlns:p14="http://schemas.microsoft.com/office/powerpoint/2010/main" val="1286347014"/>
       </p:ext>
     </p:extLst>
   </p:cSld>
@@ -9382,7 +9382,7 @@
           <p:cNvPr id="16" name="">
             <a:extLst xmlns:a="http://schemas.openxmlformats.org/drawingml/2006/main">
               <a:ext uri="{FF2B5EF4-FFF2-40B4-BE49-F238E27FC236}">
-                <a16:creationId xmlns:a16="http://schemas.microsoft.com/office/drawing/2014/main" id="{41311DD9-BA85-46C8-8398-8A3A6DABA9CF}"/>
+                <a16:creationId xmlns:a16="http://schemas.microsoft.com/office/drawing/2014/main" id="{3D859262-E4C1-452E-A830-942FB5C9CC88}"/>
               </a:ext>
             </a:extLst>
           </p:cNvPr>
@@ -9439,7 +9439,7 @@
           <p:cNvPr id="2" name="">
             <a:extLst xmlns:a="http://schemas.openxmlformats.org/drawingml/2006/main">
               <a:ext uri="{FF2B5EF4-FFF2-40B4-BE49-F238E27FC236}">
-                <a16:creationId xmlns:a16="http://schemas.microsoft.com/office/drawing/2014/main" id="{60BAAC59-77D5-4C6C-B13E-34E9E194D5CA}"/>
+                <a16:creationId xmlns:a16="http://schemas.microsoft.com/office/drawing/2014/main" id="{DBCE9958-C290-4BF9-A9C0-2090FC3DDBB8}"/>
               </a:ext>
             </a:extLst>
           </p:cNvPr>
@@ -9496,7 +9496,7 @@
           <p:cNvPr id="3" name="">
             <a:extLst xmlns:a="http://schemas.openxmlformats.org/drawingml/2006/main">
               <a:ext uri="{FF2B5EF4-FFF2-40B4-BE49-F238E27FC236}">
-                <a16:creationId xmlns:a16="http://schemas.microsoft.com/office/drawing/2014/main" id="{CC608B54-42A4-424B-A452-F36D4F426B92}"/>
+                <a16:creationId xmlns:a16="http://schemas.microsoft.com/office/drawing/2014/main" id="{539886A8-3A34-41BE-944C-7308EF12534F}"/>
               </a:ext>
             </a:extLst>
           </p:cNvPr>
@@ -9526,7 +9526,7 @@
           <p:cNvPr id="4" name="">
             <a:extLst xmlns:a="http://schemas.openxmlformats.org/drawingml/2006/main">
               <a:ext uri="{FF2B5EF4-FFF2-40B4-BE49-F238E27FC236}">
-                <a16:creationId xmlns:a16="http://schemas.microsoft.com/office/drawing/2014/main" id="{322EEF95-9AD4-4141-AE7B-869925F1F255}"/>
+                <a16:creationId xmlns:a16="http://schemas.microsoft.com/office/drawing/2014/main" id="{B96C5E49-3436-449E-94E3-B97D93E2312C}"/>
               </a:ext>
             </a:extLst>
           </p:cNvPr>
@@ -9583,7 +9583,7 @@
           <p:cNvPr id="5" name="">
             <a:extLst xmlns:a="http://schemas.openxmlformats.org/drawingml/2006/main">
               <a:ext uri="{FF2B5EF4-FFF2-40B4-BE49-F238E27FC236}">
-                <a16:creationId xmlns:a16="http://schemas.microsoft.com/office/drawing/2014/main" id="{755447AB-F1D7-4707-955D-C734D4FC963A}"/>
+                <a16:creationId xmlns:a16="http://schemas.microsoft.com/office/drawing/2014/main" id="{8C75AF34-0DCA-45DE-86C5-C071379A36A4}"/>
               </a:ext>
             </a:extLst>
           </p:cNvPr>
@@ -9640,7 +9640,7 @@
           <p:cNvPr id="6" name="">
             <a:extLst xmlns:a="http://schemas.openxmlformats.org/drawingml/2006/main">
               <a:ext uri="{FF2B5EF4-FFF2-40B4-BE49-F238E27FC236}">
-                <a16:creationId xmlns:a16="http://schemas.microsoft.com/office/drawing/2014/main" id="{7D0692B6-3AAA-4B80-A248-4D57E71B399F}"/>
+                <a16:creationId xmlns:a16="http://schemas.microsoft.com/office/drawing/2014/main" id="{A69E6BEA-3C10-4F1C-A42E-E623E9FF3416}"/>
               </a:ext>
             </a:extLst>
           </p:cNvPr>
@@ -9674,7 +9674,7 @@
           <p:cNvPr id="7" name="">
             <a:extLst xmlns:a="http://schemas.openxmlformats.org/drawingml/2006/main">
               <a:ext uri="{FF2B5EF4-FFF2-40B4-BE49-F238E27FC236}">
-                <a16:creationId xmlns:a16="http://schemas.microsoft.com/office/drawing/2014/main" id="{43BAABDC-6FCC-4125-9EBE-25EADB0EBFD4}"/>
+                <a16:creationId xmlns:a16="http://schemas.microsoft.com/office/drawing/2014/main" id="{00AA7CB2-3D5A-4F1A-ABAC-BBFFAB509D34}"/>
               </a:ext>
             </a:extLst>
           </p:cNvPr>
@@ -9708,7 +9708,7 @@
           <p:cNvPr id="8" name="">
             <a:extLst xmlns:a="http://schemas.openxmlformats.org/drawingml/2006/main">
               <a:ext uri="{FF2B5EF4-FFF2-40B4-BE49-F238E27FC236}">
-                <a16:creationId xmlns:a16="http://schemas.microsoft.com/office/drawing/2014/main" id="{464AC3D7-6E13-445A-8EF0-AA293319D059}"/>
+                <a16:creationId xmlns:a16="http://schemas.microsoft.com/office/drawing/2014/main" id="{819291F0-A063-4243-8843-7AF475107373}"/>
               </a:ext>
             </a:extLst>
           </p:cNvPr>
@@ -9765,7 +9765,7 @@
           <p:cNvPr id="9" name="">
             <a:extLst xmlns:a="http://schemas.openxmlformats.org/drawingml/2006/main">
               <a:ext uri="{FF2B5EF4-FFF2-40B4-BE49-F238E27FC236}">
-                <a16:creationId xmlns:a16="http://schemas.microsoft.com/office/drawing/2014/main" id="{C47B6880-BE63-4D63-9D51-869A05172057}"/>
+                <a16:creationId xmlns:a16="http://schemas.microsoft.com/office/drawing/2014/main" id="{A1292A99-DABC-4B3E-B2C6-FEA45AE54CAB}"/>
               </a:ext>
             </a:extLst>
           </p:cNvPr>
@@ -9822,7 +9822,7 @@
           <p:cNvPr id="10" name="">
             <a:extLst xmlns:a="http://schemas.openxmlformats.org/drawingml/2006/main">
               <a:ext uri="{FF2B5EF4-FFF2-40B4-BE49-F238E27FC236}">
-                <a16:creationId xmlns:a16="http://schemas.microsoft.com/office/drawing/2014/main" id="{651362DB-95C4-4941-9F1A-6B35DFDD0584}"/>
+                <a16:creationId xmlns:a16="http://schemas.microsoft.com/office/drawing/2014/main" id="{CFCD5686-26A3-4C8D-982A-432988104A04}"/>
               </a:ext>
             </a:extLst>
           </p:cNvPr>
@@ -9856,7 +9856,7 @@
           <p:cNvPr id="11" name="">
             <a:extLst xmlns:a="http://schemas.openxmlformats.org/drawingml/2006/main">
               <a:ext uri="{FF2B5EF4-FFF2-40B4-BE49-F238E27FC236}">
-                <a16:creationId xmlns:a16="http://schemas.microsoft.com/office/drawing/2014/main" id="{B70A5DE2-CFEA-4953-A7D6-5ADD46F319CE}"/>
+                <a16:creationId xmlns:a16="http://schemas.microsoft.com/office/drawing/2014/main" id="{AF66C1D9-E27E-4D4A-A554-5BC96BB05900}"/>
               </a:ext>
             </a:extLst>
           </p:cNvPr>
@@ -9890,7 +9890,7 @@
           <p:cNvPr id="12" name="">
             <a:extLst xmlns:a="http://schemas.openxmlformats.org/drawingml/2006/main">
               <a:ext uri="{FF2B5EF4-FFF2-40B4-BE49-F238E27FC236}">
-                <a16:creationId xmlns:a16="http://schemas.microsoft.com/office/drawing/2014/main" id="{136550C9-9956-44AA-9057-F1F18505DB37}"/>
+                <a16:creationId xmlns:a16="http://schemas.microsoft.com/office/drawing/2014/main" id="{6CEC2199-0455-4DEA-B1AE-B612BAC6FCC1}"/>
               </a:ext>
             </a:extLst>
           </p:cNvPr>
@@ -9947,7 +9947,7 @@
           <p:cNvPr id="13" name="">
             <a:extLst xmlns:a="http://schemas.openxmlformats.org/drawingml/2006/main">
               <a:ext uri="{FF2B5EF4-FFF2-40B4-BE49-F238E27FC236}">
-                <a16:creationId xmlns:a16="http://schemas.microsoft.com/office/drawing/2014/main" id="{74DC16DF-C025-4A55-AC63-3E504711FCF1}"/>
+                <a16:creationId xmlns:a16="http://schemas.microsoft.com/office/drawing/2014/main" id="{C77A90CF-0981-4118-9682-D355A802AA05}"/>
               </a:ext>
             </a:extLst>
           </p:cNvPr>
@@ -10011,7 +10011,7 @@
         </p:xfrm>
         <a:graphic xmlns:a="http://schemas.openxmlformats.org/drawingml/2006/main">
           <a:graphicData uri="http://schemas.openxmlformats.org/drawingml/2006/chart">
-            <c:chart xmlns:r="http://schemas.openxmlformats.org/officeDocument/2006/relationships" xmlns:c="http://schemas.openxmlformats.org/drawingml/2006/chart" r:id="R493e8ab8ef0e4bed"/>
+            <c:chart xmlns:r="http://schemas.openxmlformats.org/officeDocument/2006/relationships" xmlns:c="http://schemas.openxmlformats.org/drawingml/2006/chart" r:id="R247bf12933d3476f"/>
           </a:graphicData>
         </a:graphic>
       </p:graphicFrame>
@@ -10020,7 +10020,7 @@
           <p:cNvPr id="15" name="">
             <a:extLst xmlns:a="http://schemas.openxmlformats.org/drawingml/2006/main">
               <a:ext uri="{FF2B5EF4-FFF2-40B4-BE49-F238E27FC236}">
-                <a16:creationId xmlns:a16="http://schemas.microsoft.com/office/drawing/2014/main" id="{AE22871F-E6FB-46A6-AB5E-F3059FDD1412}"/>
+                <a16:creationId xmlns:a16="http://schemas.microsoft.com/office/drawing/2014/main" id="{1033A7A2-F918-4E85-A86D-8EB446BD1CB8}"/>
               </a:ext>
             </a:extLst>
           </p:cNvPr>
@@ -10075,7 +10075,7 @@
     </p:spTree>
     <p:extLst>
       <p:ext uri="{BB962C8B-B14F-4D97-AF65-F5344CB8AC3E}">
-        <p14:creationId xmlns:p14="http://schemas.microsoft.com/office/powerpoint/2010/main" val="1441131694"/>
+        <p14:creationId xmlns:p14="http://schemas.microsoft.com/office/powerpoint/2010/main" val="1382175975"/>
       </p:ext>
     </p:extLst>
   </p:cSld>
@@ -10106,7 +10106,7 @@
           <p:cNvPr id="26" name="">
             <a:extLst xmlns:a="http://schemas.openxmlformats.org/drawingml/2006/main">
               <a:ext uri="{FF2B5EF4-FFF2-40B4-BE49-F238E27FC236}">
-                <a16:creationId xmlns:a16="http://schemas.microsoft.com/office/drawing/2014/main" id="{D5F13518-014C-4EA4-8095-D7E515756074}"/>
+                <a16:creationId xmlns:a16="http://schemas.microsoft.com/office/drawing/2014/main" id="{924F35C2-902F-4E94-8C46-B70C1D592134}"/>
               </a:ext>
             </a:extLst>
           </p:cNvPr>
@@ -10163,7 +10163,7 @@
           <p:cNvPr id="2" name="">
             <a:extLst xmlns:a="http://schemas.openxmlformats.org/drawingml/2006/main">
               <a:ext uri="{FF2B5EF4-FFF2-40B4-BE49-F238E27FC236}">
-                <a16:creationId xmlns:a16="http://schemas.microsoft.com/office/drawing/2014/main" id="{ECF95963-F214-4019-B8CF-7C34BF538AC4}"/>
+                <a16:creationId xmlns:a16="http://schemas.microsoft.com/office/drawing/2014/main" id="{C27D6AF8-3FA7-407A-B53B-B34ECD4C8768}"/>
               </a:ext>
             </a:extLst>
           </p:cNvPr>
@@ -10220,7 +10220,7 @@
           <p:cNvPr id="3" name="">
             <a:extLst xmlns:a="http://schemas.openxmlformats.org/drawingml/2006/main">
               <a:ext uri="{FF2B5EF4-FFF2-40B4-BE49-F238E27FC236}">
-                <a16:creationId xmlns:a16="http://schemas.microsoft.com/office/drawing/2014/main" id="{AF6E8BE0-C95E-4C85-B73F-88A927E17BA4}"/>
+                <a16:creationId xmlns:a16="http://schemas.microsoft.com/office/drawing/2014/main" id="{D0F7F7F1-CF5C-494F-827D-01A606110949}"/>
               </a:ext>
             </a:extLst>
           </p:cNvPr>
@@ -10250,7 +10250,7 @@
           <p:cNvPr id="4" name="">
             <a:extLst xmlns:a="http://schemas.openxmlformats.org/drawingml/2006/main">
               <a:ext uri="{FF2B5EF4-FFF2-40B4-BE49-F238E27FC236}">
-                <a16:creationId xmlns:a16="http://schemas.microsoft.com/office/drawing/2014/main" id="{EAA769AD-F927-4055-B5C5-826697D3A406}"/>
+                <a16:creationId xmlns:a16="http://schemas.microsoft.com/office/drawing/2014/main" id="{82731FE5-45A1-410A-9D45-1995AFFD157E}"/>
               </a:ext>
             </a:extLst>
           </p:cNvPr>
@@ -10307,7 +10307,7 @@
           <p:cNvPr id="5" name="">
             <a:extLst xmlns:a="http://schemas.openxmlformats.org/drawingml/2006/main">
               <a:ext uri="{FF2B5EF4-FFF2-40B4-BE49-F238E27FC236}">
-                <a16:creationId xmlns:a16="http://schemas.microsoft.com/office/drawing/2014/main" id="{0686595F-1F4A-40D6-B7A9-3E3120AAE7D7}"/>
+                <a16:creationId xmlns:a16="http://schemas.microsoft.com/office/drawing/2014/main" id="{F5B2E718-5625-46C1-866E-55277F40CBCA}"/>
               </a:ext>
             </a:extLst>
           </p:cNvPr>
@@ -10364,7 +10364,7 @@
           <p:cNvPr id="6" name="">
             <a:extLst xmlns:a="http://schemas.openxmlformats.org/drawingml/2006/main">
               <a:ext uri="{FF2B5EF4-FFF2-40B4-BE49-F238E27FC236}">
-                <a16:creationId xmlns:a16="http://schemas.microsoft.com/office/drawing/2014/main" id="{C24FC833-A813-4055-A9E4-5F64D57E8246}"/>
+                <a16:creationId xmlns:a16="http://schemas.microsoft.com/office/drawing/2014/main" id="{7B16B295-A959-49E9-BB0C-5E03CA381E1A}"/>
               </a:ext>
             </a:extLst>
           </p:cNvPr>
@@ -10421,7 +10421,7 @@
           <p:cNvPr id="7" name="">
             <a:extLst xmlns:a="http://schemas.openxmlformats.org/drawingml/2006/main">
               <a:ext uri="{FF2B5EF4-FFF2-40B4-BE49-F238E27FC236}">
-                <a16:creationId xmlns:a16="http://schemas.microsoft.com/office/drawing/2014/main" id="{B328119C-65DE-48BE-91A3-D7CA2016F459}"/>
+                <a16:creationId xmlns:a16="http://schemas.microsoft.com/office/drawing/2014/main" id="{A99EECF7-73F4-436A-B9AD-7C9F7E119183}"/>
               </a:ext>
             </a:extLst>
           </p:cNvPr>
@@ -10478,7 +10478,7 @@
           <p:cNvPr id="8" name="">
             <a:extLst xmlns:a="http://schemas.openxmlformats.org/drawingml/2006/main">
               <a:ext uri="{FF2B5EF4-FFF2-40B4-BE49-F238E27FC236}">
-                <a16:creationId xmlns:a16="http://schemas.microsoft.com/office/drawing/2014/main" id="{EFD2297C-4E44-4A0E-ACAA-30F9A4CC6590}"/>
+                <a16:creationId xmlns:a16="http://schemas.microsoft.com/office/drawing/2014/main" id="{ECD1BD1B-C5DB-45F1-A5E4-0279B331B812}"/>
               </a:ext>
             </a:extLst>
           </p:cNvPr>
@@ -10535,7 +10535,7 @@
           <p:cNvPr id="9" name="">
             <a:extLst xmlns:a="http://schemas.openxmlformats.org/drawingml/2006/main">
               <a:ext uri="{FF2B5EF4-FFF2-40B4-BE49-F238E27FC236}">
-                <a16:creationId xmlns:a16="http://schemas.microsoft.com/office/drawing/2014/main" id="{D7246B19-FA2C-479A-B5B0-8C6EE2E01D62}"/>
+                <a16:creationId xmlns:a16="http://schemas.microsoft.com/office/drawing/2014/main" id="{B00142F6-0C0C-4ACC-B91D-17AF2FDEB281}"/>
               </a:ext>
             </a:extLst>
           </p:cNvPr>
@@ -10592,7 +10592,7 @@
           <p:cNvPr id="10" name="">
             <a:extLst xmlns:a="http://schemas.openxmlformats.org/drawingml/2006/main">
               <a:ext uri="{FF2B5EF4-FFF2-40B4-BE49-F238E27FC236}">
-                <a16:creationId xmlns:a16="http://schemas.microsoft.com/office/drawing/2014/main" id="{F30F80EB-AEC7-46EE-9FE5-D409A884785B}"/>
+                <a16:creationId xmlns:a16="http://schemas.microsoft.com/office/drawing/2014/main" id="{307A4409-FD21-4897-8166-1F264D7736AB}"/>
               </a:ext>
             </a:extLst>
           </p:cNvPr>
@@ -10649,7 +10649,7 @@
           <p:cNvPr id="11" name="">
             <a:extLst xmlns:a="http://schemas.openxmlformats.org/drawingml/2006/main">
               <a:ext uri="{FF2B5EF4-FFF2-40B4-BE49-F238E27FC236}">
-                <a16:creationId xmlns:a16="http://schemas.microsoft.com/office/drawing/2014/main" id="{548CBB51-54A6-4622-AD08-079FCB3A28C5}"/>
+                <a16:creationId xmlns:a16="http://schemas.microsoft.com/office/drawing/2014/main" id="{D0A5DEB7-1A93-4C9B-ADE4-5BDDC0EF803B}"/>
               </a:ext>
             </a:extLst>
           </p:cNvPr>
@@ -10706,7 +10706,7 @@
           <p:cNvPr id="12" name="">
             <a:extLst xmlns:a="http://schemas.openxmlformats.org/drawingml/2006/main">
               <a:ext uri="{FF2B5EF4-FFF2-40B4-BE49-F238E27FC236}">
-                <a16:creationId xmlns:a16="http://schemas.microsoft.com/office/drawing/2014/main" id="{A0B9D873-41E7-4917-A98E-ABE3063032A0}"/>
+                <a16:creationId xmlns:a16="http://schemas.microsoft.com/office/drawing/2014/main" id="{8347CFFE-AED9-4383-B430-E11BC14AA448}"/>
               </a:ext>
             </a:extLst>
           </p:cNvPr>
@@ -10763,7 +10763,7 @@
           <p:cNvPr id="13" name="">
             <a:extLst xmlns:a="http://schemas.openxmlformats.org/drawingml/2006/main">
               <a:ext uri="{FF2B5EF4-FFF2-40B4-BE49-F238E27FC236}">
-                <a16:creationId xmlns:a16="http://schemas.microsoft.com/office/drawing/2014/main" id="{48E16E78-C8DE-4A31-A07E-39D1E90822D6}"/>
+                <a16:creationId xmlns:a16="http://schemas.microsoft.com/office/drawing/2014/main" id="{B8F1EA3E-58B9-48FA-9AA4-0ACFCEFB073B}"/>
               </a:ext>
             </a:extLst>
           </p:cNvPr>
@@ -10793,7 +10793,7 @@
           <p:cNvPr id="14" name="">
             <a:extLst xmlns:a="http://schemas.openxmlformats.org/drawingml/2006/main">
               <a:ext uri="{FF2B5EF4-FFF2-40B4-BE49-F238E27FC236}">
-                <a16:creationId xmlns:a16="http://schemas.microsoft.com/office/drawing/2014/main" id="{F25FB695-A9F9-46C9-A076-F041497C72AC}"/>
+                <a16:creationId xmlns:a16="http://schemas.microsoft.com/office/drawing/2014/main" id="{928956AA-635F-4559-9C79-860A7AF3E5AD}"/>
               </a:ext>
             </a:extLst>
           </p:cNvPr>
@@ -10827,7 +10827,7 @@
           <p:cNvPr id="15" name="">
             <a:extLst xmlns:a="http://schemas.openxmlformats.org/drawingml/2006/main">
               <a:ext uri="{FF2B5EF4-FFF2-40B4-BE49-F238E27FC236}">
-                <a16:creationId xmlns:a16="http://schemas.microsoft.com/office/drawing/2014/main" id="{BB297621-1C7C-43A7-9703-E44BB5279333}"/>
+                <a16:creationId xmlns:a16="http://schemas.microsoft.com/office/drawing/2014/main" id="{D2429B42-1FEE-4D5D-82F6-EBA8D22CA9E7}"/>
               </a:ext>
             </a:extLst>
           </p:cNvPr>
@@ -10861,7 +10861,7 @@
           <p:cNvPr id="16" name="">
             <a:extLst xmlns:a="http://schemas.openxmlformats.org/drawingml/2006/main">
               <a:ext uri="{FF2B5EF4-FFF2-40B4-BE49-F238E27FC236}">
-                <a16:creationId xmlns:a16="http://schemas.microsoft.com/office/drawing/2014/main" id="{F8774AE9-0377-4EDB-920C-8AF90DD6A226}"/>
+                <a16:creationId xmlns:a16="http://schemas.microsoft.com/office/drawing/2014/main" id="{5F33DBDC-26BB-49CB-BCE6-2E160D9482CA}"/>
               </a:ext>
             </a:extLst>
           </p:cNvPr>
@@ -10918,7 +10918,7 @@
           <p:cNvPr id="17" name="">
             <a:extLst xmlns:a="http://schemas.openxmlformats.org/drawingml/2006/main">
               <a:ext uri="{FF2B5EF4-FFF2-40B4-BE49-F238E27FC236}">
-                <a16:creationId xmlns:a16="http://schemas.microsoft.com/office/drawing/2014/main" id="{895C5F5B-6B01-485F-B621-18C16E11E04A}"/>
+                <a16:creationId xmlns:a16="http://schemas.microsoft.com/office/drawing/2014/main" id="{3BE60972-DA26-41F8-B3BF-8B8D99DED6AC}"/>
               </a:ext>
             </a:extLst>
           </p:cNvPr>
@@ -10975,7 +10975,7 @@
           <p:cNvPr id="18" name="">
             <a:extLst xmlns:a="http://schemas.openxmlformats.org/drawingml/2006/main">
               <a:ext uri="{FF2B5EF4-FFF2-40B4-BE49-F238E27FC236}">
-                <a16:creationId xmlns:a16="http://schemas.microsoft.com/office/drawing/2014/main" id="{DCDFFFBD-4D68-48A6-9A68-A3B55FA55A40}"/>
+                <a16:creationId xmlns:a16="http://schemas.microsoft.com/office/drawing/2014/main" id="{CDCDB82E-6056-4BBB-B3D3-6BC4515208B3}"/>
               </a:ext>
             </a:extLst>
           </p:cNvPr>
@@ -11009,7 +11009,7 @@
           <p:cNvPr id="19" name="">
             <a:extLst xmlns:a="http://schemas.openxmlformats.org/drawingml/2006/main">
               <a:ext uri="{FF2B5EF4-FFF2-40B4-BE49-F238E27FC236}">
-                <a16:creationId xmlns:a16="http://schemas.microsoft.com/office/drawing/2014/main" id="{7E4DDF84-66D7-40A4-BA2E-3527956FCF42}"/>
+                <a16:creationId xmlns:a16="http://schemas.microsoft.com/office/drawing/2014/main" id="{E1FA384B-B92F-4E4A-8395-E41538EAE97E}"/>
               </a:ext>
             </a:extLst>
           </p:cNvPr>
@@ -11043,7 +11043,7 @@
           <p:cNvPr id="20" name="">
             <a:extLst xmlns:a="http://schemas.openxmlformats.org/drawingml/2006/main">
               <a:ext uri="{FF2B5EF4-FFF2-40B4-BE49-F238E27FC236}">
-                <a16:creationId xmlns:a16="http://schemas.microsoft.com/office/drawing/2014/main" id="{1B7A7666-815F-4EDD-BBF0-AC518448A7EA}"/>
+                <a16:creationId xmlns:a16="http://schemas.microsoft.com/office/drawing/2014/main" id="{A94B8BDE-898A-4838-8C42-694C2818FB2E}"/>
               </a:ext>
             </a:extLst>
           </p:cNvPr>
@@ -11100,7 +11100,7 @@
           <p:cNvPr id="21" name="">
             <a:extLst xmlns:a="http://schemas.openxmlformats.org/drawingml/2006/main">
               <a:ext uri="{FF2B5EF4-FFF2-40B4-BE49-F238E27FC236}">
-                <a16:creationId xmlns:a16="http://schemas.microsoft.com/office/drawing/2014/main" id="{6D5BA5BD-8A08-4379-940A-9BCBD4AA44AF}"/>
+                <a16:creationId xmlns:a16="http://schemas.microsoft.com/office/drawing/2014/main" id="{0938864C-521C-4CD4-9D4D-0BE908336412}"/>
               </a:ext>
             </a:extLst>
           </p:cNvPr>
@@ -11157,7 +11157,7 @@
           <p:cNvPr id="22" name="">
             <a:extLst xmlns:a="http://schemas.openxmlformats.org/drawingml/2006/main">
               <a:ext uri="{FF2B5EF4-FFF2-40B4-BE49-F238E27FC236}">
-                <a16:creationId xmlns:a16="http://schemas.microsoft.com/office/drawing/2014/main" id="{0BD2A8FB-983A-4565-9A64-C64C0F7A3F97}"/>
+                <a16:creationId xmlns:a16="http://schemas.microsoft.com/office/drawing/2014/main" id="{2F845C9D-1D2A-4EDE-B31E-B27B33B443F8}"/>
               </a:ext>
             </a:extLst>
           </p:cNvPr>
@@ -11191,7 +11191,7 @@
           <p:cNvPr id="23" name="">
             <a:extLst xmlns:a="http://schemas.openxmlformats.org/drawingml/2006/main">
               <a:ext uri="{FF2B5EF4-FFF2-40B4-BE49-F238E27FC236}">
-                <a16:creationId xmlns:a16="http://schemas.microsoft.com/office/drawing/2014/main" id="{1F0A0A76-8405-4749-8E54-649E4B31B11E}"/>
+                <a16:creationId xmlns:a16="http://schemas.microsoft.com/office/drawing/2014/main" id="{F2AC8C32-E0B0-42E1-9CD7-DC7548F03584}"/>
               </a:ext>
             </a:extLst>
           </p:cNvPr>
@@ -11225,7 +11225,7 @@
           <p:cNvPr id="24" name="">
             <a:extLst xmlns:a="http://schemas.openxmlformats.org/drawingml/2006/main">
               <a:ext uri="{FF2B5EF4-FFF2-40B4-BE49-F238E27FC236}">
-                <a16:creationId xmlns:a16="http://schemas.microsoft.com/office/drawing/2014/main" id="{12B190AA-924D-4748-87B3-CE2152253FC2}"/>
+                <a16:creationId xmlns:a16="http://schemas.microsoft.com/office/drawing/2014/main" id="{7B9EDCF7-C59A-492E-8F66-14D17B2F8640}"/>
               </a:ext>
             </a:extLst>
           </p:cNvPr>
@@ -11282,7 +11282,7 @@
           <p:cNvPr id="25" name="">
             <a:extLst xmlns:a="http://schemas.openxmlformats.org/drawingml/2006/main">
               <a:ext uri="{FF2B5EF4-FFF2-40B4-BE49-F238E27FC236}">
-                <a16:creationId xmlns:a16="http://schemas.microsoft.com/office/drawing/2014/main" id="{11556AC2-38C8-4FB5-87B1-3C63D62060C5}"/>
+                <a16:creationId xmlns:a16="http://schemas.microsoft.com/office/drawing/2014/main" id="{CEFD1633-7553-4C96-BC88-6D69EFDF1A9F}"/>
               </a:ext>
             </a:extLst>
           </p:cNvPr>
@@ -11337,7 +11337,7 @@
     </p:spTree>
     <p:extLst>
       <p:ext uri="{BB962C8B-B14F-4D97-AF65-F5344CB8AC3E}">
-        <p14:creationId xmlns:p14="http://schemas.microsoft.com/office/powerpoint/2010/main" val="1888924586"/>
+        <p14:creationId xmlns:p14="http://schemas.microsoft.com/office/powerpoint/2010/main" val="1395636109"/>
       </p:ext>
     </p:extLst>
   </p:cSld>
@@ -11368,7 +11368,7 @@
           <p:cNvPr id="37" name="">
             <a:extLst xmlns:a="http://schemas.openxmlformats.org/drawingml/2006/main">
               <a:ext uri="{FF2B5EF4-FFF2-40B4-BE49-F238E27FC236}">
-                <a16:creationId xmlns:a16="http://schemas.microsoft.com/office/drawing/2014/main" id="{FC895DEA-CB1E-4549-AFA1-43F7AEDAC9FD}"/>
+                <a16:creationId xmlns:a16="http://schemas.microsoft.com/office/drawing/2014/main" id="{532859E6-49B5-4EA7-9A15-D54207A8CB95}"/>
               </a:ext>
             </a:extLst>
           </p:cNvPr>
@@ -11425,7 +11425,7 @@
           <p:cNvPr id="2" name="">
             <a:extLst xmlns:a="http://schemas.openxmlformats.org/drawingml/2006/main">
               <a:ext uri="{FF2B5EF4-FFF2-40B4-BE49-F238E27FC236}">
-                <a16:creationId xmlns:a16="http://schemas.microsoft.com/office/drawing/2014/main" id="{6F046C05-CB4E-4799-BA39-91458338F72C}"/>
+                <a16:creationId xmlns:a16="http://schemas.microsoft.com/office/drawing/2014/main" id="{8F61568A-5EB7-4C74-88CC-FEE69B8503C7}"/>
               </a:ext>
             </a:extLst>
           </p:cNvPr>
@@ -11482,7 +11482,7 @@
           <p:cNvPr id="3" name="">
             <a:extLst xmlns:a="http://schemas.openxmlformats.org/drawingml/2006/main">
               <a:ext uri="{FF2B5EF4-FFF2-40B4-BE49-F238E27FC236}">
-                <a16:creationId xmlns:a16="http://schemas.microsoft.com/office/drawing/2014/main" id="{67C878B9-F563-430C-8DE1-370808EFC1B1}"/>
+                <a16:creationId xmlns:a16="http://schemas.microsoft.com/office/drawing/2014/main" id="{C8D8ADAB-CA2C-4F04-AEA5-7D18F5C6255F}"/>
               </a:ext>
             </a:extLst>
           </p:cNvPr>
@@ -11512,7 +11512,7 @@
           <p:cNvPr id="4" name="">
             <a:extLst xmlns:a="http://schemas.openxmlformats.org/drawingml/2006/main">
               <a:ext uri="{FF2B5EF4-FFF2-40B4-BE49-F238E27FC236}">
-                <a16:creationId xmlns:a16="http://schemas.microsoft.com/office/drawing/2014/main" id="{58332264-7BFE-4368-B4E2-8493DD263D7A}"/>
+                <a16:creationId xmlns:a16="http://schemas.microsoft.com/office/drawing/2014/main" id="{0A252786-C830-4BB7-A0CA-E10E7FE85D86}"/>
               </a:ext>
             </a:extLst>
           </p:cNvPr>
@@ -11569,7 +11569,7 @@
           <p:cNvPr id="5" name="">
             <a:extLst xmlns:a="http://schemas.openxmlformats.org/drawingml/2006/main">
               <a:ext uri="{FF2B5EF4-FFF2-40B4-BE49-F238E27FC236}">
-                <a16:creationId xmlns:a16="http://schemas.microsoft.com/office/drawing/2014/main" id="{D18E85D4-859D-4489-BCDF-AA387531D6AD}"/>
+                <a16:creationId xmlns:a16="http://schemas.microsoft.com/office/drawing/2014/main" id="{C5CE8021-9A45-49C7-A8DE-19649ECE036A}"/>
               </a:ext>
             </a:extLst>
           </p:cNvPr>
@@ -11603,7 +11603,7 @@
           <p:cNvPr id="6" name="">
             <a:extLst xmlns:a="http://schemas.openxmlformats.org/drawingml/2006/main">
               <a:ext uri="{FF2B5EF4-FFF2-40B4-BE49-F238E27FC236}">
-                <a16:creationId xmlns:a16="http://schemas.microsoft.com/office/drawing/2014/main" id="{ED86CFD1-F25E-4229-A0C1-9D5E9D1179E6}"/>
+                <a16:creationId xmlns:a16="http://schemas.microsoft.com/office/drawing/2014/main" id="{951CCC3F-2E9E-4632-9784-7C9A0D8FA019}"/>
               </a:ext>
             </a:extLst>
           </p:cNvPr>
@@ -11660,7 +11660,7 @@
           <p:cNvPr id="7" name="">
             <a:extLst xmlns:a="http://schemas.openxmlformats.org/drawingml/2006/main">
               <a:ext uri="{FF2B5EF4-FFF2-40B4-BE49-F238E27FC236}">
-                <a16:creationId xmlns:a16="http://schemas.microsoft.com/office/drawing/2014/main" id="{F9D9ABF9-0099-403C-8FBA-7A4800D05B5D}"/>
+                <a16:creationId xmlns:a16="http://schemas.microsoft.com/office/drawing/2014/main" id="{00BE624D-83A5-4FB2-8FD2-924B386BF645}"/>
               </a:ext>
             </a:extLst>
           </p:cNvPr>
@@ -11717,7 +11717,7 @@
           <p:cNvPr id="8" name="">
             <a:extLst xmlns:a="http://schemas.openxmlformats.org/drawingml/2006/main">
               <a:ext uri="{FF2B5EF4-FFF2-40B4-BE49-F238E27FC236}">
-                <a16:creationId xmlns:a16="http://schemas.microsoft.com/office/drawing/2014/main" id="{7F1E9832-9136-4BC2-97C4-9FB8EFE765E5}"/>
+                <a16:creationId xmlns:a16="http://schemas.microsoft.com/office/drawing/2014/main" id="{020F1658-2B80-4A15-A966-A8FD791E6B04}"/>
               </a:ext>
             </a:extLst>
           </p:cNvPr>
@@ -11774,7 +11774,7 @@
           <p:cNvPr id="9" name="">
             <a:extLst xmlns:a="http://schemas.openxmlformats.org/drawingml/2006/main">
               <a:ext uri="{FF2B5EF4-FFF2-40B4-BE49-F238E27FC236}">
-                <a16:creationId xmlns:a16="http://schemas.microsoft.com/office/drawing/2014/main" id="{7BAFAFB9-BE9B-47C3-AB01-D669DA6BA9C1}"/>
+                <a16:creationId xmlns:a16="http://schemas.microsoft.com/office/drawing/2014/main" id="{792E3434-351F-4992-ACC5-C3EF7DADA9E2}"/>
               </a:ext>
             </a:extLst>
           </p:cNvPr>
@@ -11808,7 +11808,7 @@
           <p:cNvPr id="10" name="">
             <a:extLst xmlns:a="http://schemas.openxmlformats.org/drawingml/2006/main">
               <a:ext uri="{FF2B5EF4-FFF2-40B4-BE49-F238E27FC236}">
-                <a16:creationId xmlns:a16="http://schemas.microsoft.com/office/drawing/2014/main" id="{89FDB66D-7A88-463A-94A5-4481F3AE4F65}"/>
+                <a16:creationId xmlns:a16="http://schemas.microsoft.com/office/drawing/2014/main" id="{75538BEF-5A96-4F00-847C-C1A12BA606A8}"/>
               </a:ext>
             </a:extLst>
           </p:cNvPr>
@@ -11865,7 +11865,7 @@
           <p:cNvPr id="11" name="">
             <a:extLst xmlns:a="http://schemas.openxmlformats.org/drawingml/2006/main">
               <a:ext uri="{FF2B5EF4-FFF2-40B4-BE49-F238E27FC236}">
-                <a16:creationId xmlns:a16="http://schemas.microsoft.com/office/drawing/2014/main" id="{3DBF80FD-5C93-4C82-96BA-1D2A966D357C}"/>
+                <a16:creationId xmlns:a16="http://schemas.microsoft.com/office/drawing/2014/main" id="{0FA647B1-AA0F-4DA4-87E6-C19EA05E8DFD}"/>
               </a:ext>
             </a:extLst>
           </p:cNvPr>
@@ -11922,7 +11922,7 @@
           <p:cNvPr id="12" name="">
             <a:extLst xmlns:a="http://schemas.openxmlformats.org/drawingml/2006/main">
               <a:ext uri="{FF2B5EF4-FFF2-40B4-BE49-F238E27FC236}">
-                <a16:creationId xmlns:a16="http://schemas.microsoft.com/office/drawing/2014/main" id="{F65032FA-EBE2-4077-85A4-BF4067010DF3}"/>
+                <a16:creationId xmlns:a16="http://schemas.microsoft.com/office/drawing/2014/main" id="{B5C6F4EB-E261-4DB1-9F73-8C5613771E6F}"/>
               </a:ext>
             </a:extLst>
           </p:cNvPr>
@@ -11979,7 +11979,7 @@
           <p:cNvPr id="13" name="">
             <a:extLst xmlns:a="http://schemas.openxmlformats.org/drawingml/2006/main">
               <a:ext uri="{FF2B5EF4-FFF2-40B4-BE49-F238E27FC236}">
-                <a16:creationId xmlns:a16="http://schemas.microsoft.com/office/drawing/2014/main" id="{E05BCB32-BE30-4115-9319-6F22389D29E0}"/>
+                <a16:creationId xmlns:a16="http://schemas.microsoft.com/office/drawing/2014/main" id="{7885A490-102B-4230-8F04-899AC9E66D55}"/>
               </a:ext>
             </a:extLst>
           </p:cNvPr>
@@ -12013,7 +12013,7 @@
           <p:cNvPr id="14" name="">
             <a:extLst xmlns:a="http://schemas.openxmlformats.org/drawingml/2006/main">
               <a:ext uri="{FF2B5EF4-FFF2-40B4-BE49-F238E27FC236}">
-                <a16:creationId xmlns:a16="http://schemas.microsoft.com/office/drawing/2014/main" id="{E326CCA2-730A-4C2A-8EB1-7B0389A62E51}"/>
+                <a16:creationId xmlns:a16="http://schemas.microsoft.com/office/drawing/2014/main" id="{5CC21AE3-99DF-420E-963B-E147724E6A25}"/>
               </a:ext>
             </a:extLst>
           </p:cNvPr>
@@ -12070,7 +12070,7 @@
           <p:cNvPr id="15" name="">
             <a:extLst xmlns:a="http://schemas.openxmlformats.org/drawingml/2006/main">
               <a:ext uri="{FF2B5EF4-FFF2-40B4-BE49-F238E27FC236}">
-                <a16:creationId xmlns:a16="http://schemas.microsoft.com/office/drawing/2014/main" id="{9DAED96B-46BB-4122-99EE-18509C7B8D25}"/>
+                <a16:creationId xmlns:a16="http://schemas.microsoft.com/office/drawing/2014/main" id="{22F45636-E1BC-49BF-B516-E0FAB2B9E88A}"/>
               </a:ext>
             </a:extLst>
           </p:cNvPr>
@@ -12127,7 +12127,7 @@
           <p:cNvPr id="16" name="">
             <a:extLst xmlns:a="http://schemas.openxmlformats.org/drawingml/2006/main">
               <a:ext uri="{FF2B5EF4-FFF2-40B4-BE49-F238E27FC236}">
-                <a16:creationId xmlns:a16="http://schemas.microsoft.com/office/drawing/2014/main" id="{E8309C87-AAD8-433E-83F4-167215162DFD}"/>
+                <a16:creationId xmlns:a16="http://schemas.microsoft.com/office/drawing/2014/main" id="{8941BD95-6A3C-4312-887E-A293C83A6D6A}"/>
               </a:ext>
             </a:extLst>
           </p:cNvPr>
@@ -12184,7 +12184,7 @@
           <p:cNvPr id="17" name="">
             <a:extLst xmlns:a="http://schemas.openxmlformats.org/drawingml/2006/main">
               <a:ext uri="{FF2B5EF4-FFF2-40B4-BE49-F238E27FC236}">
-                <a16:creationId xmlns:a16="http://schemas.microsoft.com/office/drawing/2014/main" id="{A0772B49-31D4-482A-B3B4-C154CA43A744}"/>
+                <a16:creationId xmlns:a16="http://schemas.microsoft.com/office/drawing/2014/main" id="{3EACB46A-3991-48D4-A447-20357FE3436B}"/>
               </a:ext>
             </a:extLst>
           </p:cNvPr>
@@ -12218,7 +12218,7 @@
           <p:cNvPr id="18" name="">
             <a:extLst xmlns:a="http://schemas.openxmlformats.org/drawingml/2006/main">
               <a:ext uri="{FF2B5EF4-FFF2-40B4-BE49-F238E27FC236}">
-                <a16:creationId xmlns:a16="http://schemas.microsoft.com/office/drawing/2014/main" id="{DBDE5D42-2002-4F14-9467-1EFF1222B4F9}"/>
+                <a16:creationId xmlns:a16="http://schemas.microsoft.com/office/drawing/2014/main" id="{600490E7-FE81-49DF-8D1C-7170E63B9C10}"/>
               </a:ext>
             </a:extLst>
           </p:cNvPr>
@@ -12275,7 +12275,7 @@
           <p:cNvPr id="19" name="">
             <a:extLst xmlns:a="http://schemas.openxmlformats.org/drawingml/2006/main">
               <a:ext uri="{FF2B5EF4-FFF2-40B4-BE49-F238E27FC236}">
-                <a16:creationId xmlns:a16="http://schemas.microsoft.com/office/drawing/2014/main" id="{1920A169-69D8-4BA4-B414-5FA422E120F0}"/>
+                <a16:creationId xmlns:a16="http://schemas.microsoft.com/office/drawing/2014/main" id="{7F6CEF1D-BFFA-4B5B-874A-0A8D107E583E}"/>
               </a:ext>
             </a:extLst>
           </p:cNvPr>
@@ -12332,7 +12332,7 @@
           <p:cNvPr id="20" name="">
             <a:extLst xmlns:a="http://schemas.openxmlformats.org/drawingml/2006/main">
               <a:ext uri="{FF2B5EF4-FFF2-40B4-BE49-F238E27FC236}">
-                <a16:creationId xmlns:a16="http://schemas.microsoft.com/office/drawing/2014/main" id="{5656E09A-AE8A-40ED-A463-F6AF40D299CB}"/>
+                <a16:creationId xmlns:a16="http://schemas.microsoft.com/office/drawing/2014/main" id="{2A8C8E7E-7542-40FA-8086-30A89EBE827A}"/>
               </a:ext>
             </a:extLst>
           </p:cNvPr>
@@ -12389,7 +12389,7 @@
           <p:cNvPr id="21" name="">
             <a:extLst xmlns:a="http://schemas.openxmlformats.org/drawingml/2006/main">
               <a:ext uri="{FF2B5EF4-FFF2-40B4-BE49-F238E27FC236}">
-                <a16:creationId xmlns:a16="http://schemas.microsoft.com/office/drawing/2014/main" id="{F1E9C7E9-3ED8-44F3-B149-7C4FB2B63B30}"/>
+                <a16:creationId xmlns:a16="http://schemas.microsoft.com/office/drawing/2014/main" id="{0767E9F8-7242-4421-AE1E-9063B3EE95BF}"/>
               </a:ext>
             </a:extLst>
           </p:cNvPr>
@@ -12423,7 +12423,7 @@
           <p:cNvPr id="22" name="">
             <a:extLst xmlns:a="http://schemas.openxmlformats.org/drawingml/2006/main">
               <a:ext uri="{FF2B5EF4-FFF2-40B4-BE49-F238E27FC236}">
-                <a16:creationId xmlns:a16="http://schemas.microsoft.com/office/drawing/2014/main" id="{9C62926B-97A6-40D6-9B0E-A00235B12C70}"/>
+                <a16:creationId xmlns:a16="http://schemas.microsoft.com/office/drawing/2014/main" id="{E2245DE0-0BD3-4AA4-87F8-BD0F6F60FB98}"/>
               </a:ext>
             </a:extLst>
           </p:cNvPr>
@@ -12480,7 +12480,7 @@
           <p:cNvPr id="23" name="">
             <a:extLst xmlns:a="http://schemas.openxmlformats.org/drawingml/2006/main">
               <a:ext uri="{FF2B5EF4-FFF2-40B4-BE49-F238E27FC236}">
-                <a16:creationId xmlns:a16="http://schemas.microsoft.com/office/drawing/2014/main" id="{5A1841E6-9EA1-4619-BCD5-9B50D6B2D432}"/>
+                <a16:creationId xmlns:a16="http://schemas.microsoft.com/office/drawing/2014/main" id="{16A6EC2F-21DF-4FEA-909F-46F4C050F186}"/>
               </a:ext>
             </a:extLst>
           </p:cNvPr>
@@ -12537,7 +12537,7 @@
           <p:cNvPr id="24" name="">
             <a:extLst xmlns:a="http://schemas.openxmlformats.org/drawingml/2006/main">
               <a:ext uri="{FF2B5EF4-FFF2-40B4-BE49-F238E27FC236}">
-                <a16:creationId xmlns:a16="http://schemas.microsoft.com/office/drawing/2014/main" id="{081EBBB8-8B72-4997-AB14-33444C3626A6}"/>
+                <a16:creationId xmlns:a16="http://schemas.microsoft.com/office/drawing/2014/main" id="{781D1350-F7FC-43A6-ACBA-347FE69E973D}"/>
               </a:ext>
             </a:extLst>
           </p:cNvPr>
@@ -12694,7 +12694,7 @@
           <p:cNvPr id="29" name="">
             <a:extLst xmlns:a="http://schemas.openxmlformats.org/drawingml/2006/main">
               <a:ext uri="{FF2B5EF4-FFF2-40B4-BE49-F238E27FC236}">
-                <a16:creationId xmlns:a16="http://schemas.microsoft.com/office/drawing/2014/main" id="{5CAAC750-B5BC-4547-BEA5-B7EF0CACF387}"/>
+                <a16:creationId xmlns:a16="http://schemas.microsoft.com/office/drawing/2014/main" id="{11986D16-748E-421B-8B07-F9322B827C8A}"/>
               </a:ext>
             </a:extLst>
           </p:cNvPr>
@@ -12728,7 +12728,7 @@
           <p:cNvPr id="30" name="">
             <a:extLst xmlns:a="http://schemas.openxmlformats.org/drawingml/2006/main">
               <a:ext uri="{FF2B5EF4-FFF2-40B4-BE49-F238E27FC236}">
-                <a16:creationId xmlns:a16="http://schemas.microsoft.com/office/drawing/2014/main" id="{DB570BFD-78C5-4562-965A-3565BAD9A387}"/>
+                <a16:creationId xmlns:a16="http://schemas.microsoft.com/office/drawing/2014/main" id="{4FA44430-8413-4A0A-BB91-8B825752726F}"/>
               </a:ext>
             </a:extLst>
           </p:cNvPr>
@@ -12762,7 +12762,7 @@
           <p:cNvPr id="31" name="">
             <a:extLst xmlns:a="http://schemas.openxmlformats.org/drawingml/2006/main">
               <a:ext uri="{FF2B5EF4-FFF2-40B4-BE49-F238E27FC236}">
-                <a16:creationId xmlns:a16="http://schemas.microsoft.com/office/drawing/2014/main" id="{42C548F7-F65B-48B1-911B-B1D2B9B11E8A}"/>
+                <a16:creationId xmlns:a16="http://schemas.microsoft.com/office/drawing/2014/main" id="{69DD5244-8C8A-4F81-9EED-5E1767DFBB13}"/>
               </a:ext>
             </a:extLst>
           </p:cNvPr>
@@ -12819,7 +12819,7 @@
           <p:cNvPr id="32" name="">
             <a:extLst xmlns:a="http://schemas.openxmlformats.org/drawingml/2006/main">
               <a:ext uri="{FF2B5EF4-FFF2-40B4-BE49-F238E27FC236}">
-                <a16:creationId xmlns:a16="http://schemas.microsoft.com/office/drawing/2014/main" id="{24C06E34-A17C-48B1-B4FE-6E7F23CBF132}"/>
+                <a16:creationId xmlns:a16="http://schemas.microsoft.com/office/drawing/2014/main" id="{C397FC06-3966-4660-86FB-E37280BF17B8}"/>
               </a:ext>
             </a:extLst>
           </p:cNvPr>
@@ -12876,7 +12876,7 @@
           <p:cNvPr id="33" name="">
             <a:extLst xmlns:a="http://schemas.openxmlformats.org/drawingml/2006/main">
               <a:ext uri="{FF2B5EF4-FFF2-40B4-BE49-F238E27FC236}">
-                <a16:creationId xmlns:a16="http://schemas.microsoft.com/office/drawing/2014/main" id="{794AC25D-6594-4DFD-A56B-1BA55C0EB819}"/>
+                <a16:creationId xmlns:a16="http://schemas.microsoft.com/office/drawing/2014/main" id="{C1D391AA-6AAA-4232-9354-232F88A433A1}"/>
               </a:ext>
             </a:extLst>
           </p:cNvPr>
@@ -12910,7 +12910,7 @@
           <p:cNvPr id="34" name="">
             <a:extLst xmlns:a="http://schemas.openxmlformats.org/drawingml/2006/main">
               <a:ext uri="{FF2B5EF4-FFF2-40B4-BE49-F238E27FC236}">
-                <a16:creationId xmlns:a16="http://schemas.microsoft.com/office/drawing/2014/main" id="{79932C44-8546-4583-9DB8-CBA3A0197727}"/>
+                <a16:creationId xmlns:a16="http://schemas.microsoft.com/office/drawing/2014/main" id="{E41DD859-883A-4A0A-9BAC-60E93FC8E1DF}"/>
               </a:ext>
             </a:extLst>
           </p:cNvPr>
@@ -12944,7 +12944,7 @@
           <p:cNvPr id="35" name="">
             <a:extLst xmlns:a="http://schemas.openxmlformats.org/drawingml/2006/main">
               <a:ext uri="{FF2B5EF4-FFF2-40B4-BE49-F238E27FC236}">
-                <a16:creationId xmlns:a16="http://schemas.microsoft.com/office/drawing/2014/main" id="{5CC68BC2-5C00-41BA-BAE6-17BE168A41CE}"/>
+                <a16:creationId xmlns:a16="http://schemas.microsoft.com/office/drawing/2014/main" id="{0CCC742B-6883-4977-A66F-5903861BF8E1}"/>
               </a:ext>
             </a:extLst>
           </p:cNvPr>
@@ -13001,7 +13001,7 @@
           <p:cNvPr id="36" name="">
             <a:extLst xmlns:a="http://schemas.openxmlformats.org/drawingml/2006/main">
               <a:ext uri="{FF2B5EF4-FFF2-40B4-BE49-F238E27FC236}">
-                <a16:creationId xmlns:a16="http://schemas.microsoft.com/office/drawing/2014/main" id="{EF9B2467-BDA9-4F44-AE20-88A342C80443}"/>
+                <a16:creationId xmlns:a16="http://schemas.microsoft.com/office/drawing/2014/main" id="{794F903F-56B5-4A99-B7AD-2BCDEDA100BB}"/>
               </a:ext>
             </a:extLst>
           </p:cNvPr>
@@ -13056,7 +13056,7 @@
     </p:spTree>
     <p:extLst>
       <p:ext uri="{BB962C8B-B14F-4D97-AF65-F5344CB8AC3E}">
-        <p14:creationId xmlns:p14="http://schemas.microsoft.com/office/powerpoint/2010/main" val="420697720"/>
+        <p14:creationId xmlns:p14="http://schemas.microsoft.com/office/powerpoint/2010/main" val="1554994875"/>
       </p:ext>
     </p:extLst>
   </p:cSld>
@@ -13087,7 +13087,7 @@
           <p:cNvPr id="36" name="">
             <a:extLst xmlns:a="http://schemas.openxmlformats.org/drawingml/2006/main">
               <a:ext uri="{FF2B5EF4-FFF2-40B4-BE49-F238E27FC236}">
-                <a16:creationId xmlns:a16="http://schemas.microsoft.com/office/drawing/2014/main" id="{A33D5BE6-3AC2-4BCF-948D-2C8A562D7813}"/>
+                <a16:creationId xmlns:a16="http://schemas.microsoft.com/office/drawing/2014/main" id="{DC1EB2A0-565F-42F4-8B80-162EAD1E436C}"/>
               </a:ext>
             </a:extLst>
           </p:cNvPr>
@@ -13144,7 +13144,7 @@
           <p:cNvPr id="2" name="">
             <a:extLst xmlns:a="http://schemas.openxmlformats.org/drawingml/2006/main">
               <a:ext uri="{FF2B5EF4-FFF2-40B4-BE49-F238E27FC236}">
-                <a16:creationId xmlns:a16="http://schemas.microsoft.com/office/drawing/2014/main" id="{C50AD09F-2BB7-4A92-86D6-C4AF53617407}"/>
+                <a16:creationId xmlns:a16="http://schemas.microsoft.com/office/drawing/2014/main" id="{712CFBC5-4B23-413B-B8B3-09623FD4A5A0}"/>
               </a:ext>
             </a:extLst>
           </p:cNvPr>
@@ -13201,7 +13201,7 @@
           <p:cNvPr id="3" name="">
             <a:extLst xmlns:a="http://schemas.openxmlformats.org/drawingml/2006/main">
               <a:ext uri="{FF2B5EF4-FFF2-40B4-BE49-F238E27FC236}">
-                <a16:creationId xmlns:a16="http://schemas.microsoft.com/office/drawing/2014/main" id="{6F6B8FFB-099E-4089-B488-C4D2BD8FD761}"/>
+                <a16:creationId xmlns:a16="http://schemas.microsoft.com/office/drawing/2014/main" id="{DE3FBB84-0F92-4844-AA6D-CA7AA45DB4AB}"/>
               </a:ext>
             </a:extLst>
           </p:cNvPr>
@@ -13231,7 +13231,7 @@
           <p:cNvPr id="4" name="">
             <a:extLst xmlns:a="http://schemas.openxmlformats.org/drawingml/2006/main">
               <a:ext uri="{FF2B5EF4-FFF2-40B4-BE49-F238E27FC236}">
-                <a16:creationId xmlns:a16="http://schemas.microsoft.com/office/drawing/2014/main" id="{A79CDE3E-9AFE-4201-8290-4B22F6A53216}"/>
+                <a16:creationId xmlns:a16="http://schemas.microsoft.com/office/drawing/2014/main" id="{B3A76FF7-B267-4A5C-B086-B1E80297497C}"/>
               </a:ext>
             </a:extLst>
           </p:cNvPr>
@@ -13288,7 +13288,7 @@
           <p:cNvPr id="5" name="">
             <a:extLst xmlns:a="http://schemas.openxmlformats.org/drawingml/2006/main">
               <a:ext uri="{FF2B5EF4-FFF2-40B4-BE49-F238E27FC236}">
-                <a16:creationId xmlns:a16="http://schemas.microsoft.com/office/drawing/2014/main" id="{D9CD70F2-DACB-4FD5-8914-3E86743E96AB}"/>
+                <a16:creationId xmlns:a16="http://schemas.microsoft.com/office/drawing/2014/main" id="{F5691970-9333-42A1-B4C2-8FE4DC69AA3E}"/>
               </a:ext>
             </a:extLst>
           </p:cNvPr>
@@ -13322,7 +13322,7 @@
           <p:cNvPr id="6" name="">
             <a:extLst xmlns:a="http://schemas.openxmlformats.org/drawingml/2006/main">
               <a:ext uri="{FF2B5EF4-FFF2-40B4-BE49-F238E27FC236}">
-                <a16:creationId xmlns:a16="http://schemas.microsoft.com/office/drawing/2014/main" id="{5A12E15A-BD18-48E0-872F-23661845E105}"/>
+                <a16:creationId xmlns:a16="http://schemas.microsoft.com/office/drawing/2014/main" id="{4BE25F1C-363C-4DF7-A3D4-EE9F95E17233}"/>
               </a:ext>
             </a:extLst>
           </p:cNvPr>
@@ -13383,7 +13383,7 @@
           <p:cNvPr id="7" name="">
             <a:extLst xmlns:a="http://schemas.openxmlformats.org/drawingml/2006/main">
               <a:ext uri="{FF2B5EF4-FFF2-40B4-BE49-F238E27FC236}">
-                <a16:creationId xmlns:a16="http://schemas.microsoft.com/office/drawing/2014/main" id="{5F121371-DEC3-4B6C-91DB-B3C0C5CE5CE9}"/>
+                <a16:creationId xmlns:a16="http://schemas.microsoft.com/office/drawing/2014/main" id="{9FFAF797-4099-47D1-83C0-A94725E0BCA0}"/>
               </a:ext>
             </a:extLst>
           </p:cNvPr>
@@ -13440,7 +13440,7 @@
           <p:cNvPr id="8" name="">
             <a:extLst xmlns:a="http://schemas.openxmlformats.org/drawingml/2006/main">
               <a:ext uri="{FF2B5EF4-FFF2-40B4-BE49-F238E27FC236}">
-                <a16:creationId xmlns:a16="http://schemas.microsoft.com/office/drawing/2014/main" id="{543175F8-D4F5-47A5-9FB4-DB78EA459D4F}"/>
+                <a16:creationId xmlns:a16="http://schemas.microsoft.com/office/drawing/2014/main" id="{5AB22073-D644-4CA5-9365-BBF9D6E5E248}"/>
               </a:ext>
             </a:extLst>
           </p:cNvPr>
@@ -13497,7 +13497,7 @@
           <p:cNvPr id="9" name="">
             <a:extLst xmlns:a="http://schemas.openxmlformats.org/drawingml/2006/main">
               <a:ext uri="{FF2B5EF4-FFF2-40B4-BE49-F238E27FC236}">
-                <a16:creationId xmlns:a16="http://schemas.microsoft.com/office/drawing/2014/main" id="{D630FA7F-948A-4363-86E8-CA1A6A203E43}"/>
+                <a16:creationId xmlns:a16="http://schemas.microsoft.com/office/drawing/2014/main" id="{E592949E-0373-4EAC-8706-359777C9A361}"/>
               </a:ext>
             </a:extLst>
           </p:cNvPr>
@@ -13531,7 +13531,7 @@
           <p:cNvPr id="10" name="">
             <a:extLst xmlns:a="http://schemas.openxmlformats.org/drawingml/2006/main">
               <a:ext uri="{FF2B5EF4-FFF2-40B4-BE49-F238E27FC236}">
-                <a16:creationId xmlns:a16="http://schemas.microsoft.com/office/drawing/2014/main" id="{7423AFE1-A7A8-4DE2-BB97-458DF8696D38}"/>
+                <a16:creationId xmlns:a16="http://schemas.microsoft.com/office/drawing/2014/main" id="{8510CD54-965F-455A-8B0B-72C84163F82A}"/>
               </a:ext>
             </a:extLst>
           </p:cNvPr>
@@ -13592,7 +13592,7 @@
           <p:cNvPr id="11" name="">
             <a:extLst xmlns:a="http://schemas.openxmlformats.org/drawingml/2006/main">
               <a:ext uri="{FF2B5EF4-FFF2-40B4-BE49-F238E27FC236}">
-                <a16:creationId xmlns:a16="http://schemas.microsoft.com/office/drawing/2014/main" id="{EC526150-912F-4EC5-896A-8F750D8B6CFF}"/>
+                <a16:creationId xmlns:a16="http://schemas.microsoft.com/office/drawing/2014/main" id="{ED25C5C8-EB26-4381-A804-5375066D9854}"/>
               </a:ext>
             </a:extLst>
           </p:cNvPr>
@@ -13649,7 +13649,7 @@
           <p:cNvPr id="12" name="">
             <a:extLst xmlns:a="http://schemas.openxmlformats.org/drawingml/2006/main">
               <a:ext uri="{FF2B5EF4-FFF2-40B4-BE49-F238E27FC236}">
-                <a16:creationId xmlns:a16="http://schemas.microsoft.com/office/drawing/2014/main" id="{B8B39999-B202-4EA5-90FE-53DE03D661EC}"/>
+                <a16:creationId xmlns:a16="http://schemas.microsoft.com/office/drawing/2014/main" id="{E38794D5-41ED-4CF4-A778-33DAA8617271}"/>
               </a:ext>
             </a:extLst>
           </p:cNvPr>
@@ -13706,7 +13706,7 @@
           <p:cNvPr id="13" name="">
             <a:extLst xmlns:a="http://schemas.openxmlformats.org/drawingml/2006/main">
               <a:ext uri="{FF2B5EF4-FFF2-40B4-BE49-F238E27FC236}">
-                <a16:creationId xmlns:a16="http://schemas.microsoft.com/office/drawing/2014/main" id="{DB928EA1-CFC7-4C80-8982-C5B1D2881992}"/>
+                <a16:creationId xmlns:a16="http://schemas.microsoft.com/office/drawing/2014/main" id="{B351B080-6836-4A4F-AFF5-3E49BA214839}"/>
               </a:ext>
             </a:extLst>
           </p:cNvPr>
@@ -13740,7 +13740,7 @@
           <p:cNvPr id="14" name="">
             <a:extLst xmlns:a="http://schemas.openxmlformats.org/drawingml/2006/main">
               <a:ext uri="{FF2B5EF4-FFF2-40B4-BE49-F238E27FC236}">
-                <a16:creationId xmlns:a16="http://schemas.microsoft.com/office/drawing/2014/main" id="{B08892E0-1B22-4B75-8DC1-2DC0E45EA838}"/>
+                <a16:creationId xmlns:a16="http://schemas.microsoft.com/office/drawing/2014/main" id="{ADBB8D83-7D42-40A7-8A76-81A9BA9506FE}"/>
               </a:ext>
             </a:extLst>
           </p:cNvPr>
@@ -13801,7 +13801,7 @@
           <p:cNvPr id="15" name="">
             <a:extLst xmlns:a="http://schemas.openxmlformats.org/drawingml/2006/main">
               <a:ext uri="{FF2B5EF4-FFF2-40B4-BE49-F238E27FC236}">
-                <a16:creationId xmlns:a16="http://schemas.microsoft.com/office/drawing/2014/main" id="{7F2CAC61-DDFF-4A40-87E0-9BC69CC473D4}"/>
+                <a16:creationId xmlns:a16="http://schemas.microsoft.com/office/drawing/2014/main" id="{21C84EEB-B92E-4114-8F6C-BD656EB1C929}"/>
               </a:ext>
             </a:extLst>
           </p:cNvPr>
@@ -13858,7 +13858,7 @@
           <p:cNvPr id="16" name="">
             <a:extLst xmlns:a="http://schemas.openxmlformats.org/drawingml/2006/main">
               <a:ext uri="{FF2B5EF4-FFF2-40B4-BE49-F238E27FC236}">
-                <a16:creationId xmlns:a16="http://schemas.microsoft.com/office/drawing/2014/main" id="{AC918BCA-98B8-484A-AAA0-48767EF1317E}"/>
+                <a16:creationId xmlns:a16="http://schemas.microsoft.com/office/drawing/2014/main" id="{E63A4136-C9E4-4E10-A03E-50D2F57C373C}"/>
               </a:ext>
             </a:extLst>
           </p:cNvPr>
@@ -13915,7 +13915,7 @@
           <p:cNvPr id="17" name="">
             <a:extLst xmlns:a="http://schemas.openxmlformats.org/drawingml/2006/main">
               <a:ext uri="{FF2B5EF4-FFF2-40B4-BE49-F238E27FC236}">
-                <a16:creationId xmlns:a16="http://schemas.microsoft.com/office/drawing/2014/main" id="{A59F71AD-E646-4A0C-B11B-AF427B77DB76}"/>
+                <a16:creationId xmlns:a16="http://schemas.microsoft.com/office/drawing/2014/main" id="{85EF91DD-4C65-4412-9FAD-67397A2147F4}"/>
               </a:ext>
             </a:extLst>
           </p:cNvPr>
@@ -13949,7 +13949,7 @@
           <p:cNvPr id="18" name="">
             <a:extLst xmlns:a="http://schemas.openxmlformats.org/drawingml/2006/main">
               <a:ext uri="{FF2B5EF4-FFF2-40B4-BE49-F238E27FC236}">
-                <a16:creationId xmlns:a16="http://schemas.microsoft.com/office/drawing/2014/main" id="{143EEE70-4AEC-4D7A-B2A6-B1BB08692F0A}"/>
+                <a16:creationId xmlns:a16="http://schemas.microsoft.com/office/drawing/2014/main" id="{B4F5141E-4457-43FC-8EE9-41D7E35A90BF}"/>
               </a:ext>
             </a:extLst>
           </p:cNvPr>
@@ -14010,7 +14010,7 @@
           <p:cNvPr id="19" name="">
             <a:extLst xmlns:a="http://schemas.openxmlformats.org/drawingml/2006/main">
               <a:ext uri="{FF2B5EF4-FFF2-40B4-BE49-F238E27FC236}">
-                <a16:creationId xmlns:a16="http://schemas.microsoft.com/office/drawing/2014/main" id="{C1B9C31D-39DB-41E9-A7C4-CA3EF7D5F204}"/>
+                <a16:creationId xmlns:a16="http://schemas.microsoft.com/office/drawing/2014/main" id="{3192945C-8329-4E18-A6A9-9E2F556650F5}"/>
               </a:ext>
             </a:extLst>
           </p:cNvPr>
@@ -14067,7 +14067,7 @@
           <p:cNvPr id="20" name="">
             <a:extLst xmlns:a="http://schemas.openxmlformats.org/drawingml/2006/main">
               <a:ext uri="{FF2B5EF4-FFF2-40B4-BE49-F238E27FC236}">
-                <a16:creationId xmlns:a16="http://schemas.microsoft.com/office/drawing/2014/main" id="{07DFE624-A1EA-4B7D-88C6-B47565097A5E}"/>
+                <a16:creationId xmlns:a16="http://schemas.microsoft.com/office/drawing/2014/main" id="{A906F812-B7FD-4E14-B523-F022115E5213}"/>
               </a:ext>
             </a:extLst>
           </p:cNvPr>
@@ -14199,7 +14199,7 @@
           <p:cNvPr id="24" name="">
             <a:extLst xmlns:a="http://schemas.openxmlformats.org/drawingml/2006/main">
               <a:ext uri="{FF2B5EF4-FFF2-40B4-BE49-F238E27FC236}">
-                <a16:creationId xmlns:a16="http://schemas.microsoft.com/office/drawing/2014/main" id="{896DBC5E-F49C-4169-9D40-4B702539E355}"/>
+                <a16:creationId xmlns:a16="http://schemas.microsoft.com/office/drawing/2014/main" id="{DE25833C-F3D9-4DA4-B205-5EBAD7AD376E}"/>
               </a:ext>
             </a:extLst>
           </p:cNvPr>
@@ -14256,7 +14256,7 @@
           <p:cNvPr id="25" name="">
             <a:extLst xmlns:a="http://schemas.openxmlformats.org/drawingml/2006/main">
               <a:ext uri="{FF2B5EF4-FFF2-40B4-BE49-F238E27FC236}">
-                <a16:creationId xmlns:a16="http://schemas.microsoft.com/office/drawing/2014/main" id="{C6DE8EDC-D5DF-4C00-B8F3-2221791648EF}"/>
+                <a16:creationId xmlns:a16="http://schemas.microsoft.com/office/drawing/2014/main" id="{A2514DD2-E3F6-41C5-A825-94ABD32BFBCB}"/>
               </a:ext>
             </a:extLst>
           </p:cNvPr>
@@ -14313,7 +14313,7 @@
           <p:cNvPr id="26" name="">
             <a:extLst xmlns:a="http://schemas.openxmlformats.org/drawingml/2006/main">
               <a:ext uri="{FF2B5EF4-FFF2-40B4-BE49-F238E27FC236}">
-                <a16:creationId xmlns:a16="http://schemas.microsoft.com/office/drawing/2014/main" id="{00938F72-49F1-44FD-9655-36965A343390}"/>
+                <a16:creationId xmlns:a16="http://schemas.microsoft.com/office/drawing/2014/main" id="{1026CCA0-4B33-4107-81EF-58AC091185FD}"/>
               </a:ext>
             </a:extLst>
           </p:cNvPr>
@@ -14370,7 +14370,7 @@
           <p:cNvPr id="27" name="">
             <a:extLst xmlns:a="http://schemas.openxmlformats.org/drawingml/2006/main">
               <a:ext uri="{FF2B5EF4-FFF2-40B4-BE49-F238E27FC236}">
-                <a16:creationId xmlns:a16="http://schemas.microsoft.com/office/drawing/2014/main" id="{5161C708-BC12-46CA-B3A6-74B89759ADE0}"/>
+                <a16:creationId xmlns:a16="http://schemas.microsoft.com/office/drawing/2014/main" id="{D3DF4C65-42D6-45C6-9130-484469380DC0}"/>
               </a:ext>
             </a:extLst>
           </p:cNvPr>
@@ -14427,7 +14427,7 @@
           <p:cNvPr id="28" name="">
             <a:extLst xmlns:a="http://schemas.openxmlformats.org/drawingml/2006/main">
               <a:ext uri="{FF2B5EF4-FFF2-40B4-BE49-F238E27FC236}">
-                <a16:creationId xmlns:a16="http://schemas.microsoft.com/office/drawing/2014/main" id="{2A296464-BAA6-49E7-AEF7-420E76FB0382}"/>
+                <a16:creationId xmlns:a16="http://schemas.microsoft.com/office/drawing/2014/main" id="{458860A9-06D8-422B-91A1-34F5228BF6E3}"/>
               </a:ext>
             </a:extLst>
           </p:cNvPr>
@@ -14484,7 +14484,7 @@
           <p:cNvPr id="29" name="">
             <a:extLst xmlns:a="http://schemas.openxmlformats.org/drawingml/2006/main">
               <a:ext uri="{FF2B5EF4-FFF2-40B4-BE49-F238E27FC236}">
-                <a16:creationId xmlns:a16="http://schemas.microsoft.com/office/drawing/2014/main" id="{0205067D-BD28-4795-8272-80C674EAE100}"/>
+                <a16:creationId xmlns:a16="http://schemas.microsoft.com/office/drawing/2014/main" id="{804A0821-A715-4C4E-9D33-FD6B2CF4551D}"/>
               </a:ext>
             </a:extLst>
           </p:cNvPr>
@@ -14541,7 +14541,7 @@
           <p:cNvPr id="30" name="">
             <a:extLst xmlns:a="http://schemas.openxmlformats.org/drawingml/2006/main">
               <a:ext uri="{FF2B5EF4-FFF2-40B4-BE49-F238E27FC236}">
-                <a16:creationId xmlns:a16="http://schemas.microsoft.com/office/drawing/2014/main" id="{5DCF8B5F-58B6-45C1-942F-7C106337BE68}"/>
+                <a16:creationId xmlns:a16="http://schemas.microsoft.com/office/drawing/2014/main" id="{473DAEBF-5530-4E80-AB6C-E11F05616620}"/>
               </a:ext>
             </a:extLst>
           </p:cNvPr>
@@ -14598,7 +14598,7 @@
           <p:cNvPr id="31" name="">
             <a:extLst xmlns:a="http://schemas.openxmlformats.org/drawingml/2006/main">
               <a:ext uri="{FF2B5EF4-FFF2-40B4-BE49-F238E27FC236}">
-                <a16:creationId xmlns:a16="http://schemas.microsoft.com/office/drawing/2014/main" id="{5C9942D2-C7BF-475D-8D81-16CB4830A37E}"/>
+                <a16:creationId xmlns:a16="http://schemas.microsoft.com/office/drawing/2014/main" id="{3BE84C86-C86D-4798-AF3E-CB1A5DCC3052}"/>
               </a:ext>
             </a:extLst>
           </p:cNvPr>
@@ -14655,7 +14655,7 @@
           <p:cNvPr id="32" name="">
             <a:extLst xmlns:a="http://schemas.openxmlformats.org/drawingml/2006/main">
               <a:ext uri="{FF2B5EF4-FFF2-40B4-BE49-F238E27FC236}">
-                <a16:creationId xmlns:a16="http://schemas.microsoft.com/office/drawing/2014/main" id="{A7D9A86E-64A1-4567-BA16-DFA5DB714B89}"/>
+                <a16:creationId xmlns:a16="http://schemas.microsoft.com/office/drawing/2014/main" id="{51C65660-DAB5-46AB-9CE9-A6A53BCA8C10}"/>
               </a:ext>
             </a:extLst>
           </p:cNvPr>
@@ -14689,7 +14689,7 @@
           <p:cNvPr id="33" name="">
             <a:extLst xmlns:a="http://schemas.openxmlformats.org/drawingml/2006/main">
               <a:ext uri="{FF2B5EF4-FFF2-40B4-BE49-F238E27FC236}">
-                <a16:creationId xmlns:a16="http://schemas.microsoft.com/office/drawing/2014/main" id="{5603CCC3-C3FC-48C1-9177-E8A45654C4CC}"/>
+                <a16:creationId xmlns:a16="http://schemas.microsoft.com/office/drawing/2014/main" id="{14AA6935-43B8-4D8A-AF34-6137FFF6FFCF}"/>
               </a:ext>
             </a:extLst>
           </p:cNvPr>
@@ -14723,7 +14723,7 @@
           <p:cNvPr id="34" name="">
             <a:extLst xmlns:a="http://schemas.openxmlformats.org/drawingml/2006/main">
               <a:ext uri="{FF2B5EF4-FFF2-40B4-BE49-F238E27FC236}">
-                <a16:creationId xmlns:a16="http://schemas.microsoft.com/office/drawing/2014/main" id="{EEB14F90-80CE-437A-8F9D-B24F14C07698}"/>
+                <a16:creationId xmlns:a16="http://schemas.microsoft.com/office/drawing/2014/main" id="{510E2D90-C865-407D-A3DA-71E58BADAC64}"/>
               </a:ext>
             </a:extLst>
           </p:cNvPr>
@@ -14780,7 +14780,7 @@
           <p:cNvPr id="35" name="">
             <a:extLst xmlns:a="http://schemas.openxmlformats.org/drawingml/2006/main">
               <a:ext uri="{FF2B5EF4-FFF2-40B4-BE49-F238E27FC236}">
-                <a16:creationId xmlns:a16="http://schemas.microsoft.com/office/drawing/2014/main" id="{904D2E73-2C58-4EA5-A61C-BAF8434AA4FE}"/>
+                <a16:creationId xmlns:a16="http://schemas.microsoft.com/office/drawing/2014/main" id="{A62C31C4-853E-460B-B113-5516BA5F23C3}"/>
               </a:ext>
             </a:extLst>
           </p:cNvPr>
@@ -14835,7 +14835,7 @@
     </p:spTree>
     <p:extLst>
       <p:ext uri="{BB962C8B-B14F-4D97-AF65-F5344CB8AC3E}">
-        <p14:creationId xmlns:p14="http://schemas.microsoft.com/office/powerpoint/2010/main" val="1376660598"/>
+        <p14:creationId xmlns:p14="http://schemas.microsoft.com/office/powerpoint/2010/main" val="612170327"/>
       </p:ext>
     </p:extLst>
   </p:cSld>
@@ -14866,7 +14866,7 @@
           <p:cNvPr id="28" name="">
             <a:extLst xmlns:a="http://schemas.openxmlformats.org/drawingml/2006/main">
               <a:ext uri="{FF2B5EF4-FFF2-40B4-BE49-F238E27FC236}">
-                <a16:creationId xmlns:a16="http://schemas.microsoft.com/office/drawing/2014/main" id="{8A4BA332-3079-467A-82DC-9B8CA734A22D}"/>
+                <a16:creationId xmlns:a16="http://schemas.microsoft.com/office/drawing/2014/main" id="{69EB71BD-B1FF-4165-BF77-5EB490DE755D}"/>
               </a:ext>
             </a:extLst>
           </p:cNvPr>
@@ -14923,7 +14923,7 @@
           <p:cNvPr id="2" name="">
             <a:extLst xmlns:a="http://schemas.openxmlformats.org/drawingml/2006/main">
               <a:ext uri="{FF2B5EF4-FFF2-40B4-BE49-F238E27FC236}">
-                <a16:creationId xmlns:a16="http://schemas.microsoft.com/office/drawing/2014/main" id="{D7057A33-386C-41F9-B06F-72E189C497AE}"/>
+                <a16:creationId xmlns:a16="http://schemas.microsoft.com/office/drawing/2014/main" id="{30225174-5E90-475E-857D-D36DF141F10F}"/>
               </a:ext>
             </a:extLst>
           </p:cNvPr>
@@ -14980,7 +14980,7 @@
           <p:cNvPr id="3" name="">
             <a:extLst xmlns:a="http://schemas.openxmlformats.org/drawingml/2006/main">
               <a:ext uri="{FF2B5EF4-FFF2-40B4-BE49-F238E27FC236}">
-                <a16:creationId xmlns:a16="http://schemas.microsoft.com/office/drawing/2014/main" id="{AC8CDF2A-19EE-4131-9E65-E11DB76AD6D6}"/>
+                <a16:creationId xmlns:a16="http://schemas.microsoft.com/office/drawing/2014/main" id="{B7692D5E-255E-4B51-A79A-52D4DAEAC5FE}"/>
               </a:ext>
             </a:extLst>
           </p:cNvPr>
@@ -15010,7 +15010,7 @@
           <p:cNvPr id="4" name="">
             <a:extLst xmlns:a="http://schemas.openxmlformats.org/drawingml/2006/main">
               <a:ext uri="{FF2B5EF4-FFF2-40B4-BE49-F238E27FC236}">
-                <a16:creationId xmlns:a16="http://schemas.microsoft.com/office/drawing/2014/main" id="{E23D7EE2-F805-418B-8B9B-A35ACFDD30E6}"/>
+                <a16:creationId xmlns:a16="http://schemas.microsoft.com/office/drawing/2014/main" id="{199427C2-5EEA-4C75-9269-AFF8F64F6E13}"/>
               </a:ext>
             </a:extLst>
           </p:cNvPr>
@@ -15067,7 +15067,7 @@
           <p:cNvPr id="5" name="">
             <a:extLst xmlns:a="http://schemas.openxmlformats.org/drawingml/2006/main">
               <a:ext uri="{FF2B5EF4-FFF2-40B4-BE49-F238E27FC236}">
-                <a16:creationId xmlns:a16="http://schemas.microsoft.com/office/drawing/2014/main" id="{E0C7A7E9-6A4D-48E6-82E6-E9E8199DB446}"/>
+                <a16:creationId xmlns:a16="http://schemas.microsoft.com/office/drawing/2014/main" id="{3E5E4AA6-631C-460C-8A76-D01250D383E8}"/>
               </a:ext>
             </a:extLst>
           </p:cNvPr>
@@ -15101,7 +15101,7 @@
           <p:cNvPr id="6" name="">
             <a:extLst xmlns:a="http://schemas.openxmlformats.org/drawingml/2006/main">
               <a:ext uri="{FF2B5EF4-FFF2-40B4-BE49-F238E27FC236}">
-                <a16:creationId xmlns:a16="http://schemas.microsoft.com/office/drawing/2014/main" id="{AFB93A5E-3E09-4E6E-8D04-8AB263EA91B8}"/>
+                <a16:creationId xmlns:a16="http://schemas.microsoft.com/office/drawing/2014/main" id="{F7F66A40-8EE1-47A4-BE13-D28456299029}"/>
               </a:ext>
             </a:extLst>
           </p:cNvPr>
@@ -15158,7 +15158,7 @@
           <p:cNvPr id="7" name="">
             <a:extLst xmlns:a="http://schemas.openxmlformats.org/drawingml/2006/main">
               <a:ext uri="{FF2B5EF4-FFF2-40B4-BE49-F238E27FC236}">
-                <a16:creationId xmlns:a16="http://schemas.microsoft.com/office/drawing/2014/main" id="{7FBE0E0D-3F7A-4BF1-AB49-ECE75A52ECA3}"/>
+                <a16:creationId xmlns:a16="http://schemas.microsoft.com/office/drawing/2014/main" id="{F64E5DFE-AA1F-4500-8448-DA2BE03DD202}"/>
               </a:ext>
             </a:extLst>
           </p:cNvPr>
@@ -15192,7 +15192,7 @@
           <p:cNvPr id="8" name="">
             <a:extLst xmlns:a="http://schemas.openxmlformats.org/drawingml/2006/main">
               <a:ext uri="{FF2B5EF4-FFF2-40B4-BE49-F238E27FC236}">
-                <a16:creationId xmlns:a16="http://schemas.microsoft.com/office/drawing/2014/main" id="{29FA9C14-EA4A-46CE-B4D4-54855C0ADA01}"/>
+                <a16:creationId xmlns:a16="http://schemas.microsoft.com/office/drawing/2014/main" id="{E8B135FD-FE78-4D30-B57B-48E5E602EC2A}"/>
               </a:ext>
             </a:extLst>
           </p:cNvPr>
@@ -15249,7 +15249,7 @@
           <p:cNvPr id="9" name="">
             <a:extLst xmlns:a="http://schemas.openxmlformats.org/drawingml/2006/main">
               <a:ext uri="{FF2B5EF4-FFF2-40B4-BE49-F238E27FC236}">
-                <a16:creationId xmlns:a16="http://schemas.microsoft.com/office/drawing/2014/main" id="{D898CA1E-85C2-414E-9EB8-3EFC66F37A1C}"/>
+                <a16:creationId xmlns:a16="http://schemas.microsoft.com/office/drawing/2014/main" id="{CB446747-A2AB-46DC-B8D1-794031946CB5}"/>
               </a:ext>
             </a:extLst>
           </p:cNvPr>
@@ -15333,7 +15333,7 @@
           <p:cNvPr id="11" name="">
             <a:extLst xmlns:a="http://schemas.openxmlformats.org/drawingml/2006/main">
               <a:ext uri="{FF2B5EF4-FFF2-40B4-BE49-F238E27FC236}">
-                <a16:creationId xmlns:a16="http://schemas.microsoft.com/office/drawing/2014/main" id="{93CB4BC7-D62C-48AB-8089-A4E5F33DEB84}"/>
+                <a16:creationId xmlns:a16="http://schemas.microsoft.com/office/drawing/2014/main" id="{F351A5DD-145B-4317-856B-5D8F410A9044}"/>
               </a:ext>
             </a:extLst>
           </p:cNvPr>
@@ -15367,7 +15367,7 @@
           <p:cNvPr id="12" name="">
             <a:extLst xmlns:a="http://schemas.openxmlformats.org/drawingml/2006/main">
               <a:ext uri="{FF2B5EF4-FFF2-40B4-BE49-F238E27FC236}">
-                <a16:creationId xmlns:a16="http://schemas.microsoft.com/office/drawing/2014/main" id="{29EA9C95-8543-4814-8F5F-846927C8C904}"/>
+                <a16:creationId xmlns:a16="http://schemas.microsoft.com/office/drawing/2014/main" id="{F56D34CA-A151-41FB-9CDD-084E55099B3F}"/>
               </a:ext>
             </a:extLst>
           </p:cNvPr>
@@ -15424,7 +15424,7 @@
           <p:cNvPr id="13" name="">
             <a:extLst xmlns:a="http://schemas.openxmlformats.org/drawingml/2006/main">
               <a:ext uri="{FF2B5EF4-FFF2-40B4-BE49-F238E27FC236}">
-                <a16:creationId xmlns:a16="http://schemas.microsoft.com/office/drawing/2014/main" id="{0593110E-4EDC-4107-A88A-BBF398438B0F}"/>
+                <a16:creationId xmlns:a16="http://schemas.microsoft.com/office/drawing/2014/main" id="{D1C0BD5F-A859-4275-BB26-505D0B0B8889}"/>
               </a:ext>
             </a:extLst>
           </p:cNvPr>
@@ -15508,7 +15508,7 @@
           <p:cNvPr id="15" name="">
             <a:extLst xmlns:a="http://schemas.openxmlformats.org/drawingml/2006/main">
               <a:ext uri="{FF2B5EF4-FFF2-40B4-BE49-F238E27FC236}">
-                <a16:creationId xmlns:a16="http://schemas.microsoft.com/office/drawing/2014/main" id="{8FFA093D-BA3E-4B50-A369-7ACF48FAFAB6}"/>
+                <a16:creationId xmlns:a16="http://schemas.microsoft.com/office/drawing/2014/main" id="{CA2255CB-C26C-4CB7-95A3-61C40DD32293}"/>
               </a:ext>
             </a:extLst>
           </p:cNvPr>
@@ -15542,7 +15542,7 @@
           <p:cNvPr id="16" name="">
             <a:extLst xmlns:a="http://schemas.openxmlformats.org/drawingml/2006/main">
               <a:ext uri="{FF2B5EF4-FFF2-40B4-BE49-F238E27FC236}">
-                <a16:creationId xmlns:a16="http://schemas.microsoft.com/office/drawing/2014/main" id="{2C50E6D0-8B47-4FDE-9AC6-81F7074936D5}"/>
+                <a16:creationId xmlns:a16="http://schemas.microsoft.com/office/drawing/2014/main" id="{37A75D31-34D8-46AD-B4B5-A0E8FD7109FD}"/>
               </a:ext>
             </a:extLst>
           </p:cNvPr>
@@ -15599,7 +15599,7 @@
           <p:cNvPr id="17" name="">
             <a:extLst xmlns:a="http://schemas.openxmlformats.org/drawingml/2006/main">
               <a:ext uri="{FF2B5EF4-FFF2-40B4-BE49-F238E27FC236}">
-                <a16:creationId xmlns:a16="http://schemas.microsoft.com/office/drawing/2014/main" id="{5F47B21E-AE93-4F8B-B77A-B26728DDEA0F}"/>
+                <a16:creationId xmlns:a16="http://schemas.microsoft.com/office/drawing/2014/main" id="{79E3F9D1-E95F-4576-AD99-20A2849E597A}"/>
               </a:ext>
             </a:extLst>
           </p:cNvPr>
@@ -15683,7 +15683,7 @@
           <p:cNvPr id="19" name="">
             <a:extLst xmlns:a="http://schemas.openxmlformats.org/drawingml/2006/main">
               <a:ext uri="{FF2B5EF4-FFF2-40B4-BE49-F238E27FC236}">
-                <a16:creationId xmlns:a16="http://schemas.microsoft.com/office/drawing/2014/main" id="{FA06B7F6-8EA4-494E-98D5-94DEADDEDF7A}"/>
+                <a16:creationId xmlns:a16="http://schemas.microsoft.com/office/drawing/2014/main" id="{62574D58-8482-46B4-AA2A-3786D684BE02}"/>
               </a:ext>
             </a:extLst>
           </p:cNvPr>
@@ -15717,7 +15717,7 @@
           <p:cNvPr id="20" name="">
             <a:extLst xmlns:a="http://schemas.openxmlformats.org/drawingml/2006/main">
               <a:ext uri="{FF2B5EF4-FFF2-40B4-BE49-F238E27FC236}">
-                <a16:creationId xmlns:a16="http://schemas.microsoft.com/office/drawing/2014/main" id="{06F9B6F7-A279-4775-B9AD-83792639255D}"/>
+                <a16:creationId xmlns:a16="http://schemas.microsoft.com/office/drawing/2014/main" id="{A4838F47-8BCA-4169-AD2B-2AD6AF8D94AF}"/>
               </a:ext>
             </a:extLst>
           </p:cNvPr>
@@ -15774,7 +15774,7 @@
           <p:cNvPr id="21" name="">
             <a:extLst xmlns:a="http://schemas.openxmlformats.org/drawingml/2006/main">
               <a:ext uri="{FF2B5EF4-FFF2-40B4-BE49-F238E27FC236}">
-                <a16:creationId xmlns:a16="http://schemas.microsoft.com/office/drawing/2014/main" id="{26228084-20C9-4F0F-9E10-E50ED234D3E3}"/>
+                <a16:creationId xmlns:a16="http://schemas.microsoft.com/office/drawing/2014/main" id="{50E9B8DA-CDD3-490A-B28D-E335543AD6C9}"/>
               </a:ext>
             </a:extLst>
           </p:cNvPr>
@@ -15858,7 +15858,7 @@
           <p:cNvPr id="23" name="">
             <a:extLst xmlns:a="http://schemas.openxmlformats.org/drawingml/2006/main">
               <a:ext uri="{FF2B5EF4-FFF2-40B4-BE49-F238E27FC236}">
-                <a16:creationId xmlns:a16="http://schemas.microsoft.com/office/drawing/2014/main" id="{E3C2EBC1-6A4B-48A4-BFE2-591BD4D90092}"/>
+                <a16:creationId xmlns:a16="http://schemas.microsoft.com/office/drawing/2014/main" id="{E05CD755-D47B-41A1-B38C-8EE93FD688DC}"/>
               </a:ext>
             </a:extLst>
           </p:cNvPr>
@@ -15892,7 +15892,7 @@
           <p:cNvPr id="24" name="">
             <a:extLst xmlns:a="http://schemas.openxmlformats.org/drawingml/2006/main">
               <a:ext uri="{FF2B5EF4-FFF2-40B4-BE49-F238E27FC236}">
-                <a16:creationId xmlns:a16="http://schemas.microsoft.com/office/drawing/2014/main" id="{3B3B1C96-69AC-45B2-94D7-CE9D3A5C052A}"/>
+                <a16:creationId xmlns:a16="http://schemas.microsoft.com/office/drawing/2014/main" id="{AA432F2D-7F61-4B27-9128-DF6875C57B4D}"/>
               </a:ext>
             </a:extLst>
           </p:cNvPr>
@@ -15926,7 +15926,7 @@
           <p:cNvPr id="25" name="">
             <a:extLst xmlns:a="http://schemas.openxmlformats.org/drawingml/2006/main">
               <a:ext uri="{FF2B5EF4-FFF2-40B4-BE49-F238E27FC236}">
-                <a16:creationId xmlns:a16="http://schemas.microsoft.com/office/drawing/2014/main" id="{497A15EA-C96E-4577-A76D-71091B9E5BE5}"/>
+                <a16:creationId xmlns:a16="http://schemas.microsoft.com/office/drawing/2014/main" id="{95A046BE-E73B-4721-818D-17534DA0222E}"/>
               </a:ext>
             </a:extLst>
           </p:cNvPr>
@@ -15983,7 +15983,7 @@
           <p:cNvPr id="26" name="">
             <a:extLst xmlns:a="http://schemas.openxmlformats.org/drawingml/2006/main">
               <a:ext uri="{FF2B5EF4-FFF2-40B4-BE49-F238E27FC236}">
-                <a16:creationId xmlns:a16="http://schemas.microsoft.com/office/drawing/2014/main" id="{78123BB7-F772-4609-8668-C6A7815BF398}"/>
+                <a16:creationId xmlns:a16="http://schemas.microsoft.com/office/drawing/2014/main" id="{FE0B12B2-7D6F-4AC0-8633-389CEC7EBF3B}"/>
               </a:ext>
             </a:extLst>
           </p:cNvPr>
@@ -16040,7 +16040,7 @@
           <p:cNvPr id="27" name="">
             <a:extLst xmlns:a="http://schemas.openxmlformats.org/drawingml/2006/main">
               <a:ext uri="{FF2B5EF4-FFF2-40B4-BE49-F238E27FC236}">
-                <a16:creationId xmlns:a16="http://schemas.microsoft.com/office/drawing/2014/main" id="{57F24AB7-39A3-452F-9C42-81D80A8DCF6F}"/>
+                <a16:creationId xmlns:a16="http://schemas.microsoft.com/office/drawing/2014/main" id="{461B47F2-AFAB-4BD4-8384-2D563699799E}"/>
               </a:ext>
             </a:extLst>
           </p:cNvPr>
@@ -16095,7 +16095,7 @@
     </p:spTree>
     <p:extLst>
       <p:ext uri="{BB962C8B-B14F-4D97-AF65-F5344CB8AC3E}">
-        <p14:creationId xmlns:p14="http://schemas.microsoft.com/office/powerpoint/2010/main" val="624474588"/>
+        <p14:creationId xmlns:p14="http://schemas.microsoft.com/office/powerpoint/2010/main" val="1815373096"/>
       </p:ext>
     </p:extLst>
   </p:cSld>
@@ -16126,7 +16126,7 @@
           <p:cNvPr id="26" name="">
             <a:extLst xmlns:a="http://schemas.openxmlformats.org/drawingml/2006/main">
               <a:ext uri="{FF2B5EF4-FFF2-40B4-BE49-F238E27FC236}">
-                <a16:creationId xmlns:a16="http://schemas.microsoft.com/office/drawing/2014/main" id="{1BBA773C-07A0-4A46-B8AB-8E6B9D062B5F}"/>
+                <a16:creationId xmlns:a16="http://schemas.microsoft.com/office/drawing/2014/main" id="{79C8D28E-4D87-463B-BDAC-52CD23434868}"/>
               </a:ext>
             </a:extLst>
           </p:cNvPr>
@@ -16183,7 +16183,7 @@
           <p:cNvPr id="2" name="">
             <a:extLst xmlns:a="http://schemas.openxmlformats.org/drawingml/2006/main">
               <a:ext uri="{FF2B5EF4-FFF2-40B4-BE49-F238E27FC236}">
-                <a16:creationId xmlns:a16="http://schemas.microsoft.com/office/drawing/2014/main" id="{5D9D3E89-EBE3-4AE0-AB2E-BE6B1B8A56D8}"/>
+                <a16:creationId xmlns:a16="http://schemas.microsoft.com/office/drawing/2014/main" id="{EAB012A3-0A77-406F-BD7C-F1624D296A06}"/>
               </a:ext>
             </a:extLst>
           </p:cNvPr>
@@ -16240,7 +16240,7 @@
           <p:cNvPr id="3" name="">
             <a:extLst xmlns:a="http://schemas.openxmlformats.org/drawingml/2006/main">
               <a:ext uri="{FF2B5EF4-FFF2-40B4-BE49-F238E27FC236}">
-                <a16:creationId xmlns:a16="http://schemas.microsoft.com/office/drawing/2014/main" id="{8E107124-CD9E-4BF7-9B0D-A93439C8F802}"/>
+                <a16:creationId xmlns:a16="http://schemas.microsoft.com/office/drawing/2014/main" id="{9DA24A1A-6FFC-476C-972E-37BCDBB92DC4}"/>
               </a:ext>
             </a:extLst>
           </p:cNvPr>
@@ -16270,7 +16270,7 @@
           <p:cNvPr id="4" name="">
             <a:extLst xmlns:a="http://schemas.openxmlformats.org/drawingml/2006/main">
               <a:ext uri="{FF2B5EF4-FFF2-40B4-BE49-F238E27FC236}">
-                <a16:creationId xmlns:a16="http://schemas.microsoft.com/office/drawing/2014/main" id="{DEB8487B-FD61-407C-8D6C-3010F01A6B55}"/>
+                <a16:creationId xmlns:a16="http://schemas.microsoft.com/office/drawing/2014/main" id="{6A0CA949-A1BF-42AA-A98A-1EEEA9FFE434}"/>
               </a:ext>
             </a:extLst>
           </p:cNvPr>
@@ -16327,7 +16327,7 @@
           <p:cNvPr id="5" name="">
             <a:extLst xmlns:a="http://schemas.openxmlformats.org/drawingml/2006/main">
               <a:ext uri="{FF2B5EF4-FFF2-40B4-BE49-F238E27FC236}">
-                <a16:creationId xmlns:a16="http://schemas.microsoft.com/office/drawing/2014/main" id="{220B5A3F-99D3-40D2-9AFC-C10D9402DFB2}"/>
+                <a16:creationId xmlns:a16="http://schemas.microsoft.com/office/drawing/2014/main" id="{52FA2B72-49CD-43F2-8F23-8D6F994F6E11}"/>
               </a:ext>
             </a:extLst>
           </p:cNvPr>
@@ -16384,7 +16384,7 @@
           <p:cNvPr id="6" name="">
             <a:extLst xmlns:a="http://schemas.openxmlformats.org/drawingml/2006/main">
               <a:ext uri="{FF2B5EF4-FFF2-40B4-BE49-F238E27FC236}">
-                <a16:creationId xmlns:a16="http://schemas.microsoft.com/office/drawing/2014/main" id="{D6071152-812B-40A0-A7C8-0E22F69185AD}"/>
+                <a16:creationId xmlns:a16="http://schemas.microsoft.com/office/drawing/2014/main" id="{CBC741E9-6EAD-4514-8EEE-2F5BA84204FA}"/>
               </a:ext>
             </a:extLst>
           </p:cNvPr>
@@ -16441,7 +16441,7 @@
           <p:cNvPr id="7" name="">
             <a:extLst xmlns:a="http://schemas.openxmlformats.org/drawingml/2006/main">
               <a:ext uri="{FF2B5EF4-FFF2-40B4-BE49-F238E27FC236}">
-                <a16:creationId xmlns:a16="http://schemas.microsoft.com/office/drawing/2014/main" id="{BE0629FA-1627-4DE7-9F1A-9F906A4DC91A}"/>
+                <a16:creationId xmlns:a16="http://schemas.microsoft.com/office/drawing/2014/main" id="{EEF64D84-0E34-481B-B8B6-97FDFCE9F737}"/>
               </a:ext>
             </a:extLst>
           </p:cNvPr>
@@ -16475,7 +16475,7 @@
           <p:cNvPr id="8" name="">
             <a:extLst xmlns:a="http://schemas.openxmlformats.org/drawingml/2006/main">
               <a:ext uri="{FF2B5EF4-FFF2-40B4-BE49-F238E27FC236}">
-                <a16:creationId xmlns:a16="http://schemas.microsoft.com/office/drawing/2014/main" id="{9EDD106C-6F27-4336-B744-89A8EBA5832E}"/>
+                <a16:creationId xmlns:a16="http://schemas.microsoft.com/office/drawing/2014/main" id="{431F9887-5045-486A-A84D-A030D1336CBE}"/>
               </a:ext>
             </a:extLst>
           </p:cNvPr>
@@ -16532,7 +16532,7 @@
           <p:cNvPr id="9" name="">
             <a:extLst xmlns:a="http://schemas.openxmlformats.org/drawingml/2006/main">
               <a:ext uri="{FF2B5EF4-FFF2-40B4-BE49-F238E27FC236}">
-                <a16:creationId xmlns:a16="http://schemas.microsoft.com/office/drawing/2014/main" id="{6B2A6BA9-9480-431E-A8FB-ACD1D07A1655}"/>
+                <a16:creationId xmlns:a16="http://schemas.microsoft.com/office/drawing/2014/main" id="{13A160FC-F037-4F44-80BA-366D7D857B25}"/>
               </a:ext>
             </a:extLst>
           </p:cNvPr>
@@ -16589,7 +16589,7 @@
           <p:cNvPr id="10" name="">
             <a:extLst xmlns:a="http://schemas.openxmlformats.org/drawingml/2006/main">
               <a:ext uri="{FF2B5EF4-FFF2-40B4-BE49-F238E27FC236}">
-                <a16:creationId xmlns:a16="http://schemas.microsoft.com/office/drawing/2014/main" id="{7133BEC3-02FF-4154-8D8C-325156D3A661}"/>
+                <a16:creationId xmlns:a16="http://schemas.microsoft.com/office/drawing/2014/main" id="{826F74AC-9100-4B57-85F3-0F2A263A7EF4}"/>
               </a:ext>
             </a:extLst>
           </p:cNvPr>
@@ -16623,7 +16623,7 @@
           <p:cNvPr id="11" name="">
             <a:extLst xmlns:a="http://schemas.openxmlformats.org/drawingml/2006/main">
               <a:ext uri="{FF2B5EF4-FFF2-40B4-BE49-F238E27FC236}">
-                <a16:creationId xmlns:a16="http://schemas.microsoft.com/office/drawing/2014/main" id="{ADF8DA01-B140-4F0A-A769-BA2D46E2D2D6}"/>
+                <a16:creationId xmlns:a16="http://schemas.microsoft.com/office/drawing/2014/main" id="{7D4E15CE-609B-46B5-BBD9-0A2FCAC7FAB1}"/>
               </a:ext>
             </a:extLst>
           </p:cNvPr>
@@ -16680,7 +16680,7 @@
           <p:cNvPr id="12" name="">
             <a:extLst xmlns:a="http://schemas.openxmlformats.org/drawingml/2006/main">
               <a:ext uri="{FF2B5EF4-FFF2-40B4-BE49-F238E27FC236}">
-                <a16:creationId xmlns:a16="http://schemas.microsoft.com/office/drawing/2014/main" id="{EA2D5146-4A4D-4BAB-9E24-8E9CB1825422}"/>
+                <a16:creationId xmlns:a16="http://schemas.microsoft.com/office/drawing/2014/main" id="{C1C5F561-8DF0-4666-A2FB-AD9A5265F015}"/>
               </a:ext>
             </a:extLst>
           </p:cNvPr>
@@ -16737,7 +16737,7 @@
           <p:cNvPr id="13" name="">
             <a:extLst xmlns:a="http://schemas.openxmlformats.org/drawingml/2006/main">
               <a:ext uri="{FF2B5EF4-FFF2-40B4-BE49-F238E27FC236}">
-                <a16:creationId xmlns:a16="http://schemas.microsoft.com/office/drawing/2014/main" id="{24001046-B0C1-4DD3-9937-2C3BA40872CA}"/>
+                <a16:creationId xmlns:a16="http://schemas.microsoft.com/office/drawing/2014/main" id="{AD2DF9A2-A0F0-4A9D-9E01-BD00401CAF8D}"/>
               </a:ext>
             </a:extLst>
           </p:cNvPr>
@@ -16771,7 +16771,7 @@
           <p:cNvPr id="14" name="">
             <a:extLst xmlns:a="http://schemas.openxmlformats.org/drawingml/2006/main">
               <a:ext uri="{FF2B5EF4-FFF2-40B4-BE49-F238E27FC236}">
-                <a16:creationId xmlns:a16="http://schemas.microsoft.com/office/drawing/2014/main" id="{2CD3C49C-A9E0-4DB3-9BC8-4BA8D05F453B}"/>
+                <a16:creationId xmlns:a16="http://schemas.microsoft.com/office/drawing/2014/main" id="{6C355181-4E41-47C4-AF91-3D5CADCFF847}"/>
               </a:ext>
             </a:extLst>
           </p:cNvPr>
@@ -16828,7 +16828,7 @@
           <p:cNvPr id="15" name="">
             <a:extLst xmlns:a="http://schemas.openxmlformats.org/drawingml/2006/main">
               <a:ext uri="{FF2B5EF4-FFF2-40B4-BE49-F238E27FC236}">
-                <a16:creationId xmlns:a16="http://schemas.microsoft.com/office/drawing/2014/main" id="{251BC9D4-C475-4D02-99B8-2A85A47C4BF0}"/>
+                <a16:creationId xmlns:a16="http://schemas.microsoft.com/office/drawing/2014/main" id="{4411AFF5-3119-4130-9A0C-4FFD9A286753}"/>
               </a:ext>
             </a:extLst>
           </p:cNvPr>
@@ -16885,7 +16885,7 @@
           <p:cNvPr id="16" name="">
             <a:extLst xmlns:a="http://schemas.openxmlformats.org/drawingml/2006/main">
               <a:ext uri="{FF2B5EF4-FFF2-40B4-BE49-F238E27FC236}">
-                <a16:creationId xmlns:a16="http://schemas.microsoft.com/office/drawing/2014/main" id="{F27961D7-6523-42E3-9EB2-9A9F6900FF41}"/>
+                <a16:creationId xmlns:a16="http://schemas.microsoft.com/office/drawing/2014/main" id="{2EAFA1EF-5EF6-49C8-B397-583F74103E63}"/>
               </a:ext>
             </a:extLst>
           </p:cNvPr>
@@ -16919,7 +16919,7 @@
           <p:cNvPr id="17" name="">
             <a:extLst xmlns:a="http://schemas.openxmlformats.org/drawingml/2006/main">
               <a:ext uri="{FF2B5EF4-FFF2-40B4-BE49-F238E27FC236}">
-                <a16:creationId xmlns:a16="http://schemas.microsoft.com/office/drawing/2014/main" id="{14C862AA-8384-4781-933B-57F98C953E60}"/>
+                <a16:creationId xmlns:a16="http://schemas.microsoft.com/office/drawing/2014/main" id="{FDF9AE8E-973F-4451-B008-428BDFF3AF74}"/>
               </a:ext>
             </a:extLst>
           </p:cNvPr>
@@ -16976,7 +16976,7 @@
           <p:cNvPr id="18" name="">
             <a:extLst xmlns:a="http://schemas.openxmlformats.org/drawingml/2006/main">
               <a:ext uri="{FF2B5EF4-FFF2-40B4-BE49-F238E27FC236}">
-                <a16:creationId xmlns:a16="http://schemas.microsoft.com/office/drawing/2014/main" id="{A71FAF76-D946-4DEE-9F49-4DBECF6BEEA3}"/>
+                <a16:creationId xmlns:a16="http://schemas.microsoft.com/office/drawing/2014/main" id="{6F4DD455-04DF-4A35-BFC3-2943C0BE6F7B}"/>
               </a:ext>
             </a:extLst>
           </p:cNvPr>
@@ -17108,7 +17108,7 @@
           <p:cNvPr id="22" name="">
             <a:extLst xmlns:a="http://schemas.openxmlformats.org/drawingml/2006/main">
               <a:ext uri="{FF2B5EF4-FFF2-40B4-BE49-F238E27FC236}">
-                <a16:creationId xmlns:a16="http://schemas.microsoft.com/office/drawing/2014/main" id="{7D9FC236-5DBF-4626-8B92-73E87186A9A4}"/>
+                <a16:creationId xmlns:a16="http://schemas.microsoft.com/office/drawing/2014/main" id="{EA81267C-F047-44BD-99EA-14E7A829C69E}"/>
               </a:ext>
             </a:extLst>
           </p:cNvPr>
@@ -17142,7 +17142,7 @@
           <p:cNvPr id="23" name="">
             <a:extLst xmlns:a="http://schemas.openxmlformats.org/drawingml/2006/main">
               <a:ext uri="{FF2B5EF4-FFF2-40B4-BE49-F238E27FC236}">
-                <a16:creationId xmlns:a16="http://schemas.microsoft.com/office/drawing/2014/main" id="{2A33C8B9-2801-463D-AD8D-C1931E42FC38}"/>
+                <a16:creationId xmlns:a16="http://schemas.microsoft.com/office/drawing/2014/main" id="{9504D400-60DE-4158-B6BD-E9E8F382BF53}"/>
               </a:ext>
             </a:extLst>
           </p:cNvPr>
@@ -17176,7 +17176,7 @@
           <p:cNvPr id="24" name="">
             <a:extLst xmlns:a="http://schemas.openxmlformats.org/drawingml/2006/main">
               <a:ext uri="{FF2B5EF4-FFF2-40B4-BE49-F238E27FC236}">
-                <a16:creationId xmlns:a16="http://schemas.microsoft.com/office/drawing/2014/main" id="{83A158CB-4044-4E86-BBED-45CF262798FB}"/>
+                <a16:creationId xmlns:a16="http://schemas.microsoft.com/office/drawing/2014/main" id="{DA971BA9-C90F-4B9D-B8CE-0EF5B73272A6}"/>
               </a:ext>
             </a:extLst>
           </p:cNvPr>
@@ -17233,7 +17233,7 @@
           <p:cNvPr id="25" name="">
             <a:extLst xmlns:a="http://schemas.openxmlformats.org/drawingml/2006/main">
               <a:ext uri="{FF2B5EF4-FFF2-40B4-BE49-F238E27FC236}">
-                <a16:creationId xmlns:a16="http://schemas.microsoft.com/office/drawing/2014/main" id="{AA4DEE52-E97A-45DB-A06D-0CC096B8FA22}"/>
+                <a16:creationId xmlns:a16="http://schemas.microsoft.com/office/drawing/2014/main" id="{9DEEAA85-E680-4229-B775-9A27D650F5A4}"/>
               </a:ext>
             </a:extLst>
           </p:cNvPr>
@@ -17288,7 +17288,7 @@
     </p:spTree>
     <p:extLst>
       <p:ext uri="{BB962C8B-B14F-4D97-AF65-F5344CB8AC3E}">
-        <p14:creationId xmlns:p14="http://schemas.microsoft.com/office/powerpoint/2010/main" val="1249586298"/>
+        <p14:creationId xmlns:p14="http://schemas.microsoft.com/office/powerpoint/2010/main" val="525618861"/>
       </p:ext>
     </p:extLst>
   </p:cSld>
@@ -17319,7 +17319,7 @@
           <p:cNvPr id="31" name="">
             <a:extLst xmlns:a="http://schemas.openxmlformats.org/drawingml/2006/main">
               <a:ext uri="{FF2B5EF4-FFF2-40B4-BE49-F238E27FC236}">
-                <a16:creationId xmlns:a16="http://schemas.microsoft.com/office/drawing/2014/main" id="{FC0E2644-2B67-47E5-8B88-A4DD6E701023}"/>
+                <a16:creationId xmlns:a16="http://schemas.microsoft.com/office/drawing/2014/main" id="{4EB315E7-1E59-4D7C-A9B3-797C2C2153BA}"/>
               </a:ext>
             </a:extLst>
           </p:cNvPr>
@@ -17376,7 +17376,7 @@
           <p:cNvPr id="2" name="">
             <a:extLst xmlns:a="http://schemas.openxmlformats.org/drawingml/2006/main">
               <a:ext uri="{FF2B5EF4-FFF2-40B4-BE49-F238E27FC236}">
-                <a16:creationId xmlns:a16="http://schemas.microsoft.com/office/drawing/2014/main" id="{D20E79A8-62FA-470C-A9FF-EE80953BA346}"/>
+                <a16:creationId xmlns:a16="http://schemas.microsoft.com/office/drawing/2014/main" id="{795AD452-C232-499D-8234-F281B6B636E7}"/>
               </a:ext>
             </a:extLst>
           </p:cNvPr>
@@ -17433,7 +17433,7 @@
           <p:cNvPr id="3" name="">
             <a:extLst xmlns:a="http://schemas.openxmlformats.org/drawingml/2006/main">
               <a:ext uri="{FF2B5EF4-FFF2-40B4-BE49-F238E27FC236}">
-                <a16:creationId xmlns:a16="http://schemas.microsoft.com/office/drawing/2014/main" id="{97C297D8-AC32-49AB-B63E-FFA07B8E2E1B}"/>
+                <a16:creationId xmlns:a16="http://schemas.microsoft.com/office/drawing/2014/main" id="{C39260EA-39CB-4F65-8E5D-6A1835FE538F}"/>
               </a:ext>
             </a:extLst>
           </p:cNvPr>
@@ -17463,7 +17463,7 @@
           <p:cNvPr id="4" name="">
             <a:extLst xmlns:a="http://schemas.openxmlformats.org/drawingml/2006/main">
               <a:ext uri="{FF2B5EF4-FFF2-40B4-BE49-F238E27FC236}">
-                <a16:creationId xmlns:a16="http://schemas.microsoft.com/office/drawing/2014/main" id="{3AACEC9B-6ECE-4B3A-A9D0-E569FFB46348}"/>
+                <a16:creationId xmlns:a16="http://schemas.microsoft.com/office/drawing/2014/main" id="{866FB5C8-53A1-490B-A839-DBCB142EB0A9}"/>
               </a:ext>
             </a:extLst>
           </p:cNvPr>
@@ -17520,7 +17520,7 @@
           <p:cNvPr id="5" name="">
             <a:extLst xmlns:a="http://schemas.openxmlformats.org/drawingml/2006/main">
               <a:ext uri="{FF2B5EF4-FFF2-40B4-BE49-F238E27FC236}">
-                <a16:creationId xmlns:a16="http://schemas.microsoft.com/office/drawing/2014/main" id="{22EEBCCF-61A4-4921-8361-EF4865A77D1C}"/>
+                <a16:creationId xmlns:a16="http://schemas.microsoft.com/office/drawing/2014/main" id="{12F950ED-9E70-467D-A5FC-6C48ADB3A742}"/>
               </a:ext>
             </a:extLst>
           </p:cNvPr>
@@ -17577,7 +17577,7 @@
           <p:cNvPr id="6" name="">
             <a:extLst xmlns:a="http://schemas.openxmlformats.org/drawingml/2006/main">
               <a:ext uri="{FF2B5EF4-FFF2-40B4-BE49-F238E27FC236}">
-                <a16:creationId xmlns:a16="http://schemas.microsoft.com/office/drawing/2014/main" id="{3D72E52C-D135-469B-B6C9-243EA1329686}"/>
+                <a16:creationId xmlns:a16="http://schemas.microsoft.com/office/drawing/2014/main" id="{D587D81A-8E63-4F81-8E3A-387BF51D5E44}"/>
               </a:ext>
             </a:extLst>
           </p:cNvPr>
@@ -17634,7 +17634,7 @@
           <p:cNvPr id="7" name="">
             <a:extLst xmlns:a="http://schemas.openxmlformats.org/drawingml/2006/main">
               <a:ext uri="{FF2B5EF4-FFF2-40B4-BE49-F238E27FC236}">
-                <a16:creationId xmlns:a16="http://schemas.microsoft.com/office/drawing/2014/main" id="{79F3DF11-666D-414D-9820-97B0F71343D2}"/>
+                <a16:creationId xmlns:a16="http://schemas.microsoft.com/office/drawing/2014/main" id="{40D2C5D3-43B8-4F03-A8C9-82F0F8AE67C9}"/>
               </a:ext>
             </a:extLst>
           </p:cNvPr>
@@ -17668,7 +17668,7 @@
           <p:cNvPr id="8" name="">
             <a:extLst xmlns:a="http://schemas.openxmlformats.org/drawingml/2006/main">
               <a:ext uri="{FF2B5EF4-FFF2-40B4-BE49-F238E27FC236}">
-                <a16:creationId xmlns:a16="http://schemas.microsoft.com/office/drawing/2014/main" id="{B06BF875-136F-4FAD-91DC-83E829D87C2C}"/>
+                <a16:creationId xmlns:a16="http://schemas.microsoft.com/office/drawing/2014/main" id="{9D1CF93D-74EB-42E2-B523-E4C81EF32050}"/>
               </a:ext>
             </a:extLst>
           </p:cNvPr>
@@ -17725,7 +17725,7 @@
           <p:cNvPr id="9" name="">
             <a:extLst xmlns:a="http://schemas.openxmlformats.org/drawingml/2006/main">
               <a:ext uri="{FF2B5EF4-FFF2-40B4-BE49-F238E27FC236}">
-                <a16:creationId xmlns:a16="http://schemas.microsoft.com/office/drawing/2014/main" id="{0AA61E9C-3C13-4B4C-B98B-7B358ECC6DC7}"/>
+                <a16:creationId xmlns:a16="http://schemas.microsoft.com/office/drawing/2014/main" id="{549C7136-4185-44D4-8EC7-9061655CE926}"/>
               </a:ext>
             </a:extLst>
           </p:cNvPr>
@@ -17782,7 +17782,7 @@
           <p:cNvPr id="10" name="">
             <a:extLst xmlns:a="http://schemas.openxmlformats.org/drawingml/2006/main">
               <a:ext uri="{FF2B5EF4-FFF2-40B4-BE49-F238E27FC236}">
-                <a16:creationId xmlns:a16="http://schemas.microsoft.com/office/drawing/2014/main" id="{2792B023-F805-4E29-9308-DD70500B5526}"/>
+                <a16:creationId xmlns:a16="http://schemas.microsoft.com/office/drawing/2014/main" id="{EF0CF620-E32B-48BE-94B8-3180439DBB8D}"/>
               </a:ext>
             </a:extLst>
           </p:cNvPr>
@@ -17816,7 +17816,7 @@
           <p:cNvPr id="11" name="">
             <a:extLst xmlns:a="http://schemas.openxmlformats.org/drawingml/2006/main">
               <a:ext uri="{FF2B5EF4-FFF2-40B4-BE49-F238E27FC236}">
-                <a16:creationId xmlns:a16="http://schemas.microsoft.com/office/drawing/2014/main" id="{DF135AAE-75A7-4873-A4A7-96A685B41E6A}"/>
+                <a16:creationId xmlns:a16="http://schemas.microsoft.com/office/drawing/2014/main" id="{799EF0B9-5C40-4BE8-9AD9-F32094DF8F1F}"/>
               </a:ext>
             </a:extLst>
           </p:cNvPr>
@@ -17873,7 +17873,7 @@
           <p:cNvPr id="12" name="">
             <a:extLst xmlns:a="http://schemas.openxmlformats.org/drawingml/2006/main">
               <a:ext uri="{FF2B5EF4-FFF2-40B4-BE49-F238E27FC236}">
-                <a16:creationId xmlns:a16="http://schemas.microsoft.com/office/drawing/2014/main" id="{ECEE4F97-59C3-4B4D-93B2-D013D68F47F2}"/>
+                <a16:creationId xmlns:a16="http://schemas.microsoft.com/office/drawing/2014/main" id="{84EFB88D-2136-49F9-8660-2BCC966B43E1}"/>
               </a:ext>
             </a:extLst>
           </p:cNvPr>
@@ -17930,7 +17930,7 @@
           <p:cNvPr id="13" name="">
             <a:extLst xmlns:a="http://schemas.openxmlformats.org/drawingml/2006/main">
               <a:ext uri="{FF2B5EF4-FFF2-40B4-BE49-F238E27FC236}">
-                <a16:creationId xmlns:a16="http://schemas.microsoft.com/office/drawing/2014/main" id="{EB08F161-AF26-434E-B69E-1FF1E1DDAF6E}"/>
+                <a16:creationId xmlns:a16="http://schemas.microsoft.com/office/drawing/2014/main" id="{B5F6ADB2-382E-4780-8765-C5E85050405C}"/>
               </a:ext>
             </a:extLst>
           </p:cNvPr>
@@ -18013,7 +18013,7 @@
           <p:cNvPr id="15" name="">
             <a:extLst xmlns:a="http://schemas.openxmlformats.org/drawingml/2006/main">
               <a:ext uri="{FF2B5EF4-FFF2-40B4-BE49-F238E27FC236}">
-                <a16:creationId xmlns:a16="http://schemas.microsoft.com/office/drawing/2014/main" id="{12B0F435-E256-4DF8-842D-073F3F2C6A2A}"/>
+                <a16:creationId xmlns:a16="http://schemas.microsoft.com/office/drawing/2014/main" id="{8E949AD6-3948-4D15-A62D-5619005F76BC}"/>
               </a:ext>
             </a:extLst>
           </p:cNvPr>
@@ -18047,7 +18047,7 @@
           <p:cNvPr id="16" name="">
             <a:extLst xmlns:a="http://schemas.openxmlformats.org/drawingml/2006/main">
               <a:ext uri="{FF2B5EF4-FFF2-40B4-BE49-F238E27FC236}">
-                <a16:creationId xmlns:a16="http://schemas.microsoft.com/office/drawing/2014/main" id="{EC73246A-BC48-4ECC-A052-AFB2429CA74F}"/>
+                <a16:creationId xmlns:a16="http://schemas.microsoft.com/office/drawing/2014/main" id="{8781DE27-0CB2-4182-8AE9-D21A79F6DDBB}"/>
               </a:ext>
             </a:extLst>
           </p:cNvPr>
@@ -18104,7 +18104,7 @@
           <p:cNvPr id="17" name="">
             <a:extLst xmlns:a="http://schemas.openxmlformats.org/drawingml/2006/main">
               <a:ext uri="{FF2B5EF4-FFF2-40B4-BE49-F238E27FC236}">
-                <a16:creationId xmlns:a16="http://schemas.microsoft.com/office/drawing/2014/main" id="{4214B039-930E-4F4C-B8C4-C8B854248FC7}"/>
+                <a16:creationId xmlns:a16="http://schemas.microsoft.com/office/drawing/2014/main" id="{7FEA983E-8890-46E3-B75F-7C8259E855E7}"/>
               </a:ext>
             </a:extLst>
           </p:cNvPr>
@@ -18161,7 +18161,7 @@
           <p:cNvPr id="18" name="">
             <a:extLst xmlns:a="http://schemas.openxmlformats.org/drawingml/2006/main">
               <a:ext uri="{FF2B5EF4-FFF2-40B4-BE49-F238E27FC236}">
-                <a16:creationId xmlns:a16="http://schemas.microsoft.com/office/drawing/2014/main" id="{7EAFE0F9-4C41-4D0C-987B-05E1F650AC87}"/>
+                <a16:creationId xmlns:a16="http://schemas.microsoft.com/office/drawing/2014/main" id="{9519E8EB-1D66-4F52-9AB5-AE0B1C8F4FD2}"/>
               </a:ext>
             </a:extLst>
           </p:cNvPr>
@@ -18244,7 +18244,7 @@
           <p:cNvPr id="20" name="">
             <a:extLst xmlns:a="http://schemas.openxmlformats.org/drawingml/2006/main">
               <a:ext uri="{FF2B5EF4-FFF2-40B4-BE49-F238E27FC236}">
-                <a16:creationId xmlns:a16="http://schemas.microsoft.com/office/drawing/2014/main" id="{461EC37C-2FC8-4F00-9866-267811F224C3}"/>
+                <a16:creationId xmlns:a16="http://schemas.microsoft.com/office/drawing/2014/main" id="{FEF5894F-93AF-4FCF-86A2-14258CD59433}"/>
               </a:ext>
             </a:extLst>
           </p:cNvPr>
@@ -18278,7 +18278,7 @@
           <p:cNvPr id="21" name="">
             <a:extLst xmlns:a="http://schemas.openxmlformats.org/drawingml/2006/main">
               <a:ext uri="{FF2B5EF4-FFF2-40B4-BE49-F238E27FC236}">
-                <a16:creationId xmlns:a16="http://schemas.microsoft.com/office/drawing/2014/main" id="{76B11F47-0DF1-4B72-9B69-8494A8E923C4}"/>
+                <a16:creationId xmlns:a16="http://schemas.microsoft.com/office/drawing/2014/main" id="{F901E790-2283-4AFD-A262-4999EE87ADAD}"/>
               </a:ext>
             </a:extLst>
           </p:cNvPr>
@@ -18335,7 +18335,7 @@
           <p:cNvPr id="22" name="">
             <a:extLst xmlns:a="http://schemas.openxmlformats.org/drawingml/2006/main">
               <a:ext uri="{FF2B5EF4-FFF2-40B4-BE49-F238E27FC236}">
-                <a16:creationId xmlns:a16="http://schemas.microsoft.com/office/drawing/2014/main" id="{26967EA8-2999-4FD0-BBD8-85BD7D8BBE2E}"/>
+                <a16:creationId xmlns:a16="http://schemas.microsoft.com/office/drawing/2014/main" id="{DB1CA6F6-A67C-4156-BACD-50FF21FA40F3}"/>
               </a:ext>
             </a:extLst>
           </p:cNvPr>
@@ -18392,7 +18392,7 @@
           <p:cNvPr id="23" name="">
             <a:extLst xmlns:a="http://schemas.openxmlformats.org/drawingml/2006/main">
               <a:ext uri="{FF2B5EF4-FFF2-40B4-BE49-F238E27FC236}">
-                <a16:creationId xmlns:a16="http://schemas.microsoft.com/office/drawing/2014/main" id="{D2F4A848-E83E-4E07-85A5-3E91650D5C79}"/>
+                <a16:creationId xmlns:a16="http://schemas.microsoft.com/office/drawing/2014/main" id="{08094480-97FC-40AD-8597-BAB1E8BB882F}"/>
               </a:ext>
             </a:extLst>
           </p:cNvPr>
@@ -18475,7 +18475,7 @@
           <p:cNvPr id="25" name="">
             <a:extLst xmlns:a="http://schemas.openxmlformats.org/drawingml/2006/main">
               <a:ext uri="{FF2B5EF4-FFF2-40B4-BE49-F238E27FC236}">
-                <a16:creationId xmlns:a16="http://schemas.microsoft.com/office/drawing/2014/main" id="{6D3D84E1-31D1-454B-A3DF-3294562F78E2}"/>
+                <a16:creationId xmlns:a16="http://schemas.microsoft.com/office/drawing/2014/main" id="{E36AFEDA-B8A5-4E11-9EC6-59947C678952}"/>
               </a:ext>
             </a:extLst>
           </p:cNvPr>
@@ -18509,7 +18509,7 @@
           <p:cNvPr id="26" name="">
             <a:extLst xmlns:a="http://schemas.openxmlformats.org/drawingml/2006/main">
               <a:ext uri="{FF2B5EF4-FFF2-40B4-BE49-F238E27FC236}">
-                <a16:creationId xmlns:a16="http://schemas.microsoft.com/office/drawing/2014/main" id="{7C15A879-5AE4-44AC-919E-912A1B9D09FA}"/>
+                <a16:creationId xmlns:a16="http://schemas.microsoft.com/office/drawing/2014/main" id="{5C772C5F-33FB-46FD-9140-B01E254C186B}"/>
               </a:ext>
             </a:extLst>
           </p:cNvPr>
@@ -18566,7 +18566,7 @@
           <p:cNvPr id="27" name="">
             <a:extLst xmlns:a="http://schemas.openxmlformats.org/drawingml/2006/main">
               <a:ext uri="{FF2B5EF4-FFF2-40B4-BE49-F238E27FC236}">
-                <a16:creationId xmlns:a16="http://schemas.microsoft.com/office/drawing/2014/main" id="{51970AFB-7CC3-4E1F-A62E-48D27E1D1648}"/>
+                <a16:creationId xmlns:a16="http://schemas.microsoft.com/office/drawing/2014/main" id="{E4A02CF8-5107-466A-AD25-B3215C3CB5AE}"/>
               </a:ext>
             </a:extLst>
           </p:cNvPr>
@@ -18623,7 +18623,7 @@
           <p:cNvPr id="28" name="">
             <a:extLst xmlns:a="http://schemas.openxmlformats.org/drawingml/2006/main">
               <a:ext uri="{FF2B5EF4-FFF2-40B4-BE49-F238E27FC236}">
-                <a16:creationId xmlns:a16="http://schemas.microsoft.com/office/drawing/2014/main" id="{D63DC469-EB56-4A5A-B7B7-1F1C11EAF045}"/>
+                <a16:creationId xmlns:a16="http://schemas.microsoft.com/office/drawing/2014/main" id="{9ECE84AD-1E2A-4EA9-BFF3-0D65037661CA}"/>
               </a:ext>
             </a:extLst>
           </p:cNvPr>
@@ -18706,7 +18706,7 @@
           <p:cNvPr id="30" name="">
             <a:extLst xmlns:a="http://schemas.openxmlformats.org/drawingml/2006/main">
               <a:ext uri="{FF2B5EF4-FFF2-40B4-BE49-F238E27FC236}">
-                <a16:creationId xmlns:a16="http://schemas.microsoft.com/office/drawing/2014/main" id="{7A195594-25F4-43B9-BB16-4CC1530C04A6}"/>
+                <a16:creationId xmlns:a16="http://schemas.microsoft.com/office/drawing/2014/main" id="{475FE17F-D0B3-4691-8210-D51C6276F019}"/>
               </a:ext>
             </a:extLst>
           </p:cNvPr>
@@ -18761,7 +18761,7 @@
     </p:spTree>
     <p:extLst>
       <p:ext uri="{BB962C8B-B14F-4D97-AF65-F5344CB8AC3E}">
-        <p14:creationId xmlns:p14="http://schemas.microsoft.com/office/powerpoint/2010/main" val="351504119"/>
+        <p14:creationId xmlns:p14="http://schemas.microsoft.com/office/powerpoint/2010/main" val="569005988"/>
       </p:ext>
     </p:extLst>
   </p:cSld>
@@ -18792,7 +18792,7 @@
           <p:cNvPr id="29" name="">
             <a:extLst xmlns:a="http://schemas.openxmlformats.org/drawingml/2006/main">
               <a:ext uri="{FF2B5EF4-FFF2-40B4-BE49-F238E27FC236}">
-                <a16:creationId xmlns:a16="http://schemas.microsoft.com/office/drawing/2014/main" id="{CE961728-9553-4B2D-9865-F9D4B8C2EF22}"/>
+                <a16:creationId xmlns:a16="http://schemas.microsoft.com/office/drawing/2014/main" id="{CF1564B7-46B3-4F4C-971D-3744E1008C74}"/>
               </a:ext>
             </a:extLst>
           </p:cNvPr>
@@ -18849,7 +18849,7 @@
           <p:cNvPr id="2" name="">
             <a:extLst xmlns:a="http://schemas.openxmlformats.org/drawingml/2006/main">
               <a:ext uri="{FF2B5EF4-FFF2-40B4-BE49-F238E27FC236}">
-                <a16:creationId xmlns:a16="http://schemas.microsoft.com/office/drawing/2014/main" id="{240F5A78-CAB2-49D1-8C2D-9DB9B949C928}"/>
+                <a16:creationId xmlns:a16="http://schemas.microsoft.com/office/drawing/2014/main" id="{6F4041D7-3AAE-4262-801B-4EC0423D938E}"/>
               </a:ext>
             </a:extLst>
           </p:cNvPr>
@@ -18906,7 +18906,7 @@
           <p:cNvPr id="3" name="">
             <a:extLst xmlns:a="http://schemas.openxmlformats.org/drawingml/2006/main">
               <a:ext uri="{FF2B5EF4-FFF2-40B4-BE49-F238E27FC236}">
-                <a16:creationId xmlns:a16="http://schemas.microsoft.com/office/drawing/2014/main" id="{F9CB4EEF-ED68-4934-9903-A803D64BF1F9}"/>
+                <a16:creationId xmlns:a16="http://schemas.microsoft.com/office/drawing/2014/main" id="{0CC1B626-84BE-4A4E-BD0B-357480402A5A}"/>
               </a:ext>
             </a:extLst>
           </p:cNvPr>
@@ -18936,7 +18936,7 @@
           <p:cNvPr id="4" name="">
             <a:extLst xmlns:a="http://schemas.openxmlformats.org/drawingml/2006/main">
               <a:ext uri="{FF2B5EF4-FFF2-40B4-BE49-F238E27FC236}">
-                <a16:creationId xmlns:a16="http://schemas.microsoft.com/office/drawing/2014/main" id="{C0035D79-F439-444A-9800-5D469172BDC3}"/>
+                <a16:creationId xmlns:a16="http://schemas.microsoft.com/office/drawing/2014/main" id="{59456540-BEF4-4BFB-9663-920DC958DC90}"/>
               </a:ext>
             </a:extLst>
           </p:cNvPr>
@@ -18993,7 +18993,7 @@
           <p:cNvPr id="5" name="">
             <a:extLst xmlns:a="http://schemas.openxmlformats.org/drawingml/2006/main">
               <a:ext uri="{FF2B5EF4-FFF2-40B4-BE49-F238E27FC236}">
-                <a16:creationId xmlns:a16="http://schemas.microsoft.com/office/drawing/2014/main" id="{FE314B31-842F-455B-9FDC-4C021584D95A}"/>
+                <a16:creationId xmlns:a16="http://schemas.microsoft.com/office/drawing/2014/main" id="{B14B663B-B4BD-4199-83B6-C1C824DA2D3B}"/>
               </a:ext>
             </a:extLst>
           </p:cNvPr>
@@ -19027,7 +19027,7 @@
           <p:cNvPr id="6" name="">
             <a:extLst xmlns:a="http://schemas.openxmlformats.org/drawingml/2006/main">
               <a:ext uri="{FF2B5EF4-FFF2-40B4-BE49-F238E27FC236}">
-                <a16:creationId xmlns:a16="http://schemas.microsoft.com/office/drawing/2014/main" id="{96B61F6B-AFE1-4221-B4A3-95EB70394B76}"/>
+                <a16:creationId xmlns:a16="http://schemas.microsoft.com/office/drawing/2014/main" id="{5D42934E-F49D-4CC4-BE26-B29DF42E04FE}"/>
               </a:ext>
             </a:extLst>
           </p:cNvPr>
@@ -19084,7 +19084,7 @@
           <p:cNvPr id="7" name="">
             <a:extLst xmlns:a="http://schemas.openxmlformats.org/drawingml/2006/main">
               <a:ext uri="{FF2B5EF4-FFF2-40B4-BE49-F238E27FC236}">
-                <a16:creationId xmlns:a16="http://schemas.microsoft.com/office/drawing/2014/main" id="{CCE5199D-367E-473E-B18A-32F7F6170B1A}"/>
+                <a16:creationId xmlns:a16="http://schemas.microsoft.com/office/drawing/2014/main" id="{1AA3DF87-5D3C-4DB8-8A92-0863EB162032}"/>
               </a:ext>
             </a:extLst>
           </p:cNvPr>
@@ -19141,7 +19141,7 @@
           <p:cNvPr id="8" name="">
             <a:extLst xmlns:a="http://schemas.openxmlformats.org/drawingml/2006/main">
               <a:ext uri="{FF2B5EF4-FFF2-40B4-BE49-F238E27FC236}">
-                <a16:creationId xmlns:a16="http://schemas.microsoft.com/office/drawing/2014/main" id="{EF4AF608-C7FA-49B7-A56E-F7D8EF89A734}"/>
+                <a16:creationId xmlns:a16="http://schemas.microsoft.com/office/drawing/2014/main" id="{396C1C35-67B5-4FD0-9203-ABD3A35E0BC0}"/>
               </a:ext>
             </a:extLst>
           </p:cNvPr>
@@ -19175,7 +19175,7 @@
           <p:cNvPr id="9" name="">
             <a:extLst xmlns:a="http://schemas.openxmlformats.org/drawingml/2006/main">
               <a:ext uri="{FF2B5EF4-FFF2-40B4-BE49-F238E27FC236}">
-                <a16:creationId xmlns:a16="http://schemas.microsoft.com/office/drawing/2014/main" id="{8FB163D8-AFC8-4D2D-84C2-4C35A131604D}"/>
+                <a16:creationId xmlns:a16="http://schemas.microsoft.com/office/drawing/2014/main" id="{D6313CF1-B45E-4FBA-A84A-573A854834E2}"/>
               </a:ext>
             </a:extLst>
           </p:cNvPr>
@@ -19232,7 +19232,7 @@
           <p:cNvPr id="10" name="">
             <a:extLst xmlns:a="http://schemas.openxmlformats.org/drawingml/2006/main">
               <a:ext uri="{FF2B5EF4-FFF2-40B4-BE49-F238E27FC236}">
-                <a16:creationId xmlns:a16="http://schemas.microsoft.com/office/drawing/2014/main" id="{91F94E09-5D8E-4545-9187-EFBD154ECFD5}"/>
+                <a16:creationId xmlns:a16="http://schemas.microsoft.com/office/drawing/2014/main" id="{62007481-8AF8-4C28-AD6D-FD66521A0B45}"/>
               </a:ext>
             </a:extLst>
           </p:cNvPr>
@@ -19289,7 +19289,7 @@
           <p:cNvPr id="11" name="">
             <a:extLst xmlns:a="http://schemas.openxmlformats.org/drawingml/2006/main">
               <a:ext uri="{FF2B5EF4-FFF2-40B4-BE49-F238E27FC236}">
-                <a16:creationId xmlns:a16="http://schemas.microsoft.com/office/drawing/2014/main" id="{CC7A8603-0B8E-4A6B-89F7-FCBC734B9831}"/>
+                <a16:creationId xmlns:a16="http://schemas.microsoft.com/office/drawing/2014/main" id="{3388867A-9AAD-4417-A31B-26F1DD9B89C6}"/>
               </a:ext>
             </a:extLst>
           </p:cNvPr>
@@ -19323,7 +19323,7 @@
           <p:cNvPr id="12" name="">
             <a:extLst xmlns:a="http://schemas.openxmlformats.org/drawingml/2006/main">
               <a:ext uri="{FF2B5EF4-FFF2-40B4-BE49-F238E27FC236}">
-                <a16:creationId xmlns:a16="http://schemas.microsoft.com/office/drawing/2014/main" id="{B37C0EFB-80A2-4814-99D4-838492EEEA8B}"/>
+                <a16:creationId xmlns:a16="http://schemas.microsoft.com/office/drawing/2014/main" id="{50A25377-AAA0-410A-873D-EA9765F31227}"/>
               </a:ext>
             </a:extLst>
           </p:cNvPr>
@@ -19380,7 +19380,7 @@
           <p:cNvPr id="13" name="">
             <a:extLst xmlns:a="http://schemas.openxmlformats.org/drawingml/2006/main">
               <a:ext uri="{FF2B5EF4-FFF2-40B4-BE49-F238E27FC236}">
-                <a16:creationId xmlns:a16="http://schemas.microsoft.com/office/drawing/2014/main" id="{7EA2BAD4-8E9A-4D9E-9CB4-B501814C090A}"/>
+                <a16:creationId xmlns:a16="http://schemas.microsoft.com/office/drawing/2014/main" id="{A563D00D-C6A8-47ED-983A-E686D4D6F155}"/>
               </a:ext>
             </a:extLst>
           </p:cNvPr>
@@ -19437,7 +19437,7 @@
           <p:cNvPr id="14" name="">
             <a:extLst xmlns:a="http://schemas.openxmlformats.org/drawingml/2006/main">
               <a:ext uri="{FF2B5EF4-FFF2-40B4-BE49-F238E27FC236}">
-                <a16:creationId xmlns:a16="http://schemas.microsoft.com/office/drawing/2014/main" id="{32D0E99E-D95F-45B8-9C96-44F44E2EB8ED}"/>
+                <a16:creationId xmlns:a16="http://schemas.microsoft.com/office/drawing/2014/main" id="{2A953DE4-8C75-4040-AADE-FF9B9D3C41F5}"/>
               </a:ext>
             </a:extLst>
           </p:cNvPr>
@@ -19471,7 +19471,7 @@
           <p:cNvPr id="15" name="">
             <a:extLst xmlns:a="http://schemas.openxmlformats.org/drawingml/2006/main">
               <a:ext uri="{FF2B5EF4-FFF2-40B4-BE49-F238E27FC236}">
-                <a16:creationId xmlns:a16="http://schemas.microsoft.com/office/drawing/2014/main" id="{95BF78FA-9E5D-4DB3-96F0-85C8B49FF9AA}"/>
+                <a16:creationId xmlns:a16="http://schemas.microsoft.com/office/drawing/2014/main" id="{8C58907C-9BEF-4D83-A6F6-12B6C040D0DA}"/>
               </a:ext>
             </a:extLst>
           </p:cNvPr>
@@ -19528,7 +19528,7 @@
           <p:cNvPr id="16" name="">
             <a:extLst xmlns:a="http://schemas.openxmlformats.org/drawingml/2006/main">
               <a:ext uri="{FF2B5EF4-FFF2-40B4-BE49-F238E27FC236}">
-                <a16:creationId xmlns:a16="http://schemas.microsoft.com/office/drawing/2014/main" id="{C4493D20-00E2-4293-8FA4-22743A7405AB}"/>
+                <a16:creationId xmlns:a16="http://schemas.microsoft.com/office/drawing/2014/main" id="{2D07C664-E78F-4B2A-B797-3B671F9272C7}"/>
               </a:ext>
             </a:extLst>
           </p:cNvPr>
@@ -19660,7 +19660,7 @@
           <p:cNvPr id="20" name="">
             <a:extLst xmlns:a="http://schemas.openxmlformats.org/drawingml/2006/main">
               <a:ext uri="{FF2B5EF4-FFF2-40B4-BE49-F238E27FC236}">
-                <a16:creationId xmlns:a16="http://schemas.microsoft.com/office/drawing/2014/main" id="{DFC31BC7-9FE0-46E0-8B92-E3EE46FE17C1}"/>
+                <a16:creationId xmlns:a16="http://schemas.microsoft.com/office/drawing/2014/main" id="{C88CC80F-0C34-4D4C-95B8-0635D33ABAD7}"/>
               </a:ext>
             </a:extLst>
           </p:cNvPr>
@@ -19694,7 +19694,7 @@
           <p:cNvPr id="21" name="">
             <a:extLst xmlns:a="http://schemas.openxmlformats.org/drawingml/2006/main">
               <a:ext uri="{FF2B5EF4-FFF2-40B4-BE49-F238E27FC236}">
-                <a16:creationId xmlns:a16="http://schemas.microsoft.com/office/drawing/2014/main" id="{7E5C7348-A9D9-4E51-9D41-0737E6601423}"/>
+                <a16:creationId xmlns:a16="http://schemas.microsoft.com/office/drawing/2014/main" id="{B6DAED9C-DA9E-45FD-BCE4-AA1C07195204}"/>
               </a:ext>
             </a:extLst>
           </p:cNvPr>
@@ -19728,7 +19728,7 @@
           <p:cNvPr id="22" name="">
             <a:extLst xmlns:a="http://schemas.openxmlformats.org/drawingml/2006/main">
               <a:ext uri="{FF2B5EF4-FFF2-40B4-BE49-F238E27FC236}">
-                <a16:creationId xmlns:a16="http://schemas.microsoft.com/office/drawing/2014/main" id="{82EE7BEF-CB32-431F-ACA7-47821A5A7E4C}"/>
+                <a16:creationId xmlns:a16="http://schemas.microsoft.com/office/drawing/2014/main" id="{E96A77C4-9D51-49C7-92F1-DC4996F670B7}"/>
               </a:ext>
             </a:extLst>
           </p:cNvPr>
@@ -19785,7 +19785,7 @@
           <p:cNvPr id="23" name="">
             <a:extLst xmlns:a="http://schemas.openxmlformats.org/drawingml/2006/main">
               <a:ext uri="{FF2B5EF4-FFF2-40B4-BE49-F238E27FC236}">
-                <a16:creationId xmlns:a16="http://schemas.microsoft.com/office/drawing/2014/main" id="{CC9AC6A7-F3F6-4293-8BAA-4A77AD95BD41}"/>
+                <a16:creationId xmlns:a16="http://schemas.microsoft.com/office/drawing/2014/main" id="{11F8A60C-CBE9-4CD2-9250-4502994D3B43}"/>
               </a:ext>
             </a:extLst>
           </p:cNvPr>
@@ -19842,7 +19842,7 @@
           <p:cNvPr id="24" name="">
             <a:extLst xmlns:a="http://schemas.openxmlformats.org/drawingml/2006/main">
               <a:ext uri="{FF2B5EF4-FFF2-40B4-BE49-F238E27FC236}">
-                <a16:creationId xmlns:a16="http://schemas.microsoft.com/office/drawing/2014/main" id="{F57BA765-515A-42DF-ABA6-9A5F69F73A22}"/>
+                <a16:creationId xmlns:a16="http://schemas.microsoft.com/office/drawing/2014/main" id="{1BA1AB6C-9CDD-4681-B275-9C885BF22C1E}"/>
               </a:ext>
             </a:extLst>
           </p:cNvPr>
@@ -19876,7 +19876,7 @@
           <p:cNvPr id="25" name="">
             <a:extLst xmlns:a="http://schemas.openxmlformats.org/drawingml/2006/main">
               <a:ext uri="{FF2B5EF4-FFF2-40B4-BE49-F238E27FC236}">
-                <a16:creationId xmlns:a16="http://schemas.microsoft.com/office/drawing/2014/main" id="{9F3EFDA3-F63F-4CDA-85D6-3BBC17A46D43}"/>
+                <a16:creationId xmlns:a16="http://schemas.microsoft.com/office/drawing/2014/main" id="{227978D8-C909-44ED-A70A-CCAB80AF4415}"/>
               </a:ext>
             </a:extLst>
           </p:cNvPr>
@@ -19910,7 +19910,7 @@
           <p:cNvPr id="26" name="">
             <a:extLst xmlns:a="http://schemas.openxmlformats.org/drawingml/2006/main">
               <a:ext uri="{FF2B5EF4-FFF2-40B4-BE49-F238E27FC236}">
-                <a16:creationId xmlns:a16="http://schemas.microsoft.com/office/drawing/2014/main" id="{699A5513-7F0A-4C07-A2B5-6A24F76C8B8F}"/>
+                <a16:creationId xmlns:a16="http://schemas.microsoft.com/office/drawing/2014/main" id="{FE230774-6EA8-4342-9B6E-44876968FDB1}"/>
               </a:ext>
             </a:extLst>
           </p:cNvPr>
@@ -19967,7 +19967,7 @@
           <p:cNvPr id="27" name="">
             <a:extLst xmlns:a="http://schemas.openxmlformats.org/drawingml/2006/main">
               <a:ext uri="{FF2B5EF4-FFF2-40B4-BE49-F238E27FC236}">
-                <a16:creationId xmlns:a16="http://schemas.microsoft.com/office/drawing/2014/main" id="{64DE9CB8-6FF3-48C4-93AE-76367E406F1B}"/>
+                <a16:creationId xmlns:a16="http://schemas.microsoft.com/office/drawing/2014/main" id="{37A6E18C-09D9-41F2-A2A2-8917B07E0ADC}"/>
               </a:ext>
             </a:extLst>
           </p:cNvPr>
@@ -20024,7 +20024,7 @@
           <p:cNvPr id="28" name="">
             <a:extLst xmlns:a="http://schemas.openxmlformats.org/drawingml/2006/main">
               <a:ext uri="{FF2B5EF4-FFF2-40B4-BE49-F238E27FC236}">
-                <a16:creationId xmlns:a16="http://schemas.microsoft.com/office/drawing/2014/main" id="{3F78A898-F298-444A-ADE7-2FD012F288DD}"/>
+                <a16:creationId xmlns:a16="http://schemas.microsoft.com/office/drawing/2014/main" id="{94337062-541D-4495-939D-6744498CF790}"/>
               </a:ext>
             </a:extLst>
           </p:cNvPr>
@@ -20079,7 +20079,7 @@
     </p:spTree>
     <p:extLst>
       <p:ext uri="{BB962C8B-B14F-4D97-AF65-F5344CB8AC3E}">
-        <p14:creationId xmlns:p14="http://schemas.microsoft.com/office/powerpoint/2010/main" val="394641553"/>
+        <p14:creationId xmlns:p14="http://schemas.microsoft.com/office/powerpoint/2010/main" val="1567509446"/>
       </p:ext>
     </p:extLst>
   </p:cSld>

</xml_diff>

<commit_message>
docs: align final submission with official evaluation window
</commit_message>
<xml_diff>
--- a/docs/submission/FinProof_Technical_Proposal.pptx
+++ b/docs/submission/FinProof_Technical_Proposal.pptx
@@ -877,6 +877,11 @@
           <a:p xmlns:a="http://schemas.openxmlformats.org/drawingml/2006/main">
             <a:r>
               <a:t>근거: README.md; docs/submission/API_SCHEMA.md; docs/submission/SUBMISSION_CHECKLIST.md; docs/submission/PROPOSAL_EVIDENCE_INDEX.md; artifacts/evaluation/ablation-organizer-20260824.json; source_material/competition_task_financial_product_agent.pdf 7쪽</a:t>
+            </a:r>
+          </a:p>
+          <a:p xmlns:a="http://schemas.openxmlformats.org/drawingml/2006/main">
+            <a:r>
+              <a:t>운영기간 및 정확한 마감: source_material/official_notices/2026-09-06-evaluation-window-and-healthcheck.md (이전 PDF의 운영기간을 대체한 최신 주최측 공지, D-042).</a:t>
             </a:r>
           </a:p>
         </p:txBody>
@@ -7791,7 +7796,7 @@
                 <a:ea typeface="Apple SD Gothic Neo"/>
                 <a:cs typeface="Apple SD Gothic Neo"/>
               </a:rPr>
-              <a:t>평가 기간 09.07-09.20 운영</a:t>
+              <a:t>운영 09.07 10:00 - 09.11 15:00 (KST)</a:t>
             </a:r>
           </a:p>
         </p:txBody>

</xml_diff>